<commit_message>
docs: clarify DP45 cross-activity context rationale
Replace the main example with VIA-delivered evaluation criteria and two confirmed task result references used in a new proposal request. Preserve the A/B contracts and distinguish VIA evidence linking from downstream task analysis. Synchronize editable diagrams, previews and only the selected slides and notes in three decks.
</commit_message>
<xml_diff>
--- a/docs/presentations_files/dp-background/VIA-DP-background-41-45.pptx
+++ b/docs/presentations_files/dp-background/VIA-DP-background-41-45.pptx
@@ -802,6 +802,16 @@
           <a:p xmlns:a="http://schemas.openxmlformats.org/drawingml/2006/main">
             <a:r>
               <a:t>공통 문제와 설계 고려 사항의 배경이며 특정 설계안의 선택을 뜻하지 않는다.</a:t>
+            </a:r>
+          </a:p>
+          <a:p xmlns:a="http://schemas.openxmlformats.org/drawingml/2006/main">
+            <a:r>
+              <a:t>공통 사례: C20/E20 VIA 직접 평가 기준 설명과 실제 전달 P20, C21/T21/D21@v2 제품 비교, C22/T22/D22@v1 견적. 현재 C23/R23의 제안서 작성 Task T23 연결은 현재 해석/채택의 결과다. VIA는 허용된 발췌와 참조를 연결하고, 평가 기준 적용과 제안서 작성은 Downstream Agent가 수행한다. 결과 참조는 본문 전체 보관을 뜻하지 않으며 Agent 내부 reasoning/모든 tool 기록은 전제하지 않는다.</a:t>
+            </a:r>
+          </a:p>
+          <a:p xmlns:a="http://schemas.openxmlformats.org/drawingml/2006/main">
+            <a:r>
+              <a:t>A의 요약/index/cache/관계 cache/부분 갱신/병렬 조회와 기존 Agent 실행 맥락 재사용을 허용한다. B의 과거 관계는 검증/게시 범위만 읽고 원본 확인, 미게시/표현 미지원, 오류/갱신/삭제와 생산 비용을 유지한다. R23의 정답 관계를 미리 게시하지 않는다. 필요성과 사례 보완이며 최종 DP/A/B 선정 또는 새 사례의 품질 검증이 아니다. 기존 수치와 점수는 동일한 형식 예시다.</a:t>
             </a:r>
           </a:p>
         </p:txBody>
@@ -14902,10 +14912,10 @@
       </p:grpSpPr>
       <p:sp>
         <p:nvSpPr>
-          <p:cNvPr id="56" name="dp45-background / n1">
-            <a:extLst xmlns:a="http://schemas.openxmlformats.org/drawingml/2006/main">
-              <a:ext uri="{FF2B5EF4-FFF2-40B4-BE49-F238E27FC236}">
-                <a16:creationId xmlns:a16="http://schemas.microsoft.com/office/drawing/2014/main" id="{C0CAEA11-ABAD-4F81-BD9E-2090639B2EC8}"/>
+          <p:cNvPr id="64" name="dp45-background / n1">
+            <a:extLst xmlns:a="http://schemas.openxmlformats.org/drawingml/2006/main">
+              <a:ext uri="{FF2B5EF4-FFF2-40B4-BE49-F238E27FC236}">
+                <a16:creationId xmlns:a16="http://schemas.microsoft.com/office/drawing/2014/main" id="{89C71B4D-BE14-43DE-BC25-211033E3EE4F}"/>
               </a:ext>
             </a:extLst>
           </p:cNvPr>
@@ -14936,7 +14946,7 @@
           <p:cNvPr id="2" name="dp45-background / n2 / text 1">
             <a:extLst xmlns:a="http://schemas.openxmlformats.org/drawingml/2006/main">
               <a:ext uri="{FF2B5EF4-FFF2-40B4-BE49-F238E27FC236}">
-                <a16:creationId xmlns:a16="http://schemas.microsoft.com/office/drawing/2014/main" id="{BB859E07-101F-4D4D-979A-E99AFFB647E7}"/>
+                <a16:creationId xmlns:a16="http://schemas.microsoft.com/office/drawing/2014/main" id="{A3F4AF19-9726-4227-927D-1736F80F2353}"/>
               </a:ext>
             </a:extLst>
           </p:cNvPr>
@@ -14994,7 +15004,7 @@
           <p:cNvPr id="3" name="dp45-background / n3 / text 1">
             <a:extLst xmlns:a="http://schemas.openxmlformats.org/drawingml/2006/main">
               <a:ext uri="{FF2B5EF4-FFF2-40B4-BE49-F238E27FC236}">
-                <a16:creationId xmlns:a16="http://schemas.microsoft.com/office/drawing/2014/main" id="{4E1C720E-A656-45F2-B74F-6630E9B1097B}"/>
+                <a16:creationId xmlns:a16="http://schemas.microsoft.com/office/drawing/2014/main" id="{0B7E05FD-F85F-4F6D-A7B2-DCD70C01EBF2}"/>
               </a:ext>
             </a:extLst>
           </p:cNvPr>
@@ -15052,7 +15062,7 @@
           <p:cNvPr id="4" name="dp45-background / n4 / text 1">
             <a:extLst xmlns:a="http://schemas.openxmlformats.org/drawingml/2006/main">
               <a:ext uri="{FF2B5EF4-FFF2-40B4-BE49-F238E27FC236}">
-                <a16:creationId xmlns:a16="http://schemas.microsoft.com/office/drawing/2014/main" id="{6A400340-7A3F-4EC7-9A74-514A45F39F96}"/>
+                <a16:creationId xmlns:a16="http://schemas.microsoft.com/office/drawing/2014/main" id="{78688CA1-4004-4166-8D1D-5FE65E8173F0}"/>
               </a:ext>
             </a:extLst>
           </p:cNvPr>
@@ -15110,7 +15120,7 @@
           <p:cNvPr id="5" name="dp45-background / n5 / path">
             <a:extLst xmlns:a="http://schemas.openxmlformats.org/drawingml/2006/main">
               <a:ext uri="{FF2B5EF4-FFF2-40B4-BE49-F238E27FC236}">
-                <a16:creationId xmlns:a16="http://schemas.microsoft.com/office/drawing/2014/main" id="{E6405395-3192-4B5F-87EA-9FEC12D2E267}"/>
+                <a16:creationId xmlns:a16="http://schemas.microsoft.com/office/drawing/2014/main" id="{71BAD2B5-18A0-4B91-BBF9-061BEA93EC7A}"/>
               </a:ext>
             </a:extLst>
           </p:cNvPr>
@@ -15150,7 +15160,7 @@
           <p:cNvPr id="6" name="dp45-background / n6">
             <a:extLst xmlns:a="http://schemas.openxmlformats.org/drawingml/2006/main">
               <a:ext uri="{FF2B5EF4-FFF2-40B4-BE49-F238E27FC236}">
-                <a16:creationId xmlns:a16="http://schemas.microsoft.com/office/drawing/2014/main" id="{B14C4145-030A-4143-9658-5FB3F84D8A25}"/>
+                <a16:creationId xmlns:a16="http://schemas.microsoft.com/office/drawing/2014/main" id="{338EA1BF-B468-40E1-A64E-CE19B629E91B}"/>
               </a:ext>
             </a:extLst>
           </p:cNvPr>
@@ -15181,7 +15191,7 @@
           <p:cNvPr id="7" name="dp45-background / n7 / text 1">
             <a:extLst xmlns:a="http://schemas.openxmlformats.org/drawingml/2006/main">
               <a:ext uri="{FF2B5EF4-FFF2-40B4-BE49-F238E27FC236}">
-                <a16:creationId xmlns:a16="http://schemas.microsoft.com/office/drawing/2014/main" id="{1743BCCD-3AAF-4A16-A6FB-4D66C5E0A8D4}"/>
+                <a16:creationId xmlns:a16="http://schemas.microsoft.com/office/drawing/2014/main" id="{9851151C-3168-4BE2-827D-DE6A427CE2AE}"/>
               </a:ext>
             </a:extLst>
           </p:cNvPr>
@@ -15229,7 +15239,7 @@
                 <a:ea typeface="Apple SD Gothic Neo"/>
                 <a:cs typeface="Apple SD Gothic Neo"/>
               </a:rPr>
-              <a:t>과거 정정의 누락과 유효하지 않은 결과 재사용 위험</a:t>
+              <a:t>여러 활동의 과거 근거 누락과 실제 전달 내용의 오연결 위험</a:t>
             </a:r>
           </a:p>
         </p:txBody>
@@ -15239,7 +15249,7 @@
           <p:cNvPr id="8" name="dp45-background / n8 / path">
             <a:extLst xmlns:a="http://schemas.openxmlformats.org/drawingml/2006/main">
               <a:ext uri="{FF2B5EF4-FFF2-40B4-BE49-F238E27FC236}">
-                <a16:creationId xmlns:a16="http://schemas.microsoft.com/office/drawing/2014/main" id="{6AB2FB1A-21FB-40C6-9ABF-939AB768503D}"/>
+                <a16:creationId xmlns:a16="http://schemas.microsoft.com/office/drawing/2014/main" id="{A7C2C7D3-4D44-4EA7-9DE8-00883E8A36CE}"/>
               </a:ext>
             </a:extLst>
           </p:cNvPr>
@@ -15279,7 +15289,7 @@
           <p:cNvPr id="9" name="dp45-background / n9 / text 1">
             <a:extLst xmlns:a="http://schemas.openxmlformats.org/drawingml/2006/main">
               <a:ext uri="{FF2B5EF4-FFF2-40B4-BE49-F238E27FC236}">
-                <a16:creationId xmlns:a16="http://schemas.microsoft.com/office/drawing/2014/main" id="{C5C7179E-2FD6-4AF4-83DA-64796F367C08}"/>
+                <a16:creationId xmlns:a16="http://schemas.microsoft.com/office/drawing/2014/main" id="{11FC0446-EB39-4B8E-892A-7FA55516EC62}"/>
               </a:ext>
             </a:extLst>
           </p:cNvPr>
@@ -15337,7 +15347,7 @@
           <p:cNvPr id="10" name="dp45-background / n10 / path">
             <a:extLst xmlns:a="http://schemas.openxmlformats.org/drawingml/2006/main">
               <a:ext uri="{FF2B5EF4-FFF2-40B4-BE49-F238E27FC236}">
-                <a16:creationId xmlns:a16="http://schemas.microsoft.com/office/drawing/2014/main" id="{E7409C24-CA6B-4C15-B757-03865E71C94A}"/>
+                <a16:creationId xmlns:a16="http://schemas.microsoft.com/office/drawing/2014/main" id="{B834E4E2-6845-4D4E-B91C-0B6B81977CC9}"/>
               </a:ext>
             </a:extLst>
           </p:cNvPr>
@@ -15377,7 +15387,7 @@
           <p:cNvPr id="11" name="dp45-background / n11 / text 1">
             <a:extLst xmlns:a="http://schemas.openxmlformats.org/drawingml/2006/main">
               <a:ext uri="{FF2B5EF4-FFF2-40B4-BE49-F238E27FC236}">
-                <a16:creationId xmlns:a16="http://schemas.microsoft.com/office/drawing/2014/main" id="{92BF3A9C-925F-4070-B765-E178CC93222C}"/>
+                <a16:creationId xmlns:a16="http://schemas.microsoft.com/office/drawing/2014/main" id="{6E9451A2-9EA1-4DD0-8CCB-7DA119D10410}"/>
               </a:ext>
             </a:extLst>
           </p:cNvPr>
@@ -15435,7 +15445,7 @@
           <p:cNvPr id="12" name="dp45-background / n12 / text 1">
             <a:extLst xmlns:a="http://schemas.openxmlformats.org/drawingml/2006/main">
               <a:ext uri="{FF2B5EF4-FFF2-40B4-BE49-F238E27FC236}">
-                <a16:creationId xmlns:a16="http://schemas.microsoft.com/office/drawing/2014/main" id="{03178188-7248-4E78-AE8A-FC987CFD6385}"/>
+                <a16:creationId xmlns:a16="http://schemas.microsoft.com/office/drawing/2014/main" id="{6D5A3BF5-E23E-4EA7-837F-1FCD850B46D7}"/>
               </a:ext>
             </a:extLst>
           </p:cNvPr>
@@ -15483,7 +15493,7 @@
                 <a:ea typeface="Apple SD Gothic Neo"/>
                 <a:cs typeface="Apple SD Gothic Neo"/>
               </a:rPr>
-              <a:t>과거 기록을 연결한 Context의 생산, 조회와 갱신 책임 설계</a:t>
+              <a:t>과거 근거를 연결하는 Context의 생산, 조회와 갱신 책임 설계</a:t>
             </a:r>
           </a:p>
         </p:txBody>
@@ -15493,7 +15503,7 @@
           <p:cNvPr id="13" name="dp45-background / n13 / text 1">
             <a:extLst xmlns:a="http://schemas.openxmlformats.org/drawingml/2006/main">
               <a:ext uri="{FF2B5EF4-FFF2-40B4-BE49-F238E27FC236}">
-                <a16:creationId xmlns:a16="http://schemas.microsoft.com/office/drawing/2014/main" id="{ED5056EB-69BA-45D0-AED2-094EA0C1D3D5}"/>
+                <a16:creationId xmlns:a16="http://schemas.microsoft.com/office/drawing/2014/main" id="{DA780286-2269-4EFE-821F-F9856893E83C}"/>
               </a:ext>
             </a:extLst>
           </p:cNvPr>
@@ -15541,7 +15551,7 @@
                 <a:ea typeface="Apple SD Gothic Neo"/>
                 <a:cs typeface="Apple SD Gothic Neo"/>
               </a:rPr>
-              <a:t>과거 정보 참조 / 장기 User Memory 등록은 별도 사용자 지시</a:t>
+              <a:t>VIA는 허용 근거를 연결 / 업무 판단과 제안서 작성은 Downstream Agent</a:t>
             </a:r>
           </a:p>
         </p:txBody>
@@ -15551,7 +15561,7 @@
           <p:cNvPr id="14" name="dp45-background / n14 / text 1">
             <a:extLst xmlns:a="http://schemas.openxmlformats.org/drawingml/2006/main">
               <a:ext uri="{FF2B5EF4-FFF2-40B4-BE49-F238E27FC236}">
-                <a16:creationId xmlns:a16="http://schemas.microsoft.com/office/drawing/2014/main" id="{4E7821D7-54D7-47B8-8687-605C94FA3CD8}"/>
+                <a16:creationId xmlns:a16="http://schemas.microsoft.com/office/drawing/2014/main" id="{ADF355A0-3DA7-4A92-88D6-314366108926}"/>
               </a:ext>
             </a:extLst>
           </p:cNvPr>
@@ -15609,7 +15619,7 @@
           <p:cNvPr id="15" name="dp45-background / n15 / text 1">
             <a:extLst xmlns:a="http://schemas.openxmlformats.org/drawingml/2006/main">
               <a:ext uri="{FF2B5EF4-FFF2-40B4-BE49-F238E27FC236}">
-                <a16:creationId xmlns:a16="http://schemas.microsoft.com/office/drawing/2014/main" id="{C4BA0237-C27C-44D4-9A3B-F8DC72C7B442}"/>
+                <a16:creationId xmlns:a16="http://schemas.microsoft.com/office/drawing/2014/main" id="{6DC59712-BD8F-48BA-AED2-10AD78F289CA}"/>
               </a:ext>
             </a:extLst>
           </p:cNvPr>
@@ -15667,7 +15677,7 @@
           <p:cNvPr id="16" name="dp45-background / n16 / text 1">
             <a:extLst xmlns:a="http://schemas.openxmlformats.org/drawingml/2006/main">
               <a:ext uri="{FF2B5EF4-FFF2-40B4-BE49-F238E27FC236}">
-                <a16:creationId xmlns:a16="http://schemas.microsoft.com/office/drawing/2014/main" id="{775CDEBD-1F5F-4182-8F53-10F18027CF6B}"/>
+                <a16:creationId xmlns:a16="http://schemas.microsoft.com/office/drawing/2014/main" id="{69B85323-0963-4712-B340-59653B133471}"/>
               </a:ext>
             </a:extLst>
           </p:cNvPr>
@@ -15679,25 +15689,25 @@
         <p:spPr>
           <a:xfrm xmlns:a="http://schemas.openxmlformats.org/drawingml/2006/main">
             <a:off x="609600" y="2505075"/>
-            <a:ext cx="10572750" cy="345281"/>
-          </a:xfrm>
-          <a:prstGeom xmlns:a="http://schemas.openxmlformats.org/drawingml/2006/main" prst="rect">
-            <a:avLst/>
-          </a:prstGeom>
-          <a:noFill xmlns:a="http://schemas.openxmlformats.org/drawingml/2006/main"/>
-          <a:ln xmlns:a="http://schemas.openxmlformats.org/drawingml/2006/main" w="0">
-            <a:noFill/>
-            <a:prstDash val="solid"/>
-          </a:ln>
-        </p:spPr>
-        <p:txBody>
-          <a:bodyPr xmlns:a="http://schemas.openxmlformats.org/drawingml/2006/main" wrap="none" lIns="0" tIns="0" rIns="0" bIns="0" anchor="t">
-            <a:noAutofit/>
-          </a:bodyPr>
-          <a:lstStyle xmlns:a="http://schemas.openxmlformats.org/drawingml/2006/main"/>
-          <a:p xmlns:a="http://schemas.openxmlformats.org/drawingml/2006/main">
-            <a:pPr algn="l">
-              <a:defRPr sz="1875" b="0">
+            <a:ext cx="10572750" cy="331470"/>
+          </a:xfrm>
+          <a:prstGeom xmlns:a="http://schemas.openxmlformats.org/drawingml/2006/main" prst="rect">
+            <a:avLst/>
+          </a:prstGeom>
+          <a:noFill xmlns:a="http://schemas.openxmlformats.org/drawingml/2006/main"/>
+          <a:ln xmlns:a="http://schemas.openxmlformats.org/drawingml/2006/main" w="0">
+            <a:noFill/>
+            <a:prstDash val="solid"/>
+          </a:ln>
+        </p:spPr>
+        <p:txBody>
+          <a:bodyPr xmlns:a="http://schemas.openxmlformats.org/drawingml/2006/main" wrap="none" lIns="0" tIns="0" rIns="0" bIns="0" anchor="t">
+            <a:noAutofit/>
+          </a:bodyPr>
+          <a:lstStyle xmlns:a="http://schemas.openxmlformats.org/drawingml/2006/main"/>
+          <a:p xmlns:a="http://schemas.openxmlformats.org/drawingml/2006/main">
+            <a:pPr algn="l">
+              <a:defRPr sz="1800" b="0">
                 <a:solidFill>
                   <a:srgbClr val="5F6B77"/>
                 </a:solidFill>
@@ -15707,7 +15717,7 @@
               </a:defRPr>
             </a:pPr>
             <a:r>
-              <a:rPr sz="1875" b="0">
+              <a:rPr sz="1800" b="0">
                 <a:solidFill>
                   <a:srgbClr val="5F6B77"/>
                 </a:solidFill>
@@ -15715,7 +15725,7 @@
                 <a:ea typeface="Apple SD Gothic Neo"/>
                 <a:cs typeface="Apple SD Gothic Neo"/>
               </a:rPr>
-              <a:t>지난번 / 서로 연결해야 할 세 종류의 기록</a:t>
+              <a:t>과거 활동의 시간 흐름 / VIA가 받은 기록과 허용된 참조</a:t>
             </a:r>
           </a:p>
         </p:txBody>
@@ -15725,7 +15735,7 @@
           <p:cNvPr id="17" name="dp45-background / n17">
             <a:extLst xmlns:a="http://schemas.openxmlformats.org/drawingml/2006/main">
               <a:ext uri="{FF2B5EF4-FFF2-40B4-BE49-F238E27FC236}">
-                <a16:creationId xmlns:a16="http://schemas.microsoft.com/office/drawing/2014/main" id="{8A49D3CA-E94A-4562-96B8-398D56083E18}"/>
+                <a16:creationId xmlns:a16="http://schemas.microsoft.com/office/drawing/2014/main" id="{84B91CA0-74B1-4A4D-B874-16D76AB53F4C}"/>
               </a:ext>
             </a:extLst>
           </p:cNvPr>
@@ -15777,7 +15787,7 @@
           <p:cNvPr id="18" name="dp45-background / n17 / fold">
             <a:extLst xmlns:a="http://schemas.openxmlformats.org/drawingml/2006/main">
               <a:ext uri="{FF2B5EF4-FFF2-40B4-BE49-F238E27FC236}">
-                <a16:creationId xmlns:a16="http://schemas.microsoft.com/office/drawing/2014/main" id="{B2BA2D16-9945-400A-BC1F-939D76E868FF}"/>
+                <a16:creationId xmlns:a16="http://schemas.microsoft.com/office/drawing/2014/main" id="{93565D54-C8CE-4F58-9D99-67B3C2FE55DC}"/>
               </a:ext>
             </a:extLst>
           </p:cNvPr>
@@ -15820,7 +15830,7 @@
           <p:cNvPr id="19" name="dp45-background / n18">
             <a:extLst xmlns:a="http://schemas.openxmlformats.org/drawingml/2006/main">
               <a:ext uri="{FF2B5EF4-FFF2-40B4-BE49-F238E27FC236}">
-                <a16:creationId xmlns:a16="http://schemas.microsoft.com/office/drawing/2014/main" id="{B74776DB-DF7A-4E38-A771-FD850BF093C5}"/>
+                <a16:creationId xmlns:a16="http://schemas.microsoft.com/office/drawing/2014/main" id="{79854D84-4941-4057-8838-19751E294BAD}"/>
               </a:ext>
             </a:extLst>
           </p:cNvPr>
@@ -15872,7 +15882,7 @@
           <p:cNvPr id="20" name="dp45-background / n18 / fold">
             <a:extLst xmlns:a="http://schemas.openxmlformats.org/drawingml/2006/main">
               <a:ext uri="{FF2B5EF4-FFF2-40B4-BE49-F238E27FC236}">
-                <a16:creationId xmlns:a16="http://schemas.microsoft.com/office/drawing/2014/main" id="{70A140CC-DE91-4532-88BA-C6643A128BB0}"/>
+                <a16:creationId xmlns:a16="http://schemas.microsoft.com/office/drawing/2014/main" id="{9101B0EB-CD05-4D83-A00D-43C4287CC8DE}"/>
               </a:ext>
             </a:extLst>
           </p:cNvPr>
@@ -15915,7 +15925,7 @@
           <p:cNvPr id="21" name="dp45-background / n19">
             <a:extLst xmlns:a="http://schemas.openxmlformats.org/drawingml/2006/main">
               <a:ext uri="{FF2B5EF4-FFF2-40B4-BE49-F238E27FC236}">
-                <a16:creationId xmlns:a16="http://schemas.microsoft.com/office/drawing/2014/main" id="{D3EFE853-3FEC-463C-9ED1-FED9F3A459CC}"/>
+                <a16:creationId xmlns:a16="http://schemas.microsoft.com/office/drawing/2014/main" id="{B785CA1A-6775-4E98-8D23-5F4C3D6F961F}"/>
               </a:ext>
             </a:extLst>
           </p:cNvPr>
@@ -15967,7 +15977,7 @@
           <p:cNvPr id="22" name="dp45-background / n19 / fold">
             <a:extLst xmlns:a="http://schemas.openxmlformats.org/drawingml/2006/main">
               <a:ext uri="{FF2B5EF4-FFF2-40B4-BE49-F238E27FC236}">
-                <a16:creationId xmlns:a16="http://schemas.microsoft.com/office/drawing/2014/main" id="{9969F66E-7030-4AFA-96F3-E42F15253B27}"/>
+                <a16:creationId xmlns:a16="http://schemas.microsoft.com/office/drawing/2014/main" id="{0B1307A5-1EDB-4D4A-A6A6-C34C0AECD375}"/>
               </a:ext>
             </a:extLst>
           </p:cNvPr>
@@ -16010,7 +16020,7 @@
           <p:cNvPr id="23" name="dp45-background / n20 / text 1">
             <a:extLst xmlns:a="http://schemas.openxmlformats.org/drawingml/2006/main">
               <a:ext uri="{FF2B5EF4-FFF2-40B4-BE49-F238E27FC236}">
-                <a16:creationId xmlns:a16="http://schemas.microsoft.com/office/drawing/2014/main" id="{B649591D-8257-4488-926D-22985F669E88}"/>
+                <a16:creationId xmlns:a16="http://schemas.microsoft.com/office/drawing/2014/main" id="{C2E19B32-9EE5-4AB0-BBD7-F913EE0B7F7A}"/>
               </a:ext>
             </a:extLst>
           </p:cNvPr>
@@ -16022,6 +16032,412 @@
         <p:spPr>
           <a:xfrm xmlns:a="http://schemas.openxmlformats.org/drawingml/2006/main">
             <a:off x="800100" y="3305175"/>
+            <a:ext cx="2952750" cy="331470"/>
+          </a:xfrm>
+          <a:prstGeom xmlns:a="http://schemas.openxmlformats.org/drawingml/2006/main" prst="rect">
+            <a:avLst/>
+          </a:prstGeom>
+          <a:noFill xmlns:a="http://schemas.openxmlformats.org/drawingml/2006/main"/>
+          <a:ln xmlns:a="http://schemas.openxmlformats.org/drawingml/2006/main" w="0">
+            <a:noFill/>
+            <a:prstDash val="solid"/>
+          </a:ln>
+        </p:spPr>
+        <p:txBody>
+          <a:bodyPr xmlns:a="http://schemas.openxmlformats.org/drawingml/2006/main" wrap="none" lIns="0" tIns="0" rIns="0" bIns="0" anchor="t">
+            <a:noAutofit/>
+          </a:bodyPr>
+          <a:lstStyle xmlns:a="http://schemas.openxmlformats.org/drawingml/2006/main"/>
+          <a:p xmlns:a="http://schemas.openxmlformats.org/drawingml/2006/main">
+            <a:pPr algn="l">
+              <a:defRPr sz="1800" b="1">
+                <a:solidFill>
+                  <a:srgbClr val="18232E"/>
+                </a:solidFill>
+                <a:latin typeface="Apple SD Gothic Neo"/>
+                <a:ea typeface="Apple SD Gothic Neo"/>
+                <a:cs typeface="Apple SD Gothic Neo"/>
+              </a:defRPr>
+            </a:pPr>
+            <a:r>
+              <a:rPr sz="1800" b="1">
+                <a:solidFill>
+                  <a:srgbClr val="18232E"/>
+                </a:solidFill>
+                <a:latin typeface="Apple SD Gothic Neo"/>
+                <a:ea typeface="Apple SD Gothic Neo"/>
+                <a:cs typeface="Apple SD Gothic Neo"/>
+              </a:rPr>
+              <a:t>앞선 대화 C20</a:t>
+            </a:r>
+          </a:p>
+        </p:txBody>
+      </p:sp>
+      <p:sp>
+        <p:nvSpPr>
+          <p:cNvPr id="24" name="dp45-background / n21 / text 1">
+            <a:extLst xmlns:a="http://schemas.openxmlformats.org/drawingml/2006/main">
+              <a:ext uri="{FF2B5EF4-FFF2-40B4-BE49-F238E27FC236}">
+                <a16:creationId xmlns:a16="http://schemas.microsoft.com/office/drawing/2014/main" id="{32AC7EE7-B1F7-4FF4-B011-C03865F74A1D}"/>
+              </a:ext>
+            </a:extLst>
+          </p:cNvPr>
+          <p:cNvSpPr>
+            <a:spLocks xmlns:a="http://schemas.openxmlformats.org/drawingml/2006/main" noGrp="1"/>
+          </p:cNvSpPr>
+          <p:nvPr/>
+        </p:nvSpPr>
+        <p:spPr>
+          <a:xfrm xmlns:a="http://schemas.openxmlformats.org/drawingml/2006/main">
+            <a:off x="800100" y="3829050"/>
+            <a:ext cx="2952750" cy="359092"/>
+          </a:xfrm>
+          <a:prstGeom xmlns:a="http://schemas.openxmlformats.org/drawingml/2006/main" prst="rect">
+            <a:avLst/>
+          </a:prstGeom>
+          <a:noFill xmlns:a="http://schemas.openxmlformats.org/drawingml/2006/main"/>
+          <a:ln xmlns:a="http://schemas.openxmlformats.org/drawingml/2006/main" w="0">
+            <a:noFill/>
+            <a:prstDash val="solid"/>
+          </a:ln>
+        </p:spPr>
+        <p:txBody>
+          <a:bodyPr xmlns:a="http://schemas.openxmlformats.org/drawingml/2006/main" wrap="none" lIns="0" tIns="0" rIns="0" bIns="0" anchor="t">
+            <a:noAutofit/>
+          </a:bodyPr>
+          <a:lstStyle xmlns:a="http://schemas.openxmlformats.org/drawingml/2006/main"/>
+          <a:p xmlns:a="http://schemas.openxmlformats.org/drawingml/2006/main">
+            <a:pPr algn="l">
+              <a:defRPr sz="1950" b="1">
+                <a:solidFill>
+                  <a:srgbClr val="18232E"/>
+                </a:solidFill>
+                <a:latin typeface="Apple SD Gothic Neo"/>
+                <a:ea typeface="Apple SD Gothic Neo"/>
+                <a:cs typeface="Apple SD Gothic Neo"/>
+              </a:defRPr>
+            </a:pPr>
+            <a:r>
+              <a:rPr sz="1950" b="1">
+                <a:solidFill>
+                  <a:srgbClr val="18232E"/>
+                </a:solidFill>
+                <a:latin typeface="Apple SD Gothic Neo"/>
+                <a:ea typeface="Apple SD Gothic Neo"/>
+                <a:cs typeface="Apple SD Gothic Neo"/>
+              </a:rPr>
+              <a:t>VIA의 직접 설명 E20</a:t>
+            </a:r>
+          </a:p>
+        </p:txBody>
+      </p:sp>
+      <p:sp>
+        <p:nvSpPr>
+          <p:cNvPr id="25" name="dp45-background / n21 / text 2">
+            <a:extLst xmlns:a="http://schemas.openxmlformats.org/drawingml/2006/main">
+              <a:ext uri="{FF2B5EF4-FFF2-40B4-BE49-F238E27FC236}">
+                <a16:creationId xmlns:a16="http://schemas.microsoft.com/office/drawing/2014/main" id="{D40CE102-A59D-4541-B8E6-73256A9DB02F}"/>
+              </a:ext>
+            </a:extLst>
+          </p:cNvPr>
+          <p:cNvSpPr>
+            <a:spLocks xmlns:a="http://schemas.openxmlformats.org/drawingml/2006/main" noGrp="1"/>
+          </p:cNvSpPr>
+          <p:nvPr/>
+        </p:nvSpPr>
+        <p:spPr>
+          <a:xfrm xmlns:a="http://schemas.openxmlformats.org/drawingml/2006/main">
+            <a:off x="800100" y="4181475"/>
+            <a:ext cx="2952750" cy="359092"/>
+          </a:xfrm>
+          <a:prstGeom xmlns:a="http://schemas.openxmlformats.org/drawingml/2006/main" prst="rect">
+            <a:avLst/>
+          </a:prstGeom>
+          <a:noFill xmlns:a="http://schemas.openxmlformats.org/drawingml/2006/main"/>
+          <a:ln xmlns:a="http://schemas.openxmlformats.org/drawingml/2006/main" w="0">
+            <a:noFill/>
+            <a:prstDash val="solid"/>
+          </a:ln>
+        </p:spPr>
+        <p:txBody>
+          <a:bodyPr xmlns:a="http://schemas.openxmlformats.org/drawingml/2006/main" wrap="none" lIns="0" tIns="0" rIns="0" bIns="0" anchor="t">
+            <a:noAutofit/>
+          </a:bodyPr>
+          <a:lstStyle xmlns:a="http://schemas.openxmlformats.org/drawingml/2006/main"/>
+          <a:p xmlns:a="http://schemas.openxmlformats.org/drawingml/2006/main">
+            <a:pPr algn="l">
+              <a:defRPr sz="1950" b="1">
+                <a:solidFill>
+                  <a:srgbClr val="18232E"/>
+                </a:solidFill>
+                <a:latin typeface="Apple SD Gothic Neo"/>
+                <a:ea typeface="Apple SD Gothic Neo"/>
+                <a:cs typeface="Apple SD Gothic Neo"/>
+              </a:defRPr>
+            </a:pPr>
+            <a:r>
+              <a:rPr sz="1950" b="1">
+                <a:solidFill>
+                  <a:srgbClr val="18232E"/>
+                </a:solidFill>
+                <a:latin typeface="Apple SD Gothic Neo"/>
+                <a:ea typeface="Apple SD Gothic Neo"/>
+                <a:cs typeface="Apple SD Gothic Neo"/>
+              </a:rPr>
+              <a:t>평가 기준</a:t>
+            </a:r>
+          </a:p>
+        </p:txBody>
+      </p:sp>
+      <p:sp>
+        <p:nvSpPr>
+          <p:cNvPr id="26" name="dp45-background / n22 / text 1">
+            <a:extLst xmlns:a="http://schemas.openxmlformats.org/drawingml/2006/main">
+              <a:ext uri="{FF2B5EF4-FFF2-40B4-BE49-F238E27FC236}">
+                <a16:creationId xmlns:a16="http://schemas.microsoft.com/office/drawing/2014/main" id="{F6007998-E573-4BCF-A54A-751338C12CFA}"/>
+              </a:ext>
+            </a:extLst>
+          </p:cNvPr>
+          <p:cNvSpPr>
+            <a:spLocks xmlns:a="http://schemas.openxmlformats.org/drawingml/2006/main" noGrp="1"/>
+          </p:cNvSpPr>
+          <p:nvPr/>
+        </p:nvSpPr>
+        <p:spPr>
+          <a:xfrm xmlns:a="http://schemas.openxmlformats.org/drawingml/2006/main">
+            <a:off x="800100" y="4714875"/>
+            <a:ext cx="2952750" cy="317659"/>
+          </a:xfrm>
+          <a:prstGeom xmlns:a="http://schemas.openxmlformats.org/drawingml/2006/main" prst="rect">
+            <a:avLst/>
+          </a:prstGeom>
+          <a:noFill xmlns:a="http://schemas.openxmlformats.org/drawingml/2006/main"/>
+          <a:ln xmlns:a="http://schemas.openxmlformats.org/drawingml/2006/main" w="0">
+            <a:noFill/>
+            <a:prstDash val="solid"/>
+          </a:ln>
+        </p:spPr>
+        <p:txBody>
+          <a:bodyPr xmlns:a="http://schemas.openxmlformats.org/drawingml/2006/main" wrap="none" lIns="0" tIns="0" rIns="0" bIns="0" anchor="t">
+            <a:noAutofit/>
+          </a:bodyPr>
+          <a:lstStyle xmlns:a="http://schemas.openxmlformats.org/drawingml/2006/main"/>
+          <a:p xmlns:a="http://schemas.openxmlformats.org/drawingml/2006/main">
+            <a:pPr algn="l">
+              <a:defRPr sz="1725" b="1">
+                <a:solidFill>
+                  <a:srgbClr val="087E8B"/>
+                </a:solidFill>
+                <a:latin typeface="Apple SD Gothic Neo"/>
+                <a:ea typeface="Apple SD Gothic Neo"/>
+                <a:cs typeface="Apple SD Gothic Neo"/>
+              </a:defRPr>
+            </a:pPr>
+            <a:r>
+              <a:rPr sz="1725" b="1">
+                <a:solidFill>
+                  <a:srgbClr val="087E8B"/>
+                </a:solidFill>
+                <a:latin typeface="Apple SD Gothic Neo"/>
+                <a:ea typeface="Apple SD Gothic Neo"/>
+                <a:cs typeface="Apple SD Gothic Neo"/>
+              </a:rPr>
+              <a:t>실제 전달 P20의</a:t>
+            </a:r>
+          </a:p>
+        </p:txBody>
+      </p:sp>
+      <p:sp>
+        <p:nvSpPr>
+          <p:cNvPr id="27" name="dp45-background / n22 / text 2">
+            <a:extLst xmlns:a="http://schemas.openxmlformats.org/drawingml/2006/main">
+              <a:ext uri="{FF2B5EF4-FFF2-40B4-BE49-F238E27FC236}">
+                <a16:creationId xmlns:a16="http://schemas.microsoft.com/office/drawing/2014/main" id="{9B8F31ED-C128-4418-9CE1-2BDAE47C4515}"/>
+              </a:ext>
+            </a:extLst>
+          </p:cNvPr>
+          <p:cNvSpPr>
+            <a:spLocks xmlns:a="http://schemas.openxmlformats.org/drawingml/2006/main" noGrp="1"/>
+          </p:cNvSpPr>
+          <p:nvPr/>
+        </p:nvSpPr>
+        <p:spPr>
+          <a:xfrm xmlns:a="http://schemas.openxmlformats.org/drawingml/2006/main">
+            <a:off x="800100" y="5038725"/>
+            <a:ext cx="2952750" cy="317659"/>
+          </a:xfrm>
+          <a:prstGeom xmlns:a="http://schemas.openxmlformats.org/drawingml/2006/main" prst="rect">
+            <a:avLst/>
+          </a:prstGeom>
+          <a:noFill xmlns:a="http://schemas.openxmlformats.org/drawingml/2006/main"/>
+          <a:ln xmlns:a="http://schemas.openxmlformats.org/drawingml/2006/main" w="0">
+            <a:noFill/>
+            <a:prstDash val="solid"/>
+          </a:ln>
+        </p:spPr>
+        <p:txBody>
+          <a:bodyPr xmlns:a="http://schemas.openxmlformats.org/drawingml/2006/main" wrap="none" lIns="0" tIns="0" rIns="0" bIns="0" anchor="t">
+            <a:noAutofit/>
+          </a:bodyPr>
+          <a:lstStyle xmlns:a="http://schemas.openxmlformats.org/drawingml/2006/main"/>
+          <a:p xmlns:a="http://schemas.openxmlformats.org/drawingml/2006/main">
+            <a:pPr algn="l">
+              <a:defRPr sz="1725" b="1">
+                <a:solidFill>
+                  <a:srgbClr val="087E8B"/>
+                </a:solidFill>
+                <a:latin typeface="Apple SD Gothic Neo"/>
+                <a:ea typeface="Apple SD Gothic Neo"/>
+                <a:cs typeface="Apple SD Gothic Neo"/>
+              </a:defRPr>
+            </a:pPr>
+            <a:r>
+              <a:rPr sz="1725" b="1">
+                <a:solidFill>
+                  <a:srgbClr val="087E8B"/>
+                </a:solidFill>
+                <a:latin typeface="Apple SD Gothic Neo"/>
+                <a:ea typeface="Apple SD Gothic Neo"/>
+                <a:cs typeface="Apple SD Gothic Neo"/>
+              </a:rPr>
+              <a:t>설명 내용과 범위</a:t>
+            </a:r>
+          </a:p>
+        </p:txBody>
+      </p:sp>
+      <p:sp>
+        <p:nvSpPr>
+          <p:cNvPr id="28" name="dp45-background / n23 / text 1">
+            <a:extLst xmlns:a="http://schemas.openxmlformats.org/drawingml/2006/main">
+              <a:ext uri="{FF2B5EF4-FFF2-40B4-BE49-F238E27FC236}">
+                <a16:creationId xmlns:a16="http://schemas.microsoft.com/office/drawing/2014/main" id="{E1D8B2CC-5774-415C-AF2F-D5B598B5B544}"/>
+              </a:ext>
+            </a:extLst>
+          </p:cNvPr>
+          <p:cNvSpPr>
+            <a:spLocks xmlns:a="http://schemas.openxmlformats.org/drawingml/2006/main" noGrp="1"/>
+          </p:cNvSpPr>
+          <p:nvPr/>
+        </p:nvSpPr>
+        <p:spPr>
+          <a:xfrm xmlns:a="http://schemas.openxmlformats.org/drawingml/2006/main">
+            <a:off x="800100" y="5524500"/>
+            <a:ext cx="2952750" cy="262414"/>
+          </a:xfrm>
+          <a:prstGeom xmlns:a="http://schemas.openxmlformats.org/drawingml/2006/main" prst="rect">
+            <a:avLst/>
+          </a:prstGeom>
+          <a:noFill xmlns:a="http://schemas.openxmlformats.org/drawingml/2006/main"/>
+          <a:ln xmlns:a="http://schemas.openxmlformats.org/drawingml/2006/main" w="0">
+            <a:noFill/>
+            <a:prstDash val="solid"/>
+          </a:ln>
+        </p:spPr>
+        <p:txBody>
+          <a:bodyPr xmlns:a="http://schemas.openxmlformats.org/drawingml/2006/main" wrap="none" lIns="0" tIns="0" rIns="0" bIns="0" anchor="t">
+            <a:noAutofit/>
+          </a:bodyPr>
+          <a:lstStyle xmlns:a="http://schemas.openxmlformats.org/drawingml/2006/main"/>
+          <a:p xmlns:a="http://schemas.openxmlformats.org/drawingml/2006/main">
+            <a:pPr algn="l">
+              <a:defRPr sz="1425" b="0">
+                <a:solidFill>
+                  <a:srgbClr val="5F6B77"/>
+                </a:solidFill>
+                <a:latin typeface="Apple SD Gothic Neo"/>
+                <a:ea typeface="Apple SD Gothic Neo"/>
+                <a:cs typeface="Apple SD Gothic Neo"/>
+              </a:defRPr>
+            </a:pPr>
+            <a:r>
+              <a:rPr sz="1425" b="0">
+                <a:solidFill>
+                  <a:srgbClr val="5F6B77"/>
+                </a:solidFill>
+                <a:latin typeface="Apple SD Gothic Neo"/>
+                <a:ea typeface="Apple SD Gothic Neo"/>
+                <a:cs typeface="Apple SD Gothic Neo"/>
+              </a:rPr>
+              <a:t>생성과 실제 전달 구별</a:t>
+            </a:r>
+          </a:p>
+        </p:txBody>
+      </p:sp>
+      <p:sp>
+        <p:nvSpPr>
+          <p:cNvPr id="29" name="dp45-background / n24 / text 1">
+            <a:extLst xmlns:a="http://schemas.openxmlformats.org/drawingml/2006/main">
+              <a:ext uri="{FF2B5EF4-FFF2-40B4-BE49-F238E27FC236}">
+                <a16:creationId xmlns:a16="http://schemas.microsoft.com/office/drawing/2014/main" id="{356F7FDD-1145-41F6-9DF3-7204B938FD4C}"/>
+              </a:ext>
+            </a:extLst>
+          </p:cNvPr>
+          <p:cNvSpPr>
+            <a:spLocks xmlns:a="http://schemas.openxmlformats.org/drawingml/2006/main" noGrp="1"/>
+          </p:cNvSpPr>
+          <p:nvPr/>
+        </p:nvSpPr>
+        <p:spPr>
+          <a:xfrm xmlns:a="http://schemas.openxmlformats.org/drawingml/2006/main">
+            <a:off x="4419600" y="3305175"/>
+            <a:ext cx="2952750" cy="331470"/>
+          </a:xfrm>
+          <a:prstGeom xmlns:a="http://schemas.openxmlformats.org/drawingml/2006/main" prst="rect">
+            <a:avLst/>
+          </a:prstGeom>
+          <a:noFill xmlns:a="http://schemas.openxmlformats.org/drawingml/2006/main"/>
+          <a:ln xmlns:a="http://schemas.openxmlformats.org/drawingml/2006/main" w="0">
+            <a:noFill/>
+            <a:prstDash val="solid"/>
+          </a:ln>
+        </p:spPr>
+        <p:txBody>
+          <a:bodyPr xmlns:a="http://schemas.openxmlformats.org/drawingml/2006/main" wrap="none" lIns="0" tIns="0" rIns="0" bIns="0" anchor="t">
+            <a:noAutofit/>
+          </a:bodyPr>
+          <a:lstStyle xmlns:a="http://schemas.openxmlformats.org/drawingml/2006/main"/>
+          <a:p xmlns:a="http://schemas.openxmlformats.org/drawingml/2006/main">
+            <a:pPr algn="l">
+              <a:defRPr sz="1800" b="1">
+                <a:solidFill>
+                  <a:srgbClr val="18232E"/>
+                </a:solidFill>
+                <a:latin typeface="Apple SD Gothic Neo"/>
+                <a:ea typeface="Apple SD Gothic Neo"/>
+                <a:cs typeface="Apple SD Gothic Neo"/>
+              </a:defRPr>
+            </a:pPr>
+            <a:r>
+              <a:rPr sz="1800" b="1">
+                <a:solidFill>
+                  <a:srgbClr val="18232E"/>
+                </a:solidFill>
+                <a:latin typeface="Apple SD Gothic Neo"/>
+                <a:ea typeface="Apple SD Gothic Neo"/>
+                <a:cs typeface="Apple SD Gothic Neo"/>
+              </a:rPr>
+              <a:t>이후 제품 조사 T21</a:t>
+            </a:r>
+          </a:p>
+        </p:txBody>
+      </p:sp>
+      <p:sp>
+        <p:nvSpPr>
+          <p:cNvPr id="30" name="dp45-background / n25 / text 1">
+            <a:extLst xmlns:a="http://schemas.openxmlformats.org/drawingml/2006/main">
+              <a:ext uri="{FF2B5EF4-FFF2-40B4-BE49-F238E27FC236}">
+                <a16:creationId xmlns:a16="http://schemas.microsoft.com/office/drawing/2014/main" id="{DBB1FD1E-FE1C-4D7E-BAE4-B80ECE03E7D3}"/>
+              </a:ext>
+            </a:extLst>
+          </p:cNvPr>
+          <p:cNvSpPr>
+            <a:spLocks xmlns:a="http://schemas.openxmlformats.org/drawingml/2006/main" noGrp="1"/>
+          </p:cNvSpPr>
+          <p:nvPr/>
+        </p:nvSpPr>
+        <p:spPr>
+          <a:xfrm xmlns:a="http://schemas.openxmlformats.org/drawingml/2006/main">
+            <a:off x="4419600" y="3829050"/>
             <a:ext cx="2952750" cy="345281"/>
           </a:xfrm>
           <a:prstGeom xmlns:a="http://schemas.openxmlformats.org/drawingml/2006/main" prst="rect">
@@ -16058,221 +16474,221 @@
                 <a:ea typeface="Apple SD Gothic Neo"/>
                 <a:cs typeface="Apple SD Gothic Neo"/>
               </a:rPr>
-              <a:t>정정 Request</a:t>
-            </a:r>
-          </a:p>
-        </p:txBody>
-      </p:sp>
-      <p:sp>
-        <p:nvSpPr>
-          <p:cNvPr id="24" name="dp45-background / n21 / text 1">
-            <a:extLst xmlns:a="http://schemas.openxmlformats.org/drawingml/2006/main">
-              <a:ext uri="{FF2B5EF4-FFF2-40B4-BE49-F238E27FC236}">
-                <a16:creationId xmlns:a16="http://schemas.microsoft.com/office/drawing/2014/main" id="{CAC1A7EF-9BF6-4979-95C5-1FF33301D0BC}"/>
-              </a:ext>
-            </a:extLst>
-          </p:cNvPr>
-          <p:cNvSpPr>
-            <a:spLocks xmlns:a="http://schemas.openxmlformats.org/drawingml/2006/main" noGrp="1"/>
-          </p:cNvSpPr>
-          <p:nvPr/>
-        </p:nvSpPr>
-        <p:spPr>
-          <a:xfrm xmlns:a="http://schemas.openxmlformats.org/drawingml/2006/main">
-            <a:off x="800100" y="3886200"/>
-            <a:ext cx="2952750" cy="400526"/>
-          </a:xfrm>
-          <a:prstGeom xmlns:a="http://schemas.openxmlformats.org/drawingml/2006/main" prst="rect">
-            <a:avLst/>
-          </a:prstGeom>
-          <a:noFill xmlns:a="http://schemas.openxmlformats.org/drawingml/2006/main"/>
-          <a:ln xmlns:a="http://schemas.openxmlformats.org/drawingml/2006/main" w="0">
-            <a:noFill/>
-            <a:prstDash val="solid"/>
-          </a:ln>
-        </p:spPr>
-        <p:txBody>
-          <a:bodyPr xmlns:a="http://schemas.openxmlformats.org/drawingml/2006/main" wrap="none" lIns="0" tIns="0" rIns="0" bIns="0" anchor="t">
-            <a:noAutofit/>
-          </a:bodyPr>
-          <a:lstStyle xmlns:a="http://schemas.openxmlformats.org/drawingml/2006/main"/>
-          <a:p xmlns:a="http://schemas.openxmlformats.org/drawingml/2006/main">
-            <a:pPr algn="l">
-              <a:defRPr sz="2175" b="1">
-                <a:solidFill>
-                  <a:srgbClr val="18232E"/>
-                </a:solidFill>
-                <a:latin typeface="Apple SD Gothic Neo"/>
-                <a:ea typeface="Apple SD Gothic Neo"/>
-                <a:cs typeface="Apple SD Gothic Neo"/>
-              </a:defRPr>
-            </a:pPr>
-            <a:r>
-              <a:rPr sz="2175" b="1">
-                <a:solidFill>
-                  <a:srgbClr val="18232E"/>
-                </a:solidFill>
-                <a:latin typeface="Apple SD Gothic Neo"/>
-                <a:ea typeface="Apple SD Gothic Neo"/>
-                <a:cs typeface="Apple SD Gothic Neo"/>
-              </a:rPr>
-              <a:t>“결론 먼저,</a:t>
-            </a:r>
-          </a:p>
-        </p:txBody>
-      </p:sp>
-      <p:sp>
-        <p:nvSpPr>
-          <p:cNvPr id="25" name="dp45-background / n21 / text 2">
-            <a:extLst xmlns:a="http://schemas.openxmlformats.org/drawingml/2006/main">
-              <a:ext uri="{FF2B5EF4-FFF2-40B4-BE49-F238E27FC236}">
-                <a16:creationId xmlns:a16="http://schemas.microsoft.com/office/drawing/2014/main" id="{317877D8-55B7-455C-8E24-70380B3C3536}"/>
-              </a:ext>
-            </a:extLst>
-          </p:cNvPr>
-          <p:cNvSpPr>
-            <a:spLocks xmlns:a="http://schemas.openxmlformats.org/drawingml/2006/main" noGrp="1"/>
-          </p:cNvSpPr>
-          <p:nvPr/>
-        </p:nvSpPr>
-        <p:spPr>
-          <a:xfrm xmlns:a="http://schemas.openxmlformats.org/drawingml/2006/main">
-            <a:off x="800100" y="4238625"/>
-            <a:ext cx="2952750" cy="400526"/>
-          </a:xfrm>
-          <a:prstGeom xmlns:a="http://schemas.openxmlformats.org/drawingml/2006/main" prst="rect">
-            <a:avLst/>
-          </a:prstGeom>
-          <a:noFill xmlns:a="http://schemas.openxmlformats.org/drawingml/2006/main"/>
-          <a:ln xmlns:a="http://schemas.openxmlformats.org/drawingml/2006/main" w="0">
-            <a:noFill/>
-            <a:prstDash val="solid"/>
-          </a:ln>
-        </p:spPr>
-        <p:txBody>
-          <a:bodyPr xmlns:a="http://schemas.openxmlformats.org/drawingml/2006/main" wrap="none" lIns="0" tIns="0" rIns="0" bIns="0" anchor="t">
-            <a:noAutofit/>
-          </a:bodyPr>
-          <a:lstStyle xmlns:a="http://schemas.openxmlformats.org/drawingml/2006/main"/>
-          <a:p xmlns:a="http://schemas.openxmlformats.org/drawingml/2006/main">
-            <a:pPr algn="l">
-              <a:defRPr sz="2175" b="1">
-                <a:solidFill>
-                  <a:srgbClr val="18232E"/>
-                </a:solidFill>
-                <a:latin typeface="Apple SD Gothic Neo"/>
-                <a:ea typeface="Apple SD Gothic Neo"/>
-                <a:cs typeface="Apple SD Gothic Neo"/>
-              </a:defRPr>
-            </a:pPr>
-            <a:r>
-              <a:rPr sz="2175" b="1">
-                <a:solidFill>
-                  <a:srgbClr val="18232E"/>
-                </a:solidFill>
-                <a:latin typeface="Apple SD Gothic Neo"/>
-                <a:ea typeface="Apple SD Gothic Neo"/>
-                <a:cs typeface="Apple SD Gothic Neo"/>
-              </a:rPr>
-              <a:t>짧은 문장으로</a:t>
-            </a:r>
-          </a:p>
-        </p:txBody>
-      </p:sp>
-      <p:sp>
-        <p:nvSpPr>
-          <p:cNvPr id="26" name="dp45-background / n21 / text 3">
-            <a:extLst xmlns:a="http://schemas.openxmlformats.org/drawingml/2006/main">
-              <a:ext uri="{FF2B5EF4-FFF2-40B4-BE49-F238E27FC236}">
-                <a16:creationId xmlns:a16="http://schemas.microsoft.com/office/drawing/2014/main" id="{803B16A3-9421-4B61-A149-F11A8B670CFA}"/>
-              </a:ext>
-            </a:extLst>
-          </p:cNvPr>
-          <p:cNvSpPr>
-            <a:spLocks xmlns:a="http://schemas.openxmlformats.org/drawingml/2006/main" noGrp="1"/>
-          </p:cNvSpPr>
-          <p:nvPr/>
-        </p:nvSpPr>
-        <p:spPr>
-          <a:xfrm xmlns:a="http://schemas.openxmlformats.org/drawingml/2006/main">
-            <a:off x="800100" y="4591050"/>
-            <a:ext cx="2952750" cy="400526"/>
-          </a:xfrm>
-          <a:prstGeom xmlns:a="http://schemas.openxmlformats.org/drawingml/2006/main" prst="rect">
-            <a:avLst/>
-          </a:prstGeom>
-          <a:noFill xmlns:a="http://schemas.openxmlformats.org/drawingml/2006/main"/>
-          <a:ln xmlns:a="http://schemas.openxmlformats.org/drawingml/2006/main" w="0">
-            <a:noFill/>
-            <a:prstDash val="solid"/>
-          </a:ln>
-        </p:spPr>
-        <p:txBody>
-          <a:bodyPr xmlns:a="http://schemas.openxmlformats.org/drawingml/2006/main" wrap="none" lIns="0" tIns="0" rIns="0" bIns="0" anchor="t">
-            <a:noAutofit/>
-          </a:bodyPr>
-          <a:lstStyle xmlns:a="http://schemas.openxmlformats.org/drawingml/2006/main"/>
-          <a:p xmlns:a="http://schemas.openxmlformats.org/drawingml/2006/main">
-            <a:pPr algn="l">
-              <a:defRPr sz="2175" b="1">
-                <a:solidFill>
-                  <a:srgbClr val="18232E"/>
-                </a:solidFill>
-                <a:latin typeface="Apple SD Gothic Neo"/>
-                <a:ea typeface="Apple SD Gothic Neo"/>
-                <a:cs typeface="Apple SD Gothic Neo"/>
-              </a:defRPr>
-            </a:pPr>
-            <a:r>
-              <a:rPr sz="2175" b="1">
-                <a:solidFill>
-                  <a:srgbClr val="18232E"/>
-                </a:solidFill>
-                <a:latin typeface="Apple SD Gothic Neo"/>
-                <a:ea typeface="Apple SD Gothic Neo"/>
-                <a:cs typeface="Apple SD Gothic Neo"/>
-              </a:rPr>
-              <a:t>바꿔줘.”</a:t>
-            </a:r>
-          </a:p>
-        </p:txBody>
-      </p:sp>
-      <p:sp>
-        <p:nvSpPr>
-          <p:cNvPr id="27" name="dp45-background / n22 / text 1">
-            <a:extLst xmlns:a="http://schemas.openxmlformats.org/drawingml/2006/main">
-              <a:ext uri="{FF2B5EF4-FFF2-40B4-BE49-F238E27FC236}">
-                <a16:creationId xmlns:a16="http://schemas.microsoft.com/office/drawing/2014/main" id="{029406D0-4953-48F2-909C-24CE3C2A69AB}"/>
-              </a:ext>
-            </a:extLst>
-          </p:cNvPr>
-          <p:cNvSpPr>
-            <a:spLocks xmlns:a="http://schemas.openxmlformats.org/drawingml/2006/main" noGrp="1"/>
-          </p:cNvSpPr>
-          <p:nvPr/>
-        </p:nvSpPr>
-        <p:spPr>
-          <a:xfrm xmlns:a="http://schemas.openxmlformats.org/drawingml/2006/main">
-            <a:off x="800100" y="5448300"/>
-            <a:ext cx="2952750" cy="290036"/>
-          </a:xfrm>
-          <a:prstGeom xmlns:a="http://schemas.openxmlformats.org/drawingml/2006/main" prst="rect">
-            <a:avLst/>
-          </a:prstGeom>
-          <a:noFill xmlns:a="http://schemas.openxmlformats.org/drawingml/2006/main"/>
-          <a:ln xmlns:a="http://schemas.openxmlformats.org/drawingml/2006/main" w="0">
-            <a:noFill/>
-            <a:prstDash val="solid"/>
-          </a:ln>
-        </p:spPr>
-        <p:txBody>
-          <a:bodyPr xmlns:a="http://schemas.openxmlformats.org/drawingml/2006/main" wrap="none" lIns="0" tIns="0" rIns="0" bIns="0" anchor="t">
-            <a:noAutofit/>
-          </a:bodyPr>
-          <a:lstStyle xmlns:a="http://schemas.openxmlformats.org/drawingml/2006/main"/>
-          <a:p xmlns:a="http://schemas.openxmlformats.org/drawingml/2006/main">
-            <a:pPr algn="l">
-              <a:defRPr sz="1575" b="0">
+              <a:t>한 Downstream Agent</a:t>
+            </a:r>
+          </a:p>
+        </p:txBody>
+      </p:sp>
+      <p:sp>
+        <p:nvSpPr>
+          <p:cNvPr id="31" name="dp45-background / n25 / text 2">
+            <a:extLst xmlns:a="http://schemas.openxmlformats.org/drawingml/2006/main">
+              <a:ext uri="{FF2B5EF4-FFF2-40B4-BE49-F238E27FC236}">
+                <a16:creationId xmlns:a16="http://schemas.microsoft.com/office/drawing/2014/main" id="{8456E2B0-1568-4AD9-8F3E-82194A48F465}"/>
+              </a:ext>
+            </a:extLst>
+          </p:cNvPr>
+          <p:cNvSpPr>
+            <a:spLocks xmlns:a="http://schemas.openxmlformats.org/drawingml/2006/main" noGrp="1"/>
+          </p:cNvSpPr>
+          <p:nvPr/>
+        </p:nvSpPr>
+        <p:spPr>
+          <a:xfrm xmlns:a="http://schemas.openxmlformats.org/drawingml/2006/main">
+            <a:off x="4419600" y="4181475"/>
+            <a:ext cx="2952750" cy="345281"/>
+          </a:xfrm>
+          <a:prstGeom xmlns:a="http://schemas.openxmlformats.org/drawingml/2006/main" prst="rect">
+            <a:avLst/>
+          </a:prstGeom>
+          <a:noFill xmlns:a="http://schemas.openxmlformats.org/drawingml/2006/main"/>
+          <a:ln xmlns:a="http://schemas.openxmlformats.org/drawingml/2006/main" w="0">
+            <a:noFill/>
+            <a:prstDash val="solid"/>
+          </a:ln>
+        </p:spPr>
+        <p:txBody>
+          <a:bodyPr xmlns:a="http://schemas.openxmlformats.org/drawingml/2006/main" wrap="none" lIns="0" tIns="0" rIns="0" bIns="0" anchor="t">
+            <a:noAutofit/>
+          </a:bodyPr>
+          <a:lstStyle xmlns:a="http://schemas.openxmlformats.org/drawingml/2006/main"/>
+          <a:p xmlns:a="http://schemas.openxmlformats.org/drawingml/2006/main">
+            <a:pPr algn="l">
+              <a:defRPr sz="1875" b="1">
+                <a:solidFill>
+                  <a:srgbClr val="18232E"/>
+                </a:solidFill>
+                <a:latin typeface="Apple SD Gothic Neo"/>
+                <a:ea typeface="Apple SD Gothic Neo"/>
+                <a:cs typeface="Apple SD Gothic Neo"/>
+              </a:defRPr>
+            </a:pPr>
+            <a:r>
+              <a:rPr sz="1875" b="1">
+                <a:solidFill>
+                  <a:srgbClr val="18232E"/>
+                </a:solidFill>
+                <a:latin typeface="Apple SD Gothic Neo"/>
+                <a:ea typeface="Apple SD Gothic Neo"/>
+                <a:cs typeface="Apple SD Gothic Neo"/>
+              </a:rPr>
+              <a:t>제품 비교 수행</a:t>
+            </a:r>
+          </a:p>
+        </p:txBody>
+      </p:sp>
+      <p:sp>
+        <p:nvSpPr>
+          <p:cNvPr id="32" name="dp45-background / n26 / text 1">
+            <a:extLst xmlns:a="http://schemas.openxmlformats.org/drawingml/2006/main">
+              <a:ext uri="{FF2B5EF4-FFF2-40B4-BE49-F238E27FC236}">
+                <a16:creationId xmlns:a16="http://schemas.microsoft.com/office/drawing/2014/main" id="{9C95132E-D53C-4B21-8E38-D4A452FB9297}"/>
+              </a:ext>
+            </a:extLst>
+          </p:cNvPr>
+          <p:cNvSpPr>
+            <a:spLocks xmlns:a="http://schemas.openxmlformats.org/drawingml/2006/main" noGrp="1"/>
+          </p:cNvSpPr>
+          <p:nvPr/>
+        </p:nvSpPr>
+        <p:spPr>
+          <a:xfrm xmlns:a="http://schemas.openxmlformats.org/drawingml/2006/main">
+            <a:off x="4419600" y="4714875"/>
+            <a:ext cx="2952750" cy="317659"/>
+          </a:xfrm>
+          <a:prstGeom xmlns:a="http://schemas.openxmlformats.org/drawingml/2006/main" prst="rect">
+            <a:avLst/>
+          </a:prstGeom>
+          <a:noFill xmlns:a="http://schemas.openxmlformats.org/drawingml/2006/main"/>
+          <a:ln xmlns:a="http://schemas.openxmlformats.org/drawingml/2006/main" w="0">
+            <a:noFill/>
+            <a:prstDash val="solid"/>
+          </a:ln>
+        </p:spPr>
+        <p:txBody>
+          <a:bodyPr xmlns:a="http://schemas.openxmlformats.org/drawingml/2006/main" wrap="none" lIns="0" tIns="0" rIns="0" bIns="0" anchor="t">
+            <a:noAutofit/>
+          </a:bodyPr>
+          <a:lstStyle xmlns:a="http://schemas.openxmlformats.org/drawingml/2006/main"/>
+          <a:p xmlns:a="http://schemas.openxmlformats.org/drawingml/2006/main">
+            <a:pPr algn="l">
+              <a:defRPr sz="1725" b="1">
+                <a:solidFill>
+                  <a:srgbClr val="087E8B"/>
+                </a:solidFill>
+                <a:latin typeface="Apple SD Gothic Neo"/>
+                <a:ea typeface="Apple SD Gothic Neo"/>
+                <a:cs typeface="Apple SD Gothic Neo"/>
+              </a:defRPr>
+            </a:pPr>
+            <a:r>
+              <a:rPr sz="1725" b="1">
+                <a:solidFill>
+                  <a:srgbClr val="087E8B"/>
+                </a:solidFill>
+                <a:latin typeface="Apple SD Gothic Neo"/>
+                <a:ea typeface="Apple SD Gothic Neo"/>
+                <a:cs typeface="Apple SD Gothic Neo"/>
+              </a:rPr>
+              <a:t>VIA가 확인한 결과 참조</a:t>
+            </a:r>
+          </a:p>
+        </p:txBody>
+      </p:sp>
+      <p:sp>
+        <p:nvSpPr>
+          <p:cNvPr id="33" name="dp45-background / n26 / text 2">
+            <a:extLst xmlns:a="http://schemas.openxmlformats.org/drawingml/2006/main">
+              <a:ext uri="{FF2B5EF4-FFF2-40B4-BE49-F238E27FC236}">
+                <a16:creationId xmlns:a16="http://schemas.microsoft.com/office/drawing/2014/main" id="{6C41ECBF-E1E0-4EF2-999C-F2EE0501A375}"/>
+              </a:ext>
+            </a:extLst>
+          </p:cNvPr>
+          <p:cNvSpPr>
+            <a:spLocks xmlns:a="http://schemas.openxmlformats.org/drawingml/2006/main" noGrp="1"/>
+          </p:cNvSpPr>
+          <p:nvPr/>
+        </p:nvSpPr>
+        <p:spPr>
+          <a:xfrm xmlns:a="http://schemas.openxmlformats.org/drawingml/2006/main">
+            <a:off x="4419600" y="5038725"/>
+            <a:ext cx="2952750" cy="317659"/>
+          </a:xfrm>
+          <a:prstGeom xmlns:a="http://schemas.openxmlformats.org/drawingml/2006/main" prst="rect">
+            <a:avLst/>
+          </a:prstGeom>
+          <a:noFill xmlns:a="http://schemas.openxmlformats.org/drawingml/2006/main"/>
+          <a:ln xmlns:a="http://schemas.openxmlformats.org/drawingml/2006/main" w="0">
+            <a:noFill/>
+            <a:prstDash val="solid"/>
+          </a:ln>
+        </p:spPr>
+        <p:txBody>
+          <a:bodyPr xmlns:a="http://schemas.openxmlformats.org/drawingml/2006/main" wrap="none" lIns="0" tIns="0" rIns="0" bIns="0" anchor="t">
+            <a:noAutofit/>
+          </a:bodyPr>
+          <a:lstStyle xmlns:a="http://schemas.openxmlformats.org/drawingml/2006/main"/>
+          <a:p xmlns:a="http://schemas.openxmlformats.org/drawingml/2006/main">
+            <a:pPr algn="l">
+              <a:defRPr sz="1725" b="1">
+                <a:solidFill>
+                  <a:srgbClr val="087E8B"/>
+                </a:solidFill>
+                <a:latin typeface="Apple SD Gothic Neo"/>
+                <a:ea typeface="Apple SD Gothic Neo"/>
+                <a:cs typeface="Apple SD Gothic Neo"/>
+              </a:defRPr>
+            </a:pPr>
+            <a:r>
+              <a:rPr sz="1725" b="1">
+                <a:solidFill>
+                  <a:srgbClr val="087E8B"/>
+                </a:solidFill>
+                <a:latin typeface="Apple SD Gothic Neo"/>
+                <a:ea typeface="Apple SD Gothic Neo"/>
+                <a:cs typeface="Apple SD Gothic Neo"/>
+              </a:rPr>
+              <a:t>D21@v2</a:t>
+            </a:r>
+          </a:p>
+        </p:txBody>
+      </p:sp>
+      <p:sp>
+        <p:nvSpPr>
+          <p:cNvPr id="34" name="dp45-background / n27 / text 1">
+            <a:extLst xmlns:a="http://schemas.openxmlformats.org/drawingml/2006/main">
+              <a:ext uri="{FF2B5EF4-FFF2-40B4-BE49-F238E27FC236}">
+                <a16:creationId xmlns:a16="http://schemas.microsoft.com/office/drawing/2014/main" id="{9BE499D5-EDF9-4A38-9680-91A6CA77BE2D}"/>
+              </a:ext>
+            </a:extLst>
+          </p:cNvPr>
+          <p:cNvSpPr>
+            <a:spLocks xmlns:a="http://schemas.openxmlformats.org/drawingml/2006/main" noGrp="1"/>
+          </p:cNvSpPr>
+          <p:nvPr/>
+        </p:nvSpPr>
+        <p:spPr>
+          <a:xfrm xmlns:a="http://schemas.openxmlformats.org/drawingml/2006/main">
+            <a:off x="4419600" y="5524500"/>
+            <a:ext cx="2952750" cy="262414"/>
+          </a:xfrm>
+          <a:prstGeom xmlns:a="http://schemas.openxmlformats.org/drawingml/2006/main" prst="rect">
+            <a:avLst/>
+          </a:prstGeom>
+          <a:noFill xmlns:a="http://schemas.openxmlformats.org/drawingml/2006/main"/>
+          <a:ln xmlns:a="http://schemas.openxmlformats.org/drawingml/2006/main" w="0">
+            <a:noFill/>
+            <a:prstDash val="solid"/>
+          </a:ln>
+        </p:spPr>
+        <p:txBody>
+          <a:bodyPr xmlns:a="http://schemas.openxmlformats.org/drawingml/2006/main" wrap="none" lIns="0" tIns="0" rIns="0" bIns="0" anchor="t">
+            <a:noAutofit/>
+          </a:bodyPr>
+          <a:lstStyle xmlns:a="http://schemas.openxmlformats.org/drawingml/2006/main"/>
+          <a:p xmlns:a="http://schemas.openxmlformats.org/drawingml/2006/main">
+            <a:pPr algn="l">
+              <a:defRPr sz="1425" b="0">
                 <a:solidFill>
                   <a:srgbClr val="5F6B77"/>
                 </a:solidFill>
@@ -16282,7 +16698,7 @@
               </a:defRPr>
             </a:pPr>
             <a:r>
-              <a:rPr sz="1575" b="0">
+              <a:rPr sz="1425" b="0">
                 <a:solidFill>
                   <a:srgbClr val="5F6B77"/>
                 </a:solidFill>
@@ -16290,28 +16706,86 @@
                 <a:ea typeface="Apple SD Gothic Neo"/>
                 <a:cs typeface="Apple SD Gothic Neo"/>
               </a:rPr>
-              <a:t>사용자가 고친 내용</a:t>
-            </a:r>
-          </a:p>
-        </p:txBody>
-      </p:sp>
-      <p:sp>
-        <p:nvSpPr>
-          <p:cNvPr id="28" name="dp45-background / n23 / text 1">
-            <a:extLst xmlns:a="http://schemas.openxmlformats.org/drawingml/2006/main">
-              <a:ext uri="{FF2B5EF4-FFF2-40B4-BE49-F238E27FC236}">
-                <a16:creationId xmlns:a16="http://schemas.microsoft.com/office/drawing/2014/main" id="{866196C4-B1C4-4DBF-A064-1A93515A0FF8}"/>
-              </a:ext>
-            </a:extLst>
-          </p:cNvPr>
-          <p:cNvSpPr>
-            <a:spLocks xmlns:a="http://schemas.openxmlformats.org/drawingml/2006/main" noGrp="1"/>
-          </p:cNvSpPr>
-          <p:nvPr/>
-        </p:nvSpPr>
-        <p:spPr>
-          <a:xfrm xmlns:a="http://schemas.openxmlformats.org/drawingml/2006/main">
-            <a:off x="4419600" y="3305175"/>
+              <a:t>C21 대화에 연결</a:t>
+            </a:r>
+          </a:p>
+        </p:txBody>
+      </p:sp>
+      <p:sp>
+        <p:nvSpPr>
+          <p:cNvPr id="35" name="dp45-background / n28 / text 1">
+            <a:extLst xmlns:a="http://schemas.openxmlformats.org/drawingml/2006/main">
+              <a:ext uri="{FF2B5EF4-FFF2-40B4-BE49-F238E27FC236}">
+                <a16:creationId xmlns:a16="http://schemas.microsoft.com/office/drawing/2014/main" id="{189E7174-C3DC-4E29-AFFF-F29A5C7AEB41}"/>
+              </a:ext>
+            </a:extLst>
+          </p:cNvPr>
+          <p:cNvSpPr>
+            <a:spLocks xmlns:a="http://schemas.openxmlformats.org/drawingml/2006/main" noGrp="1"/>
+          </p:cNvSpPr>
+          <p:nvPr/>
+        </p:nvSpPr>
+        <p:spPr>
+          <a:xfrm xmlns:a="http://schemas.openxmlformats.org/drawingml/2006/main">
+            <a:off x="8039100" y="3305175"/>
+            <a:ext cx="2952750" cy="331470"/>
+          </a:xfrm>
+          <a:prstGeom xmlns:a="http://schemas.openxmlformats.org/drawingml/2006/main" prst="rect">
+            <a:avLst/>
+          </a:prstGeom>
+          <a:noFill xmlns:a="http://schemas.openxmlformats.org/drawingml/2006/main"/>
+          <a:ln xmlns:a="http://schemas.openxmlformats.org/drawingml/2006/main" w="0">
+            <a:noFill/>
+            <a:prstDash val="solid"/>
+          </a:ln>
+        </p:spPr>
+        <p:txBody>
+          <a:bodyPr xmlns:a="http://schemas.openxmlformats.org/drawingml/2006/main" wrap="none" lIns="0" tIns="0" rIns="0" bIns="0" anchor="t">
+            <a:noAutofit/>
+          </a:bodyPr>
+          <a:lstStyle xmlns:a="http://schemas.openxmlformats.org/drawingml/2006/main"/>
+          <a:p xmlns:a="http://schemas.openxmlformats.org/drawingml/2006/main">
+            <a:pPr algn="l">
+              <a:defRPr sz="1800" b="1">
+                <a:solidFill>
+                  <a:srgbClr val="18232E"/>
+                </a:solidFill>
+                <a:latin typeface="Apple SD Gothic Neo"/>
+                <a:ea typeface="Apple SD Gothic Neo"/>
+                <a:cs typeface="Apple SD Gothic Neo"/>
+              </a:defRPr>
+            </a:pPr>
+            <a:r>
+              <a:rPr sz="1800" b="1">
+                <a:solidFill>
+                  <a:srgbClr val="18232E"/>
+                </a:solidFill>
+                <a:latin typeface="Apple SD Gothic Neo"/>
+                <a:ea typeface="Apple SD Gothic Neo"/>
+                <a:cs typeface="Apple SD Gothic Neo"/>
+              </a:rPr>
+              <a:t>이후 견적 업무 T22</a:t>
+            </a:r>
+          </a:p>
+        </p:txBody>
+      </p:sp>
+      <p:sp>
+        <p:nvSpPr>
+          <p:cNvPr id="36" name="dp45-background / n29 / text 1">
+            <a:extLst xmlns:a="http://schemas.openxmlformats.org/drawingml/2006/main">
+              <a:ext uri="{FF2B5EF4-FFF2-40B4-BE49-F238E27FC236}">
+                <a16:creationId xmlns:a16="http://schemas.microsoft.com/office/drawing/2014/main" id="{03FC9338-397F-4B1E-8921-6E070C4BD72F}"/>
+              </a:ext>
+            </a:extLst>
+          </p:cNvPr>
+          <p:cNvSpPr>
+            <a:spLocks xmlns:a="http://schemas.openxmlformats.org/drawingml/2006/main" noGrp="1"/>
+          </p:cNvSpPr>
+          <p:nvPr/>
+        </p:nvSpPr>
+        <p:spPr>
+          <a:xfrm xmlns:a="http://schemas.openxmlformats.org/drawingml/2006/main">
+            <a:off x="8039100" y="3829050"/>
             <a:ext cx="2952750" cy="345281"/>
           </a:xfrm>
           <a:prstGeom xmlns:a="http://schemas.openxmlformats.org/drawingml/2006/main" prst="rect">
@@ -16348,28 +16822,202 @@
                 <a:ea typeface="Apple SD Gothic Neo"/>
                 <a:cs typeface="Apple SD Gothic Neo"/>
               </a:rPr>
-              <a:t>수정 전후 결과</a:t>
-            </a:r>
-          </a:p>
-        </p:txBody>
-      </p:sp>
-      <p:sp>
-        <p:nvSpPr>
-          <p:cNvPr id="29" name="dp45-background / n24 / text 1">
-            <a:extLst xmlns:a="http://schemas.openxmlformats.org/drawingml/2006/main">
-              <a:ext uri="{FF2B5EF4-FFF2-40B4-BE49-F238E27FC236}">
-                <a16:creationId xmlns:a16="http://schemas.microsoft.com/office/drawing/2014/main" id="{67FDBDAB-8FB2-411B-B009-A2BCE29E132A}"/>
-              </a:ext>
-            </a:extLst>
-          </p:cNvPr>
-          <p:cNvSpPr>
-            <a:spLocks xmlns:a="http://schemas.openxmlformats.org/drawingml/2006/main" noGrp="1"/>
-          </p:cNvSpPr>
-          <p:nvPr/>
-        </p:nvSpPr>
-        <p:spPr>
-          <a:xfrm xmlns:a="http://schemas.openxmlformats.org/drawingml/2006/main">
-            <a:off x="4419600" y="3838575"/>
+              <a:t>다른 Downstream Agent</a:t>
+            </a:r>
+          </a:p>
+        </p:txBody>
+      </p:sp>
+      <p:sp>
+        <p:nvSpPr>
+          <p:cNvPr id="37" name="dp45-background / n29 / text 2">
+            <a:extLst xmlns:a="http://schemas.openxmlformats.org/drawingml/2006/main">
+              <a:ext uri="{FF2B5EF4-FFF2-40B4-BE49-F238E27FC236}">
+                <a16:creationId xmlns:a16="http://schemas.microsoft.com/office/drawing/2014/main" id="{6E758223-02A5-4674-B438-6AD4648B590E}"/>
+              </a:ext>
+            </a:extLst>
+          </p:cNvPr>
+          <p:cNvSpPr>
+            <a:spLocks xmlns:a="http://schemas.openxmlformats.org/drawingml/2006/main" noGrp="1"/>
+          </p:cNvSpPr>
+          <p:nvPr/>
+        </p:nvSpPr>
+        <p:spPr>
+          <a:xfrm xmlns:a="http://schemas.openxmlformats.org/drawingml/2006/main">
+            <a:off x="8039100" y="4181475"/>
+            <a:ext cx="2952750" cy="345281"/>
+          </a:xfrm>
+          <a:prstGeom xmlns:a="http://schemas.openxmlformats.org/drawingml/2006/main" prst="rect">
+            <a:avLst/>
+          </a:prstGeom>
+          <a:noFill xmlns:a="http://schemas.openxmlformats.org/drawingml/2006/main"/>
+          <a:ln xmlns:a="http://schemas.openxmlformats.org/drawingml/2006/main" w="0">
+            <a:noFill/>
+            <a:prstDash val="solid"/>
+          </a:ln>
+        </p:spPr>
+        <p:txBody>
+          <a:bodyPr xmlns:a="http://schemas.openxmlformats.org/drawingml/2006/main" wrap="none" lIns="0" tIns="0" rIns="0" bIns="0" anchor="t">
+            <a:noAutofit/>
+          </a:bodyPr>
+          <a:lstStyle xmlns:a="http://schemas.openxmlformats.org/drawingml/2006/main"/>
+          <a:p xmlns:a="http://schemas.openxmlformats.org/drawingml/2006/main">
+            <a:pPr algn="l">
+              <a:defRPr sz="1875" b="1">
+                <a:solidFill>
+                  <a:srgbClr val="18232E"/>
+                </a:solidFill>
+                <a:latin typeface="Apple SD Gothic Neo"/>
+                <a:ea typeface="Apple SD Gothic Neo"/>
+                <a:cs typeface="Apple SD Gothic Neo"/>
+              </a:defRPr>
+            </a:pPr>
+            <a:r>
+              <a:rPr sz="1875" b="1">
+                <a:solidFill>
+                  <a:srgbClr val="18232E"/>
+                </a:solidFill>
+                <a:latin typeface="Apple SD Gothic Neo"/>
+                <a:ea typeface="Apple SD Gothic Neo"/>
+                <a:cs typeface="Apple SD Gothic Neo"/>
+              </a:rPr>
+              <a:t>견적 업무 수행</a:t>
+            </a:r>
+          </a:p>
+        </p:txBody>
+      </p:sp>
+      <p:sp>
+        <p:nvSpPr>
+          <p:cNvPr id="38" name="dp45-background / n30 / text 1">
+            <a:extLst xmlns:a="http://schemas.openxmlformats.org/drawingml/2006/main">
+              <a:ext uri="{FF2B5EF4-FFF2-40B4-BE49-F238E27FC236}">
+                <a16:creationId xmlns:a16="http://schemas.microsoft.com/office/drawing/2014/main" id="{17C51896-C4D6-4D87-AEE6-50C7AA933B4B}"/>
+              </a:ext>
+            </a:extLst>
+          </p:cNvPr>
+          <p:cNvSpPr>
+            <a:spLocks xmlns:a="http://schemas.openxmlformats.org/drawingml/2006/main" noGrp="1"/>
+          </p:cNvSpPr>
+          <p:nvPr/>
+        </p:nvSpPr>
+        <p:spPr>
+          <a:xfrm xmlns:a="http://schemas.openxmlformats.org/drawingml/2006/main">
+            <a:off x="8039100" y="4714875"/>
+            <a:ext cx="2952750" cy="317659"/>
+          </a:xfrm>
+          <a:prstGeom xmlns:a="http://schemas.openxmlformats.org/drawingml/2006/main" prst="rect">
+            <a:avLst/>
+          </a:prstGeom>
+          <a:noFill xmlns:a="http://schemas.openxmlformats.org/drawingml/2006/main"/>
+          <a:ln xmlns:a="http://schemas.openxmlformats.org/drawingml/2006/main" w="0">
+            <a:noFill/>
+            <a:prstDash val="solid"/>
+          </a:ln>
+        </p:spPr>
+        <p:txBody>
+          <a:bodyPr xmlns:a="http://schemas.openxmlformats.org/drawingml/2006/main" wrap="none" lIns="0" tIns="0" rIns="0" bIns="0" anchor="t">
+            <a:noAutofit/>
+          </a:bodyPr>
+          <a:lstStyle xmlns:a="http://schemas.openxmlformats.org/drawingml/2006/main"/>
+          <a:p xmlns:a="http://schemas.openxmlformats.org/drawingml/2006/main">
+            <a:pPr algn="l">
+              <a:defRPr sz="1725" b="1">
+                <a:solidFill>
+                  <a:srgbClr val="087E8B"/>
+                </a:solidFill>
+                <a:latin typeface="Apple SD Gothic Neo"/>
+                <a:ea typeface="Apple SD Gothic Neo"/>
+                <a:cs typeface="Apple SD Gothic Neo"/>
+              </a:defRPr>
+            </a:pPr>
+            <a:r>
+              <a:rPr sz="1725" b="1">
+                <a:solidFill>
+                  <a:srgbClr val="087E8B"/>
+                </a:solidFill>
+                <a:latin typeface="Apple SD Gothic Neo"/>
+                <a:ea typeface="Apple SD Gothic Neo"/>
+                <a:cs typeface="Apple SD Gothic Neo"/>
+              </a:rPr>
+              <a:t>VIA가 확인한 결과 참조</a:t>
+            </a:r>
+          </a:p>
+        </p:txBody>
+      </p:sp>
+      <p:sp>
+        <p:nvSpPr>
+          <p:cNvPr id="39" name="dp45-background / n30 / text 2">
+            <a:extLst xmlns:a="http://schemas.openxmlformats.org/drawingml/2006/main">
+              <a:ext uri="{FF2B5EF4-FFF2-40B4-BE49-F238E27FC236}">
+                <a16:creationId xmlns:a16="http://schemas.microsoft.com/office/drawing/2014/main" id="{C81C1B3C-7287-4846-A0EA-F9A970C84BBD}"/>
+              </a:ext>
+            </a:extLst>
+          </p:cNvPr>
+          <p:cNvSpPr>
+            <a:spLocks xmlns:a="http://schemas.openxmlformats.org/drawingml/2006/main" noGrp="1"/>
+          </p:cNvSpPr>
+          <p:nvPr/>
+        </p:nvSpPr>
+        <p:spPr>
+          <a:xfrm xmlns:a="http://schemas.openxmlformats.org/drawingml/2006/main">
+            <a:off x="8039100" y="5038725"/>
+            <a:ext cx="2952750" cy="317659"/>
+          </a:xfrm>
+          <a:prstGeom xmlns:a="http://schemas.openxmlformats.org/drawingml/2006/main" prst="rect">
+            <a:avLst/>
+          </a:prstGeom>
+          <a:noFill xmlns:a="http://schemas.openxmlformats.org/drawingml/2006/main"/>
+          <a:ln xmlns:a="http://schemas.openxmlformats.org/drawingml/2006/main" w="0">
+            <a:noFill/>
+            <a:prstDash val="solid"/>
+          </a:ln>
+        </p:spPr>
+        <p:txBody>
+          <a:bodyPr xmlns:a="http://schemas.openxmlformats.org/drawingml/2006/main" wrap="none" lIns="0" tIns="0" rIns="0" bIns="0" anchor="t">
+            <a:noAutofit/>
+          </a:bodyPr>
+          <a:lstStyle xmlns:a="http://schemas.openxmlformats.org/drawingml/2006/main"/>
+          <a:p xmlns:a="http://schemas.openxmlformats.org/drawingml/2006/main">
+            <a:pPr algn="l">
+              <a:defRPr sz="1725" b="1">
+                <a:solidFill>
+                  <a:srgbClr val="087E8B"/>
+                </a:solidFill>
+                <a:latin typeface="Apple SD Gothic Neo"/>
+                <a:ea typeface="Apple SD Gothic Neo"/>
+                <a:cs typeface="Apple SD Gothic Neo"/>
+              </a:defRPr>
+            </a:pPr>
+            <a:r>
+              <a:rPr sz="1725" b="1">
+                <a:solidFill>
+                  <a:srgbClr val="087E8B"/>
+                </a:solidFill>
+                <a:latin typeface="Apple SD Gothic Neo"/>
+                <a:ea typeface="Apple SD Gothic Neo"/>
+                <a:cs typeface="Apple SD Gothic Neo"/>
+              </a:rPr>
+              <a:t>D22@v1</a:t>
+            </a:r>
+          </a:p>
+        </p:txBody>
+      </p:sp>
+      <p:sp>
+        <p:nvSpPr>
+          <p:cNvPr id="40" name="dp45-background / n31 / text 1">
+            <a:extLst xmlns:a="http://schemas.openxmlformats.org/drawingml/2006/main">
+              <a:ext uri="{FF2B5EF4-FFF2-40B4-BE49-F238E27FC236}">
+                <a16:creationId xmlns:a16="http://schemas.microsoft.com/office/drawing/2014/main" id="{09A236DD-D780-4408-BD0B-17BCD4B7C657}"/>
+              </a:ext>
+            </a:extLst>
+          </p:cNvPr>
+          <p:cNvSpPr>
+            <a:spLocks xmlns:a="http://schemas.openxmlformats.org/drawingml/2006/main" noGrp="1"/>
+          </p:cNvSpPr>
+          <p:nvPr/>
+        </p:nvSpPr>
+        <p:spPr>
+          <a:xfrm xmlns:a="http://schemas.openxmlformats.org/drawingml/2006/main">
+            <a:off x="8039100" y="5524500"/>
             <a:ext cx="2952750" cy="262414"/>
           </a:xfrm>
           <a:prstGeom xmlns:a="http://schemas.openxmlformats.org/drawingml/2006/main" prst="rect">
@@ -16406,489 +17054,43 @@
                 <a:ea typeface="Apple SD Gothic Neo"/>
                 <a:cs typeface="Apple SD Gothic Neo"/>
               </a:rPr>
-              <a:t>수정 전</a:t>
-            </a:r>
-          </a:p>
-        </p:txBody>
-      </p:sp>
-      <p:sp>
-        <p:nvSpPr>
-          <p:cNvPr id="30" name="dp45-background / n25 / text 1">
-            <a:extLst xmlns:a="http://schemas.openxmlformats.org/drawingml/2006/main">
-              <a:ext uri="{FF2B5EF4-FFF2-40B4-BE49-F238E27FC236}">
-                <a16:creationId xmlns:a16="http://schemas.microsoft.com/office/drawing/2014/main" id="{5C25DE5B-2FBC-4461-82A2-172A40B7C5F4}"/>
-              </a:ext>
-            </a:extLst>
-          </p:cNvPr>
-          <p:cNvSpPr>
-            <a:spLocks xmlns:a="http://schemas.openxmlformats.org/drawingml/2006/main" noGrp="1"/>
-          </p:cNvSpPr>
-          <p:nvPr/>
-        </p:nvSpPr>
-        <p:spPr>
-          <a:xfrm xmlns:a="http://schemas.openxmlformats.org/drawingml/2006/main">
-            <a:off x="4419600" y="4162425"/>
-            <a:ext cx="2952750" cy="317659"/>
-          </a:xfrm>
-          <a:prstGeom xmlns:a="http://schemas.openxmlformats.org/drawingml/2006/main" prst="rect">
-            <a:avLst/>
-          </a:prstGeom>
-          <a:noFill xmlns:a="http://schemas.openxmlformats.org/drawingml/2006/main"/>
-          <a:ln xmlns:a="http://schemas.openxmlformats.org/drawingml/2006/main" w="0">
-            <a:noFill/>
-            <a:prstDash val="solid"/>
-          </a:ln>
-        </p:spPr>
-        <p:txBody>
-          <a:bodyPr xmlns:a="http://schemas.openxmlformats.org/drawingml/2006/main" wrap="none" lIns="0" tIns="0" rIns="0" bIns="0" anchor="t">
-            <a:noAutofit/>
-          </a:bodyPr>
-          <a:lstStyle xmlns:a="http://schemas.openxmlformats.org/drawingml/2006/main"/>
-          <a:p xmlns:a="http://schemas.openxmlformats.org/drawingml/2006/main">
-            <a:pPr algn="l">
-              <a:defRPr sz="1725" b="0">
-                <a:solidFill>
-                  <a:srgbClr val="5F6B77"/>
-                </a:solidFill>
-                <a:latin typeface="Apple SD Gothic Neo"/>
-                <a:ea typeface="Apple SD Gothic Neo"/>
-                <a:cs typeface="Apple SD Gothic Neo"/>
-              </a:defRPr>
-            </a:pPr>
-            <a:r>
-              <a:rPr sz="1725" b="0">
-                <a:solidFill>
-                  <a:srgbClr val="5F6B77"/>
-                </a:solidFill>
-                <a:latin typeface="Apple SD Gothic Neo"/>
-                <a:ea typeface="Apple SD Gothic Neo"/>
-                <a:cs typeface="Apple SD Gothic Neo"/>
-              </a:rPr>
-              <a:t>배경 설명 … 결론</a:t>
-            </a:r>
-          </a:p>
-        </p:txBody>
-      </p:sp>
-      <p:sp>
-        <p:nvSpPr>
-          <p:cNvPr id="31" name="dp45-background / n26 / path">
-            <a:extLst xmlns:a="http://schemas.openxmlformats.org/drawingml/2006/main">
-              <a:ext uri="{FF2B5EF4-FFF2-40B4-BE49-F238E27FC236}">
-                <a16:creationId xmlns:a16="http://schemas.microsoft.com/office/drawing/2014/main" id="{C23378C0-3CAC-40E5-8EBA-A8ED2C800585}"/>
-              </a:ext>
-            </a:extLst>
-          </p:cNvPr>
-          <p:cNvSpPr>
-            <a:spLocks xmlns:a="http://schemas.openxmlformats.org/drawingml/2006/main" noGrp="1"/>
-          </p:cNvSpPr>
-          <p:nvPr/>
-        </p:nvSpPr>
-        <p:spPr>
-          <a:xfrm xmlns:a="http://schemas.openxmlformats.org/drawingml/2006/main">
-            <a:off x="4419600" y="4581525"/>
-            <a:ext cx="2952750" cy="953"/>
+              <a:t>C22 대화에 연결</a:t>
+            </a:r>
+          </a:p>
+        </p:txBody>
+      </p:sp>
+      <p:sp>
+        <p:nvSpPr>
+          <p:cNvPr id="41" name="dp45-background / n32 / path">
+            <a:extLst xmlns:a="http://schemas.openxmlformats.org/drawingml/2006/main">
+              <a:ext uri="{FF2B5EF4-FFF2-40B4-BE49-F238E27FC236}">
+                <a16:creationId xmlns:a16="http://schemas.microsoft.com/office/drawing/2014/main" id="{4F24B2B2-CCB9-45D8-BD65-F7E333C326F9}"/>
+              </a:ext>
+            </a:extLst>
+          </p:cNvPr>
+          <p:cNvSpPr>
+            <a:spLocks xmlns:a="http://schemas.openxmlformats.org/drawingml/2006/main" noGrp="1"/>
+          </p:cNvSpPr>
+          <p:nvPr/>
+        </p:nvSpPr>
+        <p:spPr>
+          <a:xfrm xmlns:a="http://schemas.openxmlformats.org/drawingml/2006/main">
+            <a:off x="3962400" y="3495675"/>
+            <a:ext cx="247650" cy="953"/>
           </a:xfrm>
           <a:custGeom xmlns:a="http://schemas.openxmlformats.org/drawingml/2006/main">
             <a:pathLst>
-              <a:path w="2952750" h="953">
+              <a:path w="247650" h="953">
                 <a:moveTo>
                   <a:pt x="0" y="0"/>
                 </a:moveTo>
                 <a:lnTo>
-                  <a:pt x="2952750" y="0"/>
+                  <a:pt x="247650" y="0"/>
                 </a:lnTo>
               </a:path>
             </a:pathLst>
           </a:custGeom>
           <a:noFill xmlns:a="http://schemas.openxmlformats.org/drawingml/2006/main"/>
-          <a:ln xmlns:a="http://schemas.openxmlformats.org/drawingml/2006/main" w="9525">
-            <a:solidFill>
-              <a:srgbClr val="CDD6DE"/>
-            </a:solidFill>
-            <a:prstDash val="solid"/>
-          </a:ln>
-        </p:spPr>
-      </p:sp>
-      <p:sp>
-        <p:nvSpPr>
-          <p:cNvPr id="32" name="dp45-background / n27 / text 1">
-            <a:extLst xmlns:a="http://schemas.openxmlformats.org/drawingml/2006/main">
-              <a:ext uri="{FF2B5EF4-FFF2-40B4-BE49-F238E27FC236}">
-                <a16:creationId xmlns:a16="http://schemas.microsoft.com/office/drawing/2014/main" id="{62B22F3A-EDF5-4A97-98DD-94CAD3510728}"/>
-              </a:ext>
-            </a:extLst>
-          </p:cNvPr>
-          <p:cNvSpPr>
-            <a:spLocks xmlns:a="http://schemas.openxmlformats.org/drawingml/2006/main" noGrp="1"/>
-          </p:cNvSpPr>
-          <p:nvPr/>
-        </p:nvSpPr>
-        <p:spPr>
-          <a:xfrm xmlns:a="http://schemas.openxmlformats.org/drawingml/2006/main">
-            <a:off x="4419600" y="4819650"/>
-            <a:ext cx="2952750" cy="262414"/>
-          </a:xfrm>
-          <a:prstGeom xmlns:a="http://schemas.openxmlformats.org/drawingml/2006/main" prst="rect">
-            <a:avLst/>
-          </a:prstGeom>
-          <a:noFill xmlns:a="http://schemas.openxmlformats.org/drawingml/2006/main"/>
-          <a:ln xmlns:a="http://schemas.openxmlformats.org/drawingml/2006/main" w="0">
-            <a:noFill/>
-            <a:prstDash val="solid"/>
-          </a:ln>
-        </p:spPr>
-        <p:txBody>
-          <a:bodyPr xmlns:a="http://schemas.openxmlformats.org/drawingml/2006/main" wrap="none" lIns="0" tIns="0" rIns="0" bIns="0" anchor="t">
-            <a:noAutofit/>
-          </a:bodyPr>
-          <a:lstStyle xmlns:a="http://schemas.openxmlformats.org/drawingml/2006/main"/>
-          <a:p xmlns:a="http://schemas.openxmlformats.org/drawingml/2006/main">
-            <a:pPr algn="l">
-              <a:defRPr sz="1425" b="0">
-                <a:solidFill>
-                  <a:srgbClr val="087E8B"/>
-                </a:solidFill>
-                <a:latin typeface="Apple SD Gothic Neo"/>
-                <a:ea typeface="Apple SD Gothic Neo"/>
-                <a:cs typeface="Apple SD Gothic Neo"/>
-              </a:defRPr>
-            </a:pPr>
-            <a:r>
-              <a:rPr sz="1425" b="0">
-                <a:solidFill>
-                  <a:srgbClr val="087E8B"/>
-                </a:solidFill>
-                <a:latin typeface="Apple SD Gothic Neo"/>
-                <a:ea typeface="Apple SD Gothic Neo"/>
-                <a:cs typeface="Apple SD Gothic Neo"/>
-              </a:rPr>
-              <a:t>수정 후</a:t>
-            </a:r>
-          </a:p>
-        </p:txBody>
-      </p:sp>
-      <p:sp>
-        <p:nvSpPr>
-          <p:cNvPr id="33" name="dp45-background / n28 / text 1">
-            <a:extLst xmlns:a="http://schemas.openxmlformats.org/drawingml/2006/main">
-              <a:ext uri="{FF2B5EF4-FFF2-40B4-BE49-F238E27FC236}">
-                <a16:creationId xmlns:a16="http://schemas.microsoft.com/office/drawing/2014/main" id="{A80516C2-2AFB-4BFE-ACB6-2D10239D840D}"/>
-              </a:ext>
-            </a:extLst>
-          </p:cNvPr>
-          <p:cNvSpPr>
-            <a:spLocks xmlns:a="http://schemas.openxmlformats.org/drawingml/2006/main" noGrp="1"/>
-          </p:cNvSpPr>
-          <p:nvPr/>
-        </p:nvSpPr>
-        <p:spPr>
-          <a:xfrm xmlns:a="http://schemas.openxmlformats.org/drawingml/2006/main">
-            <a:off x="4419600" y="5219700"/>
-            <a:ext cx="2952750" cy="345281"/>
-          </a:xfrm>
-          <a:prstGeom xmlns:a="http://schemas.openxmlformats.org/drawingml/2006/main" prst="rect">
-            <a:avLst/>
-          </a:prstGeom>
-          <a:noFill xmlns:a="http://schemas.openxmlformats.org/drawingml/2006/main"/>
-          <a:ln xmlns:a="http://schemas.openxmlformats.org/drawingml/2006/main" w="0">
-            <a:noFill/>
-            <a:prstDash val="solid"/>
-          </a:ln>
-        </p:spPr>
-        <p:txBody>
-          <a:bodyPr xmlns:a="http://schemas.openxmlformats.org/drawingml/2006/main" wrap="none" lIns="0" tIns="0" rIns="0" bIns="0" anchor="t">
-            <a:noAutofit/>
-          </a:bodyPr>
-          <a:lstStyle xmlns:a="http://schemas.openxmlformats.org/drawingml/2006/main"/>
-          <a:p xmlns:a="http://schemas.openxmlformats.org/drawingml/2006/main">
-            <a:pPr algn="l">
-              <a:defRPr sz="1875" b="1">
-                <a:solidFill>
-                  <a:srgbClr val="087E8B"/>
-                </a:solidFill>
-                <a:latin typeface="Apple SD Gothic Neo"/>
-                <a:ea typeface="Apple SD Gothic Neo"/>
-                <a:cs typeface="Apple SD Gothic Neo"/>
-              </a:defRPr>
-            </a:pPr>
-            <a:r>
-              <a:rPr sz="1875" b="1">
-                <a:solidFill>
-                  <a:srgbClr val="087E8B"/>
-                </a:solidFill>
-                <a:latin typeface="Apple SD Gothic Neo"/>
-                <a:ea typeface="Apple SD Gothic Neo"/>
-                <a:cs typeface="Apple SD Gothic Neo"/>
-              </a:rPr>
-              <a:t>결론 먼저 / 짧은 문장</a:t>
-            </a:r>
-          </a:p>
-        </p:txBody>
-      </p:sp>
-      <p:sp>
-        <p:nvSpPr>
-          <p:cNvPr id="34" name="dp45-background / n29 / text 1">
-            <a:extLst xmlns:a="http://schemas.openxmlformats.org/drawingml/2006/main">
-              <a:ext uri="{FF2B5EF4-FFF2-40B4-BE49-F238E27FC236}">
-                <a16:creationId xmlns:a16="http://schemas.microsoft.com/office/drawing/2014/main" id="{ADB5249F-A936-488D-8378-ACF0D11C689C}"/>
-              </a:ext>
-            </a:extLst>
-          </p:cNvPr>
-          <p:cNvSpPr>
-            <a:spLocks xmlns:a="http://schemas.openxmlformats.org/drawingml/2006/main" noGrp="1"/>
-          </p:cNvSpPr>
-          <p:nvPr/>
-        </p:nvSpPr>
-        <p:spPr>
-          <a:xfrm xmlns:a="http://schemas.openxmlformats.org/drawingml/2006/main">
-            <a:off x="8039100" y="3305175"/>
-            <a:ext cx="2952750" cy="345281"/>
-          </a:xfrm>
-          <a:prstGeom xmlns:a="http://schemas.openxmlformats.org/drawingml/2006/main" prst="rect">
-            <a:avLst/>
-          </a:prstGeom>
-          <a:noFill xmlns:a="http://schemas.openxmlformats.org/drawingml/2006/main"/>
-          <a:ln xmlns:a="http://schemas.openxmlformats.org/drawingml/2006/main" w="0">
-            <a:noFill/>
-            <a:prstDash val="solid"/>
-          </a:ln>
-        </p:spPr>
-        <p:txBody>
-          <a:bodyPr xmlns:a="http://schemas.openxmlformats.org/drawingml/2006/main" wrap="none" lIns="0" tIns="0" rIns="0" bIns="0" anchor="t">
-            <a:noAutofit/>
-          </a:bodyPr>
-          <a:lstStyle xmlns:a="http://schemas.openxmlformats.org/drawingml/2006/main"/>
-          <a:p xmlns:a="http://schemas.openxmlformats.org/drawingml/2006/main">
-            <a:pPr algn="l">
-              <a:defRPr sz="1875" b="1">
-                <a:solidFill>
-                  <a:srgbClr val="18232E"/>
-                </a:solidFill>
-                <a:latin typeface="Apple SD Gothic Neo"/>
-                <a:ea typeface="Apple SD Gothic Neo"/>
-                <a:cs typeface="Apple SD Gothic Neo"/>
-              </a:defRPr>
-            </a:pPr>
-            <a:r>
-              <a:rPr sz="1875" b="1">
-                <a:solidFill>
-                  <a:srgbClr val="18232E"/>
-                </a:solidFill>
-                <a:latin typeface="Apple SD Gothic Neo"/>
-                <a:ea typeface="Apple SD Gothic Neo"/>
-                <a:cs typeface="Apple SD Gothic Neo"/>
-              </a:rPr>
-              <a:t>실제 전달 기록</a:t>
-            </a:r>
-          </a:p>
-        </p:txBody>
-      </p:sp>
-      <p:sp>
-        <p:nvSpPr>
-          <p:cNvPr id="35" name="dp45-background / n30 / text 1">
-            <a:extLst xmlns:a="http://schemas.openxmlformats.org/drawingml/2006/main">
-              <a:ext uri="{FF2B5EF4-FFF2-40B4-BE49-F238E27FC236}">
-                <a16:creationId xmlns:a16="http://schemas.microsoft.com/office/drawing/2014/main" id="{B791E7E2-5D2A-4B8B-8B4E-6A1D291DB1D1}"/>
-              </a:ext>
-            </a:extLst>
-          </p:cNvPr>
-          <p:cNvSpPr>
-            <a:spLocks xmlns:a="http://schemas.openxmlformats.org/drawingml/2006/main" noGrp="1"/>
-          </p:cNvSpPr>
-          <p:nvPr/>
-        </p:nvSpPr>
-        <p:spPr>
-          <a:xfrm xmlns:a="http://schemas.openxmlformats.org/drawingml/2006/main">
-            <a:off x="8039100" y="3924300"/>
-            <a:ext cx="2952750" cy="372904"/>
-          </a:xfrm>
-          <a:prstGeom xmlns:a="http://schemas.openxmlformats.org/drawingml/2006/main" prst="rect">
-            <a:avLst/>
-          </a:prstGeom>
-          <a:noFill xmlns:a="http://schemas.openxmlformats.org/drawingml/2006/main"/>
-          <a:ln xmlns:a="http://schemas.openxmlformats.org/drawingml/2006/main" w="0">
-            <a:noFill/>
-            <a:prstDash val="solid"/>
-          </a:ln>
-        </p:spPr>
-        <p:txBody>
-          <a:bodyPr xmlns:a="http://schemas.openxmlformats.org/drawingml/2006/main" wrap="none" lIns="0" tIns="0" rIns="0" bIns="0" anchor="t">
-            <a:noAutofit/>
-          </a:bodyPr>
-          <a:lstStyle xmlns:a="http://schemas.openxmlformats.org/drawingml/2006/main"/>
-          <a:p xmlns:a="http://schemas.openxmlformats.org/drawingml/2006/main">
-            <a:pPr algn="l">
-              <a:defRPr sz="2025" b="1">
-                <a:solidFill>
-                  <a:srgbClr val="087E8B"/>
-                </a:solidFill>
-                <a:latin typeface="Apple SD Gothic Neo"/>
-                <a:ea typeface="Apple SD Gothic Neo"/>
-                <a:cs typeface="Apple SD Gothic Neo"/>
-              </a:defRPr>
-            </a:pPr>
-            <a:r>
-              <a:rPr sz="2025" b="1">
-                <a:solidFill>
-                  <a:srgbClr val="087E8B"/>
-                </a:solidFill>
-                <a:latin typeface="Apple SD Gothic Neo"/>
-                <a:ea typeface="Apple SD Gothic Neo"/>
-                <a:cs typeface="Apple SD Gothic Neo"/>
-              </a:rPr>
-              <a:t>수정 후 결과 전달</a:t>
-            </a:r>
-          </a:p>
-        </p:txBody>
-      </p:sp>
-      <p:sp>
-        <p:nvSpPr>
-          <p:cNvPr id="36" name="dp45-background / n31 / text 1">
-            <a:extLst xmlns:a="http://schemas.openxmlformats.org/drawingml/2006/main">
-              <a:ext uri="{FF2B5EF4-FFF2-40B4-BE49-F238E27FC236}">
-                <a16:creationId xmlns:a16="http://schemas.microsoft.com/office/drawing/2014/main" id="{8A754043-48D8-491B-BA62-C3D813AB902A}"/>
-              </a:ext>
-            </a:extLst>
-          </p:cNvPr>
-          <p:cNvSpPr>
-            <a:spLocks xmlns:a="http://schemas.openxmlformats.org/drawingml/2006/main" noGrp="1"/>
-          </p:cNvSpPr>
-          <p:nvPr/>
-        </p:nvSpPr>
-        <p:spPr>
-          <a:xfrm xmlns:a="http://schemas.openxmlformats.org/drawingml/2006/main">
-            <a:off x="8039100" y="4676775"/>
-            <a:ext cx="2952750" cy="317659"/>
-          </a:xfrm>
-          <a:prstGeom xmlns:a="http://schemas.openxmlformats.org/drawingml/2006/main" prst="rect">
-            <a:avLst/>
-          </a:prstGeom>
-          <a:noFill xmlns:a="http://schemas.openxmlformats.org/drawingml/2006/main"/>
-          <a:ln xmlns:a="http://schemas.openxmlformats.org/drawingml/2006/main" w="0">
-            <a:noFill/>
-            <a:prstDash val="solid"/>
-          </a:ln>
-        </p:spPr>
-        <p:txBody>
-          <a:bodyPr xmlns:a="http://schemas.openxmlformats.org/drawingml/2006/main" wrap="none" lIns="0" tIns="0" rIns="0" bIns="0" anchor="t">
-            <a:noAutofit/>
-          </a:bodyPr>
-          <a:lstStyle xmlns:a="http://schemas.openxmlformats.org/drawingml/2006/main"/>
-          <a:p xmlns:a="http://schemas.openxmlformats.org/drawingml/2006/main">
-            <a:pPr algn="l">
-              <a:defRPr sz="1725" b="0">
-                <a:solidFill>
-                  <a:srgbClr val="5F6B77"/>
-                </a:solidFill>
-                <a:latin typeface="Apple SD Gothic Neo"/>
-                <a:ea typeface="Apple SD Gothic Neo"/>
-                <a:cs typeface="Apple SD Gothic Neo"/>
-              </a:defRPr>
-            </a:pPr>
-            <a:r>
-              <a:rPr sz="1725" b="0">
-                <a:solidFill>
-                  <a:srgbClr val="5F6B77"/>
-                </a:solidFill>
-                <a:latin typeface="Apple SD Gothic Neo"/>
-                <a:ea typeface="Apple SD Gothic Neo"/>
-                <a:cs typeface="Apple SD Gothic Neo"/>
-              </a:rPr>
-              <a:t>어느 결과 버전을</a:t>
-            </a:r>
-          </a:p>
-        </p:txBody>
-      </p:sp>
-      <p:sp>
-        <p:nvSpPr>
-          <p:cNvPr id="37" name="dp45-background / n31 / text 2">
-            <a:extLst xmlns:a="http://schemas.openxmlformats.org/drawingml/2006/main">
-              <a:ext uri="{FF2B5EF4-FFF2-40B4-BE49-F238E27FC236}">
-                <a16:creationId xmlns:a16="http://schemas.microsoft.com/office/drawing/2014/main" id="{C12BA2F3-A907-4B11-BA5F-B015D4F4A5B7}"/>
-              </a:ext>
-            </a:extLst>
-          </p:cNvPr>
-          <p:cNvSpPr>
-            <a:spLocks xmlns:a="http://schemas.openxmlformats.org/drawingml/2006/main" noGrp="1"/>
-          </p:cNvSpPr>
-          <p:nvPr/>
-        </p:nvSpPr>
-        <p:spPr>
-          <a:xfrm xmlns:a="http://schemas.openxmlformats.org/drawingml/2006/main">
-            <a:off x="8039100" y="5000625"/>
-            <a:ext cx="2952750" cy="317659"/>
-          </a:xfrm>
-          <a:prstGeom xmlns:a="http://schemas.openxmlformats.org/drawingml/2006/main" prst="rect">
-            <a:avLst/>
-          </a:prstGeom>
-          <a:noFill xmlns:a="http://schemas.openxmlformats.org/drawingml/2006/main"/>
-          <a:ln xmlns:a="http://schemas.openxmlformats.org/drawingml/2006/main" w="0">
-            <a:noFill/>
-            <a:prstDash val="solid"/>
-          </a:ln>
-        </p:spPr>
-        <p:txBody>
-          <a:bodyPr xmlns:a="http://schemas.openxmlformats.org/drawingml/2006/main" wrap="none" lIns="0" tIns="0" rIns="0" bIns="0" anchor="t">
-            <a:noAutofit/>
-          </a:bodyPr>
-          <a:lstStyle xmlns:a="http://schemas.openxmlformats.org/drawingml/2006/main"/>
-          <a:p xmlns:a="http://schemas.openxmlformats.org/drawingml/2006/main">
-            <a:pPr algn="l">
-              <a:defRPr sz="1725" b="0">
-                <a:solidFill>
-                  <a:srgbClr val="5F6B77"/>
-                </a:solidFill>
-                <a:latin typeface="Apple SD Gothic Neo"/>
-                <a:ea typeface="Apple SD Gothic Neo"/>
-                <a:cs typeface="Apple SD Gothic Neo"/>
-              </a:defRPr>
-            </a:pPr>
-            <a:r>
-              <a:rPr sz="1725" b="0">
-                <a:solidFill>
-                  <a:srgbClr val="5F6B77"/>
-                </a:solidFill>
-                <a:latin typeface="Apple SD Gothic Neo"/>
-                <a:ea typeface="Apple SD Gothic Neo"/>
-                <a:cs typeface="Apple SD Gothic Neo"/>
-              </a:rPr>
-              <a:t>실제로 받았는지 확인</a:t>
-            </a:r>
-          </a:p>
-        </p:txBody>
-      </p:sp>
-      <p:sp>
-        <p:nvSpPr>
-          <p:cNvPr id="38" name="dp45-background / n32 / path">
-            <a:extLst xmlns:a="http://schemas.openxmlformats.org/drawingml/2006/main">
-              <a:ext uri="{FF2B5EF4-FFF2-40B4-BE49-F238E27FC236}">
-                <a16:creationId xmlns:a16="http://schemas.microsoft.com/office/drawing/2014/main" id="{73DE7326-08B3-4F03-B72C-23A306950F4D}"/>
-              </a:ext>
-            </a:extLst>
-          </p:cNvPr>
-          <p:cNvSpPr>
-            <a:spLocks xmlns:a="http://schemas.openxmlformats.org/drawingml/2006/main" noGrp="1"/>
-          </p:cNvSpPr>
-          <p:nvPr/>
-        </p:nvSpPr>
-        <p:spPr>
-          <a:xfrm xmlns:a="http://schemas.openxmlformats.org/drawingml/2006/main">
-            <a:off x="4029075" y="4486275"/>
-            <a:ext cx="114300" cy="953"/>
-          </a:xfrm>
-          <a:custGeom xmlns:a="http://schemas.openxmlformats.org/drawingml/2006/main">
-            <a:pathLst>
-              <a:path w="114300" h="953">
-                <a:moveTo>
-                  <a:pt x="0" y="0"/>
-                </a:moveTo>
-                <a:lnTo>
-                  <a:pt x="114300" y="0"/>
-                </a:lnTo>
-              </a:path>
-            </a:pathLst>
-          </a:custGeom>
-          <a:noFill xmlns:a="http://schemas.openxmlformats.org/drawingml/2006/main"/>
           <a:ln xmlns:a="http://schemas.openxmlformats.org/drawingml/2006/main" w="19050">
             <a:solidFill>
               <a:srgbClr val="5F6B77"/>
@@ -16899,21 +17101,21 @@
       </p:sp>
       <p:sp>
         <p:nvSpPr>
-          <p:cNvPr id="39" name="dp45-background / n32 / arrow">
-            <a:extLst xmlns:a="http://schemas.openxmlformats.org/drawingml/2006/main">
-              <a:ext uri="{FF2B5EF4-FFF2-40B4-BE49-F238E27FC236}">
-                <a16:creationId xmlns:a16="http://schemas.microsoft.com/office/drawing/2014/main" id="{8A13E14D-8B03-4106-BBA2-C3F48F8FD7FB}"/>
-              </a:ext>
-            </a:extLst>
-          </p:cNvPr>
-          <p:cNvSpPr>
-            <a:spLocks xmlns:a="http://schemas.openxmlformats.org/drawingml/2006/main" noGrp="1"/>
-          </p:cNvSpPr>
-          <p:nvPr/>
-        </p:nvSpPr>
-        <p:spPr>
-          <a:xfrm xmlns:a="http://schemas.openxmlformats.org/drawingml/2006/main">
-            <a:off x="4021455" y="4425315"/>
+          <p:cNvPr id="42" name="dp45-background / n32 / arrow">
+            <a:extLst xmlns:a="http://schemas.openxmlformats.org/drawingml/2006/main">
+              <a:ext uri="{FF2B5EF4-FFF2-40B4-BE49-F238E27FC236}">
+                <a16:creationId xmlns:a16="http://schemas.microsoft.com/office/drawing/2014/main" id="{4848B865-995F-47E3-82EF-8CFF95B3E0F0}"/>
+              </a:ext>
+            </a:extLst>
+          </p:cNvPr>
+          <p:cNvSpPr>
+            <a:spLocks xmlns:a="http://schemas.openxmlformats.org/drawingml/2006/main" noGrp="1"/>
+          </p:cNvSpPr>
+          <p:nvPr/>
+        </p:nvSpPr>
+        <p:spPr>
+          <a:xfrm xmlns:a="http://schemas.openxmlformats.org/drawingml/2006/main">
+            <a:off x="4088130" y="3434715"/>
             <a:ext cx="121920" cy="121920"/>
           </a:xfrm>
           <a:custGeom xmlns:a="http://schemas.openxmlformats.org/drawingml/2006/main">
@@ -16942,31 +17144,31 @@
       </p:sp>
       <p:sp>
         <p:nvSpPr>
-          <p:cNvPr id="40" name="dp45-background / n33 / path">
-            <a:extLst xmlns:a="http://schemas.openxmlformats.org/drawingml/2006/main">
-              <a:ext uri="{FF2B5EF4-FFF2-40B4-BE49-F238E27FC236}">
-                <a16:creationId xmlns:a16="http://schemas.microsoft.com/office/drawing/2014/main" id="{3EE2062A-59FF-4DD5-B3CF-B1F9B11F5BE3}"/>
-              </a:ext>
-            </a:extLst>
-          </p:cNvPr>
-          <p:cNvSpPr>
-            <a:spLocks xmlns:a="http://schemas.openxmlformats.org/drawingml/2006/main" noGrp="1"/>
-          </p:cNvSpPr>
-          <p:nvPr/>
-        </p:nvSpPr>
-        <p:spPr>
-          <a:xfrm xmlns:a="http://schemas.openxmlformats.org/drawingml/2006/main">
-            <a:off x="7648575" y="4486275"/>
-            <a:ext cx="114300" cy="953"/>
+          <p:cNvPr id="43" name="dp45-background / n33 / path">
+            <a:extLst xmlns:a="http://schemas.openxmlformats.org/drawingml/2006/main">
+              <a:ext uri="{FF2B5EF4-FFF2-40B4-BE49-F238E27FC236}">
+                <a16:creationId xmlns:a16="http://schemas.microsoft.com/office/drawing/2014/main" id="{C85660C4-C6B9-4F70-B2F4-8E574A29156F}"/>
+              </a:ext>
+            </a:extLst>
+          </p:cNvPr>
+          <p:cNvSpPr>
+            <a:spLocks xmlns:a="http://schemas.openxmlformats.org/drawingml/2006/main" noGrp="1"/>
+          </p:cNvSpPr>
+          <p:nvPr/>
+        </p:nvSpPr>
+        <p:spPr>
+          <a:xfrm xmlns:a="http://schemas.openxmlformats.org/drawingml/2006/main">
+            <a:off x="7581900" y="3495675"/>
+            <a:ext cx="247650" cy="953"/>
           </a:xfrm>
           <a:custGeom xmlns:a="http://schemas.openxmlformats.org/drawingml/2006/main">
             <a:pathLst>
-              <a:path w="114300" h="953">
+              <a:path w="247650" h="953">
                 <a:moveTo>
                   <a:pt x="0" y="0"/>
                 </a:moveTo>
                 <a:lnTo>
-                  <a:pt x="114300" y="0"/>
+                  <a:pt x="247650" y="0"/>
                 </a:lnTo>
               </a:path>
             </a:pathLst>
@@ -16982,21 +17184,21 @@
       </p:sp>
       <p:sp>
         <p:nvSpPr>
-          <p:cNvPr id="41" name="dp45-background / n33 / arrow">
-            <a:extLst xmlns:a="http://schemas.openxmlformats.org/drawingml/2006/main">
-              <a:ext uri="{FF2B5EF4-FFF2-40B4-BE49-F238E27FC236}">
-                <a16:creationId xmlns:a16="http://schemas.microsoft.com/office/drawing/2014/main" id="{1813A991-E9D3-4F11-9CCA-3DBCC9423AD8}"/>
-              </a:ext>
-            </a:extLst>
-          </p:cNvPr>
-          <p:cNvSpPr>
-            <a:spLocks xmlns:a="http://schemas.openxmlformats.org/drawingml/2006/main" noGrp="1"/>
-          </p:cNvSpPr>
-          <p:nvPr/>
-        </p:nvSpPr>
-        <p:spPr>
-          <a:xfrm xmlns:a="http://schemas.openxmlformats.org/drawingml/2006/main">
-            <a:off x="7640955" y="4425315"/>
+          <p:cNvPr id="44" name="dp45-background / n33 / arrow">
+            <a:extLst xmlns:a="http://schemas.openxmlformats.org/drawingml/2006/main">
+              <a:ext uri="{FF2B5EF4-FFF2-40B4-BE49-F238E27FC236}">
+                <a16:creationId xmlns:a16="http://schemas.microsoft.com/office/drawing/2014/main" id="{F589AF4A-2517-4115-91EA-00192E011A77}"/>
+              </a:ext>
+            </a:extLst>
+          </p:cNvPr>
+          <p:cNvSpPr>
+            <a:spLocks xmlns:a="http://schemas.openxmlformats.org/drawingml/2006/main" noGrp="1"/>
+          </p:cNvSpPr>
+          <p:nvPr/>
+        </p:nvSpPr>
+        <p:spPr>
+          <a:xfrm xmlns:a="http://schemas.openxmlformats.org/drawingml/2006/main">
+            <a:off x="7707630" y="3434715"/>
             <a:ext cx="121920" cy="121920"/>
           </a:xfrm>
           <a:custGeom xmlns:a="http://schemas.openxmlformats.org/drawingml/2006/main">
@@ -17025,10 +17227,10 @@
       </p:sp>
       <p:sp>
         <p:nvSpPr>
-          <p:cNvPr id="42" name="dp45-background / n34 / path">
-            <a:extLst xmlns:a="http://schemas.openxmlformats.org/drawingml/2006/main">
-              <a:ext uri="{FF2B5EF4-FFF2-40B4-BE49-F238E27FC236}">
-                <a16:creationId xmlns:a16="http://schemas.microsoft.com/office/drawing/2014/main" id="{F3EC4E07-ED8C-4EA3-A061-57618A2AA4F5}"/>
+          <p:cNvPr id="45" name="dp45-background / n34 / path">
+            <a:extLst xmlns:a="http://schemas.openxmlformats.org/drawingml/2006/main">
+              <a:ext uri="{FF2B5EF4-FFF2-40B4-BE49-F238E27FC236}">
+                <a16:creationId xmlns:a16="http://schemas.microsoft.com/office/drawing/2014/main" id="{0E06DDF8-2E10-4AE0-B1B6-934AB7DCA3DA}"/>
               </a:ext>
             </a:extLst>
           </p:cNvPr>
@@ -17040,22 +17242,16 @@
         <p:spPr>
           <a:xfrm xmlns:a="http://schemas.openxmlformats.org/drawingml/2006/main">
             <a:off x="2276475" y="5924550"/>
-            <a:ext cx="7239000" cy="228600"/>
+            <a:ext cx="953" cy="219075"/>
           </a:xfrm>
           <a:custGeom xmlns:a="http://schemas.openxmlformats.org/drawingml/2006/main">
             <a:pathLst>
-              <a:path w="7239000" h="228600">
+              <a:path w="953" h="219075">
                 <a:moveTo>
                   <a:pt x="0" y="0"/>
                 </a:moveTo>
                 <a:lnTo>
-                  <a:pt x="0" y="228600"/>
-                </a:lnTo>
-                <a:lnTo>
-                  <a:pt x="7239000" y="228600"/>
-                </a:lnTo>
-                <a:lnTo>
-                  <a:pt x="7239000" y="0"/>
+                  <a:pt x="0" y="219075"/>
                 </a:lnTo>
               </a:path>
             </a:pathLst>
@@ -17063,343 +17259,481 @@
           <a:noFill xmlns:a="http://schemas.openxmlformats.org/drawingml/2006/main"/>
           <a:ln xmlns:a="http://schemas.openxmlformats.org/drawingml/2006/main" w="19050">
             <a:solidFill>
-              <a:srgbClr val="CDD6DE"/>
+              <a:srgbClr val="087E8B"/>
             </a:solidFill>
-            <a:prstDash val="solid"/>
-          </a:ln>
-        </p:spPr>
-      </p:sp>
-      <p:sp>
-        <p:nvSpPr>
-          <p:cNvPr id="43" name="dp45-background / n35 / text 1">
-            <a:extLst xmlns:a="http://schemas.openxmlformats.org/drawingml/2006/main">
-              <a:ext uri="{FF2B5EF4-FFF2-40B4-BE49-F238E27FC236}">
-                <a16:creationId xmlns:a16="http://schemas.microsoft.com/office/drawing/2014/main" id="{C77F7C32-FFCE-4B74-915F-B76E22F1CC8C}"/>
-              </a:ext>
-            </a:extLst>
-          </p:cNvPr>
-          <p:cNvSpPr>
-            <a:spLocks xmlns:a="http://schemas.openxmlformats.org/drawingml/2006/main" noGrp="1"/>
-          </p:cNvSpPr>
-          <p:nvPr/>
-        </p:nvSpPr>
-        <p:spPr>
-          <a:xfrm xmlns:a="http://schemas.openxmlformats.org/drawingml/2006/main">
-            <a:off x="609600" y="6324600"/>
-            <a:ext cx="10572750" cy="317659"/>
-          </a:xfrm>
-          <a:prstGeom xmlns:a="http://schemas.openxmlformats.org/drawingml/2006/main" prst="rect">
-            <a:avLst/>
-          </a:prstGeom>
-          <a:noFill xmlns:a="http://schemas.openxmlformats.org/drawingml/2006/main"/>
-          <a:ln xmlns:a="http://schemas.openxmlformats.org/drawingml/2006/main" w="0">
-            <a:noFill/>
-            <a:prstDash val="solid"/>
-          </a:ln>
-        </p:spPr>
-        <p:txBody>
-          <a:bodyPr xmlns:a="http://schemas.openxmlformats.org/drawingml/2006/main" wrap="none" lIns="0" tIns="0" rIns="0" bIns="0" anchor="t">
-            <a:noAutofit/>
-          </a:bodyPr>
-          <a:lstStyle xmlns:a="http://schemas.openxmlformats.org/drawingml/2006/main"/>
-          <a:p xmlns:a="http://schemas.openxmlformats.org/drawingml/2006/main">
-            <a:pPr algn="l">
-              <a:defRPr sz="1725" b="0">
-                <a:solidFill>
-                  <a:srgbClr val="5F6B77"/>
-                </a:solidFill>
-                <a:latin typeface="Apple SD Gothic Neo"/>
-                <a:ea typeface="Apple SD Gothic Neo"/>
-                <a:cs typeface="Apple SD Gothic Neo"/>
-              </a:defRPr>
-            </a:pPr>
-            <a:r>
-              <a:rPr sz="1725" b="0">
-                <a:solidFill>
-                  <a:srgbClr val="5F6B77"/>
-                </a:solidFill>
-                <a:latin typeface="Apple SD Gothic Neo"/>
-                <a:ea typeface="Apple SD Gothic Neo"/>
-                <a:cs typeface="Apple SD Gothic Neo"/>
-              </a:rPr>
-              <a:t>이번 / 새 보고서의 Request</a:t>
-            </a:r>
-          </a:p>
-        </p:txBody>
-      </p:sp>
-      <p:sp>
-        <p:nvSpPr>
-          <p:cNvPr id="44" name="dp45-background / n36">
-            <a:extLst xmlns:a="http://schemas.openxmlformats.org/drawingml/2006/main">
-              <a:ext uri="{FF2B5EF4-FFF2-40B4-BE49-F238E27FC236}">
-                <a16:creationId xmlns:a16="http://schemas.microsoft.com/office/drawing/2014/main" id="{DCD2C33F-2788-4E5E-BF47-1C2192236E7C}"/>
-              </a:ext>
-            </a:extLst>
-          </p:cNvPr>
-          <p:cNvSpPr>
-            <a:spLocks xmlns:a="http://schemas.openxmlformats.org/drawingml/2006/main" noGrp="1"/>
-          </p:cNvSpPr>
-          <p:nvPr/>
-        </p:nvSpPr>
-        <p:spPr>
-          <a:xfrm xmlns:a="http://schemas.openxmlformats.org/drawingml/2006/main">
-            <a:off x="609600" y="6743700"/>
-            <a:ext cx="10572750" cy="771525"/>
-          </a:xfrm>
-          <a:prstGeom xmlns:a="http://schemas.openxmlformats.org/drawingml/2006/main" prst="rect">
-            <a:avLst/>
-          </a:prstGeom>
-          <a:solidFill xmlns:a="http://schemas.openxmlformats.org/drawingml/2006/main">
-            <a:srgbClr val="EAF0F8"/>
-          </a:solidFill>
-          <a:ln xmlns:a="http://schemas.openxmlformats.org/drawingml/2006/main" w="0">
-            <a:noFill/>
-            <a:prstDash val="solid"/>
-          </a:ln>
-        </p:spPr>
-      </p:sp>
-      <p:sp>
-        <p:nvSpPr>
-          <p:cNvPr id="45" name="dp45-background / n37 / text 1">
-            <a:extLst xmlns:a="http://schemas.openxmlformats.org/drawingml/2006/main">
-              <a:ext uri="{FF2B5EF4-FFF2-40B4-BE49-F238E27FC236}">
-                <a16:creationId xmlns:a16="http://schemas.microsoft.com/office/drawing/2014/main" id="{5A6E4F9B-B890-40F7-A0F3-C0172CAE6F35}"/>
-              </a:ext>
-            </a:extLst>
-          </p:cNvPr>
-          <p:cNvSpPr>
-            <a:spLocks xmlns:a="http://schemas.openxmlformats.org/drawingml/2006/main" noGrp="1"/>
-          </p:cNvSpPr>
-          <p:nvPr/>
-        </p:nvSpPr>
-        <p:spPr>
-          <a:xfrm xmlns:a="http://schemas.openxmlformats.org/drawingml/2006/main">
-            <a:off x="800100" y="6934200"/>
-            <a:ext cx="10191750" cy="386715"/>
-          </a:xfrm>
-          <a:prstGeom xmlns:a="http://schemas.openxmlformats.org/drawingml/2006/main" prst="rect">
-            <a:avLst/>
-          </a:prstGeom>
-          <a:noFill xmlns:a="http://schemas.openxmlformats.org/drawingml/2006/main"/>
-          <a:ln xmlns:a="http://schemas.openxmlformats.org/drawingml/2006/main" w="0">
-            <a:noFill/>
-            <a:prstDash val="solid"/>
-          </a:ln>
-        </p:spPr>
-        <p:txBody>
-          <a:bodyPr xmlns:a="http://schemas.openxmlformats.org/drawingml/2006/main" wrap="none" lIns="0" tIns="0" rIns="0" bIns="0" anchor="t">
-            <a:noAutofit/>
-          </a:bodyPr>
-          <a:lstStyle xmlns:a="http://schemas.openxmlformats.org/drawingml/2006/main"/>
-          <a:p xmlns:a="http://schemas.openxmlformats.org/drawingml/2006/main">
-            <a:pPr algn="l">
-              <a:defRPr sz="2100" b="1">
-                <a:solidFill>
-                  <a:srgbClr val="18232E"/>
-                </a:solidFill>
-                <a:latin typeface="Apple SD Gothic Neo"/>
-                <a:ea typeface="Apple SD Gothic Neo"/>
-                <a:cs typeface="Apple SD Gothic Neo"/>
-              </a:defRPr>
-            </a:pPr>
-            <a:r>
-              <a:rPr sz="2100" b="1">
-                <a:solidFill>
-                  <a:srgbClr val="18232E"/>
-                </a:solidFill>
-                <a:latin typeface="Apple SD Gothic Neo"/>
-                <a:ea typeface="Apple SD Gothic Neo"/>
-                <a:cs typeface="Apple SD Gothic Neo"/>
-              </a:rPr>
-              <a:t>“지난번에 내가 고친 표현 방식으로 이번 보고서도 정리해줘.”</a:t>
-            </a:r>
-          </a:p>
-        </p:txBody>
-      </p:sp>
-      <p:sp>
-        <p:nvSpPr>
-          <p:cNvPr id="46" name="dp45-background / n38">
-            <a:extLst xmlns:a="http://schemas.openxmlformats.org/drawingml/2006/main">
-              <a:ext uri="{FF2B5EF4-FFF2-40B4-BE49-F238E27FC236}">
-                <a16:creationId xmlns:a16="http://schemas.microsoft.com/office/drawing/2014/main" id="{2C2E5170-368F-416A-82F9-5FA36608F537}"/>
-              </a:ext>
-            </a:extLst>
-          </p:cNvPr>
-          <p:cNvSpPr>
-            <a:spLocks xmlns:a="http://schemas.openxmlformats.org/drawingml/2006/main" noGrp="1"/>
-          </p:cNvSpPr>
-          <p:nvPr/>
-        </p:nvSpPr>
-        <p:spPr>
-          <a:xfrm xmlns:a="http://schemas.openxmlformats.org/drawingml/2006/main">
-            <a:off x="609600" y="7724775"/>
-            <a:ext cx="10572750" cy="523875"/>
-          </a:xfrm>
-          <a:prstGeom xmlns:a="http://schemas.openxmlformats.org/drawingml/2006/main" prst="rect">
-            <a:avLst/>
-          </a:prstGeom>
-          <a:solidFill xmlns:a="http://schemas.openxmlformats.org/drawingml/2006/main">
-            <a:srgbClr val="F0F8F7"/>
-          </a:solidFill>
-          <a:ln xmlns:a="http://schemas.openxmlformats.org/drawingml/2006/main" w="0">
-            <a:noFill/>
-            <a:prstDash val="solid"/>
-          </a:ln>
-        </p:spPr>
-      </p:sp>
-      <p:sp>
-        <p:nvSpPr>
-          <p:cNvPr id="47" name="dp45-background / n39 / path">
-            <a:extLst xmlns:a="http://schemas.openxmlformats.org/drawingml/2006/main">
-              <a:ext uri="{FF2B5EF4-FFF2-40B4-BE49-F238E27FC236}">
-                <a16:creationId xmlns:a16="http://schemas.microsoft.com/office/drawing/2014/main" id="{C86465F2-351E-47AD-902F-1C287797A1F6}"/>
-              </a:ext>
-            </a:extLst>
-          </p:cNvPr>
-          <p:cNvSpPr>
-            <a:spLocks xmlns:a="http://schemas.openxmlformats.org/drawingml/2006/main" noGrp="1"/>
-          </p:cNvSpPr>
-          <p:nvPr/>
-        </p:nvSpPr>
-        <p:spPr>
-          <a:xfrm xmlns:a="http://schemas.openxmlformats.org/drawingml/2006/main">
-            <a:off x="5895975" y="6153150"/>
-            <a:ext cx="5457825" cy="1838325"/>
+            <a:prstDash val="dash"/>
+          </a:ln>
+        </p:spPr>
+      </p:sp>
+      <p:sp>
+        <p:nvSpPr>
+          <p:cNvPr id="46" name="dp45-background / n35 / path">
+            <a:extLst xmlns:a="http://schemas.openxmlformats.org/drawingml/2006/main">
+              <a:ext uri="{FF2B5EF4-FFF2-40B4-BE49-F238E27FC236}">
+                <a16:creationId xmlns:a16="http://schemas.microsoft.com/office/drawing/2014/main" id="{DF4BF248-ACF3-412E-9883-0CA360872AC6}"/>
+              </a:ext>
+            </a:extLst>
+          </p:cNvPr>
+          <p:cNvSpPr>
+            <a:spLocks xmlns:a="http://schemas.openxmlformats.org/drawingml/2006/main" noGrp="1"/>
+          </p:cNvSpPr>
+          <p:nvPr/>
+        </p:nvSpPr>
+        <p:spPr>
+          <a:xfrm xmlns:a="http://schemas.openxmlformats.org/drawingml/2006/main">
+            <a:off x="5895975" y="5924550"/>
+            <a:ext cx="953" cy="219075"/>
           </a:xfrm>
           <a:custGeom xmlns:a="http://schemas.openxmlformats.org/drawingml/2006/main">
             <a:pathLst>
-              <a:path w="5457825" h="1838325">
+              <a:path w="953" h="219075">
                 <a:moveTo>
                   <a:pt x="0" y="0"/>
                 </a:moveTo>
                 <a:lnTo>
-                  <a:pt x="5457825" y="0"/>
-                </a:lnTo>
-                <a:lnTo>
-                  <a:pt x="5457825" y="1838325"/>
-                </a:lnTo>
-                <a:lnTo>
-                  <a:pt x="5286375" y="1838325"/>
+                  <a:pt x="0" y="219075"/>
                 </a:lnTo>
               </a:path>
             </a:pathLst>
           </a:custGeom>
           <a:noFill xmlns:a="http://schemas.openxmlformats.org/drawingml/2006/main"/>
-          <a:ln xmlns:a="http://schemas.openxmlformats.org/drawingml/2006/main" w="28575">
+          <a:ln xmlns:a="http://schemas.openxmlformats.org/drawingml/2006/main" w="19050">
             <a:solidFill>
               <a:srgbClr val="087E8B"/>
             </a:solidFill>
-            <a:prstDash val="solid"/>
-          </a:ln>
-        </p:spPr>
-      </p:sp>
-      <p:sp>
-        <p:nvSpPr>
-          <p:cNvPr id="48" name="dp45-background / n39 / arrow">
-            <a:extLst xmlns:a="http://schemas.openxmlformats.org/drawingml/2006/main">
-              <a:ext uri="{FF2B5EF4-FFF2-40B4-BE49-F238E27FC236}">
-                <a16:creationId xmlns:a16="http://schemas.microsoft.com/office/drawing/2014/main" id="{46AAE001-77AC-4C9C-AFF0-DB4404D62E0C}"/>
-              </a:ext>
-            </a:extLst>
-          </p:cNvPr>
-          <p:cNvSpPr>
-            <a:spLocks xmlns:a="http://schemas.openxmlformats.org/drawingml/2006/main" noGrp="1"/>
-          </p:cNvSpPr>
-          <p:nvPr/>
-        </p:nvSpPr>
-        <p:spPr>
-          <a:xfrm xmlns:a="http://schemas.openxmlformats.org/drawingml/2006/main">
-            <a:off x="11182350" y="7900035"/>
-            <a:ext cx="182880" cy="182880"/>
+            <a:prstDash val="dash"/>
+          </a:ln>
+        </p:spPr>
+      </p:sp>
+      <p:sp>
+        <p:nvSpPr>
+          <p:cNvPr id="47" name="dp45-background / n36 / path">
+            <a:extLst xmlns:a="http://schemas.openxmlformats.org/drawingml/2006/main">
+              <a:ext uri="{FF2B5EF4-FFF2-40B4-BE49-F238E27FC236}">
+                <a16:creationId xmlns:a16="http://schemas.microsoft.com/office/drawing/2014/main" id="{BF2A861D-EDC2-4742-9D74-178241960414}"/>
+              </a:ext>
+            </a:extLst>
+          </p:cNvPr>
+          <p:cNvSpPr>
+            <a:spLocks xmlns:a="http://schemas.openxmlformats.org/drawingml/2006/main" noGrp="1"/>
+          </p:cNvSpPr>
+          <p:nvPr/>
+        </p:nvSpPr>
+        <p:spPr>
+          <a:xfrm xmlns:a="http://schemas.openxmlformats.org/drawingml/2006/main">
+            <a:off x="9515475" y="5924550"/>
+            <a:ext cx="953" cy="219075"/>
           </a:xfrm>
           <a:custGeom xmlns:a="http://schemas.openxmlformats.org/drawingml/2006/main">
             <a:pathLst>
-              <a:path w="182880" h="182880">
+              <a:path w="953" h="219075">
                 <a:moveTo>
-                  <a:pt x="182880" y="0"/>
+                  <a:pt x="0" y="0"/>
                 </a:moveTo>
                 <a:lnTo>
-                  <a:pt x="0" y="91440"/>
-                </a:lnTo>
-                <a:lnTo>
-                  <a:pt x="182880" y="182880"/>
+                  <a:pt x="0" y="219075"/>
                 </a:lnTo>
               </a:path>
             </a:pathLst>
           </a:custGeom>
           <a:noFill xmlns:a="http://schemas.openxmlformats.org/drawingml/2006/main"/>
-          <a:ln xmlns:a="http://schemas.openxmlformats.org/drawingml/2006/main" w="36576">
+          <a:ln xmlns:a="http://schemas.openxmlformats.org/drawingml/2006/main" w="19050">
             <a:solidFill>
               <a:srgbClr val="087E8B"/>
             </a:solidFill>
-            <a:prstDash val="solid"/>
-          </a:ln>
-        </p:spPr>
-      </p:sp>
-      <p:sp>
-        <p:nvSpPr>
-          <p:cNvPr id="49" name="dp45-background / n40 / text 1">
-            <a:extLst xmlns:a="http://schemas.openxmlformats.org/drawingml/2006/main">
-              <a:ext uri="{FF2B5EF4-FFF2-40B4-BE49-F238E27FC236}">
-                <a16:creationId xmlns:a16="http://schemas.microsoft.com/office/drawing/2014/main" id="{7EFD606D-C429-4317-B3E1-2731C461DB19}"/>
-              </a:ext>
-            </a:extLst>
-          </p:cNvPr>
-          <p:cNvSpPr>
-            <a:spLocks xmlns:a="http://schemas.openxmlformats.org/drawingml/2006/main" noGrp="1"/>
-          </p:cNvSpPr>
-          <p:nvPr/>
-        </p:nvSpPr>
-        <p:spPr>
-          <a:xfrm xmlns:a="http://schemas.openxmlformats.org/drawingml/2006/main">
-            <a:off x="800100" y="7858125"/>
-            <a:ext cx="10191750" cy="331470"/>
-          </a:xfrm>
-          <a:prstGeom xmlns:a="http://schemas.openxmlformats.org/drawingml/2006/main" prst="rect">
-            <a:avLst/>
-          </a:prstGeom>
-          <a:noFill xmlns:a="http://schemas.openxmlformats.org/drawingml/2006/main"/>
-          <a:ln xmlns:a="http://schemas.openxmlformats.org/drawingml/2006/main" w="0">
-            <a:noFill/>
-            <a:prstDash val="solid"/>
-          </a:ln>
-        </p:spPr>
-        <p:txBody>
-          <a:bodyPr xmlns:a="http://schemas.openxmlformats.org/drawingml/2006/main" wrap="none" lIns="0" tIns="0" rIns="0" bIns="0" anchor="t">
-            <a:noAutofit/>
-          </a:bodyPr>
-          <a:lstStyle xmlns:a="http://schemas.openxmlformats.org/drawingml/2006/main"/>
-          <a:p xmlns:a="http://schemas.openxmlformats.org/drawingml/2006/main">
-            <a:pPr algn="l">
-              <a:defRPr sz="1800" b="1">
-                <a:solidFill>
-                  <a:srgbClr val="18232E"/>
-                </a:solidFill>
-                <a:latin typeface="Apple SD Gothic Neo"/>
-                <a:ea typeface="Apple SD Gothic Neo"/>
-                <a:cs typeface="Apple SD Gothic Neo"/>
-              </a:defRPr>
-            </a:pPr>
-            <a:r>
-              <a:rPr sz="1800" b="1">
-                <a:solidFill>
-                  <a:srgbClr val="18232E"/>
-                </a:solidFill>
-                <a:latin typeface="Apple SD Gothic Neo"/>
-                <a:ea typeface="Apple SD Gothic Neo"/>
-                <a:cs typeface="Apple SD Gothic Neo"/>
-              </a:rPr>
-              <a:t>이번 Request에 연결할 과거 Context / 정정 내용, 결과 버전과 실제 전달</a:t>
-            </a:r>
-          </a:p>
-        </p:txBody>
-      </p:sp>
-      <p:sp>
-        <p:nvSpPr>
-          <p:cNvPr id="50" name="dp45-background / n41 / text 1">
-            <a:extLst xmlns:a="http://schemas.openxmlformats.org/drawingml/2006/main">
-              <a:ext uri="{FF2B5EF4-FFF2-40B4-BE49-F238E27FC236}">
-                <a16:creationId xmlns:a16="http://schemas.microsoft.com/office/drawing/2014/main" id="{B5869C03-A144-49A5-9EDD-9DB310616714}"/>
+            <a:prstDash val="dash"/>
+          </a:ln>
+        </p:spPr>
+      </p:sp>
+      <p:sp>
+        <p:nvSpPr>
+          <p:cNvPr id="48" name="dp45-background / n37 / path">
+            <a:extLst xmlns:a="http://schemas.openxmlformats.org/drawingml/2006/main">
+              <a:ext uri="{FF2B5EF4-FFF2-40B4-BE49-F238E27FC236}">
+                <a16:creationId xmlns:a16="http://schemas.microsoft.com/office/drawing/2014/main" id="{524C169C-D112-4F20-87F8-BCA78442639D}"/>
+              </a:ext>
+            </a:extLst>
+          </p:cNvPr>
+          <p:cNvSpPr>
+            <a:spLocks xmlns:a="http://schemas.openxmlformats.org/drawingml/2006/main" noGrp="1"/>
+          </p:cNvSpPr>
+          <p:nvPr/>
+        </p:nvSpPr>
+        <p:spPr>
+          <a:xfrm xmlns:a="http://schemas.openxmlformats.org/drawingml/2006/main">
+            <a:off x="2276475" y="6143625"/>
+            <a:ext cx="9077325" cy="1866900"/>
+          </a:xfrm>
+          <a:custGeom xmlns:a="http://schemas.openxmlformats.org/drawingml/2006/main">
+            <a:pathLst>
+              <a:path w="9077325" h="1866900">
+                <a:moveTo>
+                  <a:pt x="0" y="0"/>
+                </a:moveTo>
+                <a:lnTo>
+                  <a:pt x="9077325" y="0"/>
+                </a:lnTo>
+                <a:lnTo>
+                  <a:pt x="9077325" y="1866900"/>
+                </a:lnTo>
+                <a:lnTo>
+                  <a:pt x="8905875" y="1866900"/>
+                </a:lnTo>
+              </a:path>
+            </a:pathLst>
+          </a:custGeom>
+          <a:noFill xmlns:a="http://schemas.openxmlformats.org/drawingml/2006/main"/>
+          <a:ln xmlns:a="http://schemas.openxmlformats.org/drawingml/2006/main" w="19050">
+            <a:solidFill>
+              <a:srgbClr val="087E8B"/>
+            </a:solidFill>
+            <a:prstDash val="dash"/>
+          </a:ln>
+        </p:spPr>
+      </p:sp>
+      <p:sp>
+        <p:nvSpPr>
+          <p:cNvPr id="49" name="dp45-background / n37 / arrow">
+            <a:extLst xmlns:a="http://schemas.openxmlformats.org/drawingml/2006/main">
+              <a:ext uri="{FF2B5EF4-FFF2-40B4-BE49-F238E27FC236}">
+                <a16:creationId xmlns:a16="http://schemas.microsoft.com/office/drawing/2014/main" id="{5BF83986-A32A-41FF-882A-10BBCCD7520B}"/>
+              </a:ext>
+            </a:extLst>
+          </p:cNvPr>
+          <p:cNvSpPr>
+            <a:spLocks xmlns:a="http://schemas.openxmlformats.org/drawingml/2006/main" noGrp="1"/>
+          </p:cNvSpPr>
+          <p:nvPr/>
+        </p:nvSpPr>
+        <p:spPr>
+          <a:xfrm xmlns:a="http://schemas.openxmlformats.org/drawingml/2006/main">
+            <a:off x="11182350" y="7949565"/>
+            <a:ext cx="121920" cy="121920"/>
+          </a:xfrm>
+          <a:custGeom xmlns:a="http://schemas.openxmlformats.org/drawingml/2006/main">
+            <a:pathLst>
+              <a:path w="121920" h="121920">
+                <a:moveTo>
+                  <a:pt x="121920" y="0"/>
+                </a:moveTo>
+                <a:lnTo>
+                  <a:pt x="0" y="60960"/>
+                </a:lnTo>
+                <a:lnTo>
+                  <a:pt x="121920" y="121920"/>
+                </a:lnTo>
+              </a:path>
+            </a:pathLst>
+          </a:custGeom>
+          <a:noFill xmlns:a="http://schemas.openxmlformats.org/drawingml/2006/main"/>
+          <a:ln xmlns:a="http://schemas.openxmlformats.org/drawingml/2006/main" w="24384">
+            <a:solidFill>
+              <a:srgbClr val="087E8B"/>
+            </a:solidFill>
+            <a:prstDash val="solid"/>
+          </a:ln>
+        </p:spPr>
+      </p:sp>
+      <p:sp>
+        <p:nvSpPr>
+          <p:cNvPr id="50" name="dp45-background / n38 / text 1">
+            <a:extLst xmlns:a="http://schemas.openxmlformats.org/drawingml/2006/main">
+              <a:ext uri="{FF2B5EF4-FFF2-40B4-BE49-F238E27FC236}">
+                <a16:creationId xmlns:a16="http://schemas.microsoft.com/office/drawing/2014/main" id="{D2CF6044-7C8F-4950-9F3D-A1C623E41DA1}"/>
+              </a:ext>
+            </a:extLst>
+          </p:cNvPr>
+          <p:cNvSpPr>
+            <a:spLocks xmlns:a="http://schemas.openxmlformats.org/drawingml/2006/main" noGrp="1"/>
+          </p:cNvSpPr>
+          <p:nvPr/>
+        </p:nvSpPr>
+        <p:spPr>
+          <a:xfrm xmlns:a="http://schemas.openxmlformats.org/drawingml/2006/main">
+            <a:off x="609600" y="6305550"/>
+            <a:ext cx="10572750" cy="317659"/>
+          </a:xfrm>
+          <a:prstGeom xmlns:a="http://schemas.openxmlformats.org/drawingml/2006/main" prst="rect">
+            <a:avLst/>
+          </a:prstGeom>
+          <a:noFill xmlns:a="http://schemas.openxmlformats.org/drawingml/2006/main"/>
+          <a:ln xmlns:a="http://schemas.openxmlformats.org/drawingml/2006/main" w="0">
+            <a:noFill/>
+            <a:prstDash val="solid"/>
+          </a:ln>
+        </p:spPr>
+        <p:txBody>
+          <a:bodyPr xmlns:a="http://schemas.openxmlformats.org/drawingml/2006/main" wrap="none" lIns="0" tIns="0" rIns="0" bIns="0" anchor="t">
+            <a:noAutofit/>
+          </a:bodyPr>
+          <a:lstStyle xmlns:a="http://schemas.openxmlformats.org/drawingml/2006/main"/>
+          <a:p xmlns:a="http://schemas.openxmlformats.org/drawingml/2006/main">
+            <a:pPr algn="l">
+              <a:defRPr sz="1725" b="0">
+                <a:solidFill>
+                  <a:srgbClr val="5F6B77"/>
+                </a:solidFill>
+                <a:latin typeface="Apple SD Gothic Neo"/>
+                <a:ea typeface="Apple SD Gothic Neo"/>
+                <a:cs typeface="Apple SD Gothic Neo"/>
+              </a:defRPr>
+            </a:pPr>
+            <a:r>
+              <a:rPr sz="1725" b="0">
+                <a:solidFill>
+                  <a:srgbClr val="5F6B77"/>
+                </a:solidFill>
+                <a:latin typeface="Apple SD Gothic Neo"/>
+                <a:ea typeface="Apple SD Gothic Neo"/>
+                <a:cs typeface="Apple SD Gothic Neo"/>
+              </a:rPr>
+              <a:t>이번 C23 / R23: 여러 활동을 참조하는 새 제안서 요청</a:t>
+            </a:r>
+          </a:p>
+        </p:txBody>
+      </p:sp>
+      <p:sp>
+        <p:nvSpPr>
+          <p:cNvPr id="51" name="dp45-background / n39">
+            <a:extLst xmlns:a="http://schemas.openxmlformats.org/drawingml/2006/main">
+              <a:ext uri="{FF2B5EF4-FFF2-40B4-BE49-F238E27FC236}">
+                <a16:creationId xmlns:a16="http://schemas.microsoft.com/office/drawing/2014/main" id="{DB40EAD2-E716-48DF-9A3C-64AC417393D0}"/>
+              </a:ext>
+            </a:extLst>
+          </p:cNvPr>
+          <p:cNvSpPr>
+            <a:spLocks xmlns:a="http://schemas.openxmlformats.org/drawingml/2006/main" noGrp="1"/>
+          </p:cNvSpPr>
+          <p:nvPr/>
+        </p:nvSpPr>
+        <p:spPr>
+          <a:xfrm xmlns:a="http://schemas.openxmlformats.org/drawingml/2006/main">
+            <a:off x="609600" y="6686550"/>
+            <a:ext cx="10572750" cy="981075"/>
+          </a:xfrm>
+          <a:prstGeom xmlns:a="http://schemas.openxmlformats.org/drawingml/2006/main" prst="rect">
+            <a:avLst/>
+          </a:prstGeom>
+          <a:solidFill xmlns:a="http://schemas.openxmlformats.org/drawingml/2006/main">
+            <a:srgbClr val="EAF0F8"/>
+          </a:solidFill>
+          <a:ln xmlns:a="http://schemas.openxmlformats.org/drawingml/2006/main" w="0">
+            <a:noFill/>
+            <a:prstDash val="solid"/>
+          </a:ln>
+        </p:spPr>
+      </p:sp>
+      <p:sp>
+        <p:nvSpPr>
+          <p:cNvPr id="52" name="dp45-background / n40 / text 1">
+            <a:extLst xmlns:a="http://schemas.openxmlformats.org/drawingml/2006/main">
+              <a:ext uri="{FF2B5EF4-FFF2-40B4-BE49-F238E27FC236}">
+                <a16:creationId xmlns:a16="http://schemas.microsoft.com/office/drawing/2014/main" id="{AF122054-BC49-44C2-9ADB-91602DF55889}"/>
+              </a:ext>
+            </a:extLst>
+          </p:cNvPr>
+          <p:cNvSpPr>
+            <a:spLocks xmlns:a="http://schemas.openxmlformats.org/drawingml/2006/main" noGrp="1"/>
+          </p:cNvSpPr>
+          <p:nvPr/>
+        </p:nvSpPr>
+        <p:spPr>
+          <a:xfrm xmlns:a="http://schemas.openxmlformats.org/drawingml/2006/main">
+            <a:off x="800100" y="6829425"/>
+            <a:ext cx="10191750" cy="359092"/>
+          </a:xfrm>
+          <a:prstGeom xmlns:a="http://schemas.openxmlformats.org/drawingml/2006/main" prst="rect">
+            <a:avLst/>
+          </a:prstGeom>
+          <a:noFill xmlns:a="http://schemas.openxmlformats.org/drawingml/2006/main"/>
+          <a:ln xmlns:a="http://schemas.openxmlformats.org/drawingml/2006/main" w="0">
+            <a:noFill/>
+            <a:prstDash val="solid"/>
+          </a:ln>
+        </p:spPr>
+        <p:txBody>
+          <a:bodyPr xmlns:a="http://schemas.openxmlformats.org/drawingml/2006/main" wrap="none" lIns="0" tIns="0" rIns="0" bIns="0" anchor="t">
+            <a:noAutofit/>
+          </a:bodyPr>
+          <a:lstStyle xmlns:a="http://schemas.openxmlformats.org/drawingml/2006/main"/>
+          <a:p xmlns:a="http://schemas.openxmlformats.org/drawingml/2006/main">
+            <a:pPr algn="l">
+              <a:defRPr sz="1950" b="1">
+                <a:solidFill>
+                  <a:srgbClr val="18232E"/>
+                </a:solidFill>
+                <a:latin typeface="Apple SD Gothic Neo"/>
+                <a:ea typeface="Apple SD Gothic Neo"/>
+                <a:cs typeface="Apple SD Gothic Neo"/>
+              </a:defRPr>
+            </a:pPr>
+            <a:r>
+              <a:rPr sz="1950" b="1">
+                <a:solidFill>
+                  <a:srgbClr val="18232E"/>
+                </a:solidFill>
+                <a:latin typeface="Apple SD Gothic Neo"/>
+                <a:ea typeface="Apple SD Gothic Neo"/>
+                <a:cs typeface="Apple SD Gothic Neo"/>
+              </a:rPr>
+              <a:t>“지난번 네가 설명한 평가 기준에 맞춰, 앞서 조사한 제품 비교 결과와</a:t>
+            </a:r>
+          </a:p>
+        </p:txBody>
+      </p:sp>
+      <p:sp>
+        <p:nvSpPr>
+          <p:cNvPr id="53" name="dp45-background / n40 / text 2">
+            <a:extLst xmlns:a="http://schemas.openxmlformats.org/drawingml/2006/main">
+              <a:ext uri="{FF2B5EF4-FFF2-40B4-BE49-F238E27FC236}">
+                <a16:creationId xmlns:a16="http://schemas.microsoft.com/office/drawing/2014/main" id="{5E6F2EF8-5872-46FE-81E3-1CB75374B14A}"/>
+              </a:ext>
+            </a:extLst>
+          </p:cNvPr>
+          <p:cNvSpPr>
+            <a:spLocks xmlns:a="http://schemas.openxmlformats.org/drawingml/2006/main" noGrp="1"/>
+          </p:cNvSpPr>
+          <p:nvPr/>
+        </p:nvSpPr>
+        <p:spPr>
+          <a:xfrm xmlns:a="http://schemas.openxmlformats.org/drawingml/2006/main">
+            <a:off x="800100" y="7181850"/>
+            <a:ext cx="10191750" cy="359092"/>
+          </a:xfrm>
+          <a:prstGeom xmlns:a="http://schemas.openxmlformats.org/drawingml/2006/main" prst="rect">
+            <a:avLst/>
+          </a:prstGeom>
+          <a:noFill xmlns:a="http://schemas.openxmlformats.org/drawingml/2006/main"/>
+          <a:ln xmlns:a="http://schemas.openxmlformats.org/drawingml/2006/main" w="0">
+            <a:noFill/>
+            <a:prstDash val="solid"/>
+          </a:ln>
+        </p:spPr>
+        <p:txBody>
+          <a:bodyPr xmlns:a="http://schemas.openxmlformats.org/drawingml/2006/main" wrap="none" lIns="0" tIns="0" rIns="0" bIns="0" anchor="t">
+            <a:noAutofit/>
+          </a:bodyPr>
+          <a:lstStyle xmlns:a="http://schemas.openxmlformats.org/drawingml/2006/main"/>
+          <a:p xmlns:a="http://schemas.openxmlformats.org/drawingml/2006/main">
+            <a:pPr algn="l">
+              <a:defRPr sz="1950" b="1">
+                <a:solidFill>
+                  <a:srgbClr val="18232E"/>
+                </a:solidFill>
+                <a:latin typeface="Apple SD Gothic Neo"/>
+                <a:ea typeface="Apple SD Gothic Neo"/>
+                <a:cs typeface="Apple SD Gothic Neo"/>
+              </a:defRPr>
+            </a:pPr>
+            <a:r>
+              <a:rPr sz="1950" b="1">
+                <a:solidFill>
+                  <a:srgbClr val="18232E"/>
+                </a:solidFill>
+                <a:latin typeface="Apple SD Gothic Neo"/>
+                <a:ea typeface="Apple SD Gothic Neo"/>
+                <a:cs typeface="Apple SD Gothic Neo"/>
+              </a:rPr>
+              <a:t>받아둔 견적을 이번 제안서에 반영해줘.”</a:t>
+            </a:r>
+          </a:p>
+        </p:txBody>
+      </p:sp>
+      <p:sp>
+        <p:nvSpPr>
+          <p:cNvPr id="54" name="dp45-background / n41">
+            <a:extLst xmlns:a="http://schemas.openxmlformats.org/drawingml/2006/main">
+              <a:ext uri="{FF2B5EF4-FFF2-40B4-BE49-F238E27FC236}">
+                <a16:creationId xmlns:a16="http://schemas.microsoft.com/office/drawing/2014/main" id="{8C7ECBC6-FABF-4FD1-B089-B9BA54EA0119}"/>
+              </a:ext>
+            </a:extLst>
+          </p:cNvPr>
+          <p:cNvSpPr>
+            <a:spLocks xmlns:a="http://schemas.openxmlformats.org/drawingml/2006/main" noGrp="1"/>
+          </p:cNvSpPr>
+          <p:nvPr/>
+        </p:nvSpPr>
+        <p:spPr>
+          <a:xfrm xmlns:a="http://schemas.openxmlformats.org/drawingml/2006/main">
+            <a:off x="609600" y="7820025"/>
+            <a:ext cx="10572750" cy="438150"/>
+          </a:xfrm>
+          <a:prstGeom xmlns:a="http://schemas.openxmlformats.org/drawingml/2006/main" prst="rect">
+            <a:avLst/>
+          </a:prstGeom>
+          <a:solidFill xmlns:a="http://schemas.openxmlformats.org/drawingml/2006/main">
+            <a:srgbClr val="F0F8F7"/>
+          </a:solidFill>
+          <a:ln xmlns:a="http://schemas.openxmlformats.org/drawingml/2006/main" w="0">
+            <a:noFill/>
+            <a:prstDash val="solid"/>
+          </a:ln>
+        </p:spPr>
+      </p:sp>
+      <p:sp>
+        <p:nvSpPr>
+          <p:cNvPr id="55" name="dp45-background / n42 / text 1">
+            <a:extLst xmlns:a="http://schemas.openxmlformats.org/drawingml/2006/main">
+              <a:ext uri="{FF2B5EF4-FFF2-40B4-BE49-F238E27FC236}">
+                <a16:creationId xmlns:a16="http://schemas.microsoft.com/office/drawing/2014/main" id="{B3681CD6-D76C-4FEB-9D83-4C57AB42CF10}"/>
+              </a:ext>
+            </a:extLst>
+          </p:cNvPr>
+          <p:cNvSpPr>
+            <a:spLocks xmlns:a="http://schemas.openxmlformats.org/drawingml/2006/main" noGrp="1"/>
+          </p:cNvSpPr>
+          <p:nvPr/>
+        </p:nvSpPr>
+        <p:spPr>
+          <a:xfrm xmlns:a="http://schemas.openxmlformats.org/drawingml/2006/main">
+            <a:off x="800100" y="7915275"/>
+            <a:ext cx="10191750" cy="317659"/>
+          </a:xfrm>
+          <a:prstGeom xmlns:a="http://schemas.openxmlformats.org/drawingml/2006/main" prst="rect">
+            <a:avLst/>
+          </a:prstGeom>
+          <a:noFill xmlns:a="http://schemas.openxmlformats.org/drawingml/2006/main"/>
+          <a:ln xmlns:a="http://schemas.openxmlformats.org/drawingml/2006/main" w="0">
+            <a:noFill/>
+            <a:prstDash val="solid"/>
+          </a:ln>
+        </p:spPr>
+        <p:txBody>
+          <a:bodyPr xmlns:a="http://schemas.openxmlformats.org/drawingml/2006/main" wrap="none" lIns="0" tIns="0" rIns="0" bIns="0" anchor="t">
+            <a:noAutofit/>
+          </a:bodyPr>
+          <a:lstStyle xmlns:a="http://schemas.openxmlformats.org/drawingml/2006/main"/>
+          <a:p xmlns:a="http://schemas.openxmlformats.org/drawingml/2006/main">
+            <a:pPr algn="l">
+              <a:defRPr sz="1725" b="1">
+                <a:solidFill>
+                  <a:srgbClr val="18232E"/>
+                </a:solidFill>
+                <a:latin typeface="Apple SD Gothic Neo"/>
+                <a:ea typeface="Apple SD Gothic Neo"/>
+                <a:cs typeface="Apple SD Gothic Neo"/>
+              </a:defRPr>
+            </a:pPr>
+            <a:r>
+              <a:rPr sz="1725" b="1">
+                <a:solidFill>
+                  <a:srgbClr val="18232E"/>
+                </a:solidFill>
+                <a:latin typeface="Apple SD Gothic Neo"/>
+                <a:ea typeface="Apple SD Gothic Neo"/>
+                <a:cs typeface="Apple SD Gothic Neo"/>
+              </a:rPr>
+              <a:t>VIA: P20 전달 범위와 D21/D22 발췌 또는 참조를 이번 Context에 연결</a:t>
+            </a:r>
+          </a:p>
+        </p:txBody>
+      </p:sp>
+      <p:sp>
+        <p:nvSpPr>
+          <p:cNvPr id="56" name="dp45-background / n43 / text 1">
+            <a:extLst xmlns:a="http://schemas.openxmlformats.org/drawingml/2006/main">
+              <a:ext uri="{FF2B5EF4-FFF2-40B4-BE49-F238E27FC236}">
+                <a16:creationId xmlns:a16="http://schemas.microsoft.com/office/drawing/2014/main" id="{AE3536AC-6551-4CBB-8594-13D2E81A25F6}"/>
               </a:ext>
             </a:extLst>
           </p:cNvPr>
@@ -17447,17 +17781,17 @@
                 <a:ea typeface="Apple SD Gothic Neo"/>
                 <a:cs typeface="Apple SD Gothic Neo"/>
               </a:rPr>
-              <a:t>기록 간 관계의 복원</a:t>
-            </a:r>
-          </a:p>
-        </p:txBody>
-      </p:sp>
-      <p:sp>
-        <p:nvSpPr>
-          <p:cNvPr id="51" name="dp45-background / n42 / text 1">
-            <a:extLst xmlns:a="http://schemas.openxmlformats.org/drawingml/2006/main">
-              <a:ext uri="{FF2B5EF4-FFF2-40B4-BE49-F238E27FC236}">
-                <a16:creationId xmlns:a16="http://schemas.microsoft.com/office/drawing/2014/main" id="{1EE120AD-7982-41D8-98C0-4D595839F6F7}"/>
+              <a:t>여러 활동의 근거 연결</a:t>
+            </a:r>
+          </a:p>
+        </p:txBody>
+      </p:sp>
+      <p:sp>
+        <p:nvSpPr>
+          <p:cNvPr id="57" name="dp45-background / n44 / text 1">
+            <a:extLst xmlns:a="http://schemas.openxmlformats.org/drawingml/2006/main">
+              <a:ext uri="{FF2B5EF4-FFF2-40B4-BE49-F238E27FC236}">
+                <a16:creationId xmlns:a16="http://schemas.microsoft.com/office/drawing/2014/main" id="{946D5B40-1874-434E-956E-D4E93A841C74}"/>
               </a:ext>
             </a:extLst>
           </p:cNvPr>
@@ -17505,17 +17839,17 @@
                 <a:ea typeface="Apple SD Gothic Neo"/>
                 <a:cs typeface="Apple SD Gothic Neo"/>
               </a:rPr>
-              <a:t>정정 내용과 결과 버전 및 실제 전달의 연결</a:t>
-            </a:r>
-          </a:p>
-        </p:txBody>
-      </p:sp>
-      <p:sp>
-        <p:nvSpPr>
-          <p:cNvPr id="52" name="dp45-background / n43 / text 1">
-            <a:extLst xmlns:a="http://schemas.openxmlformats.org/drawingml/2006/main">
-              <a:ext uri="{FF2B5EF4-FFF2-40B4-BE49-F238E27FC236}">
-                <a16:creationId xmlns:a16="http://schemas.microsoft.com/office/drawing/2014/main" id="{22085BD8-162F-46FA-8B23-52F5B9D3BC3E}"/>
+              <a:t>직접 설명과 두 업무 결과의 후보 및 버전 확인</a:t>
+            </a:r>
+          </a:p>
+        </p:txBody>
+      </p:sp>
+      <p:sp>
+        <p:nvSpPr>
+          <p:cNvPr id="58" name="dp45-background / n45 / text 1">
+            <a:extLst xmlns:a="http://schemas.openxmlformats.org/drawingml/2006/main">
+              <a:ext uri="{FF2B5EF4-FFF2-40B4-BE49-F238E27FC236}">
+                <a16:creationId xmlns:a16="http://schemas.microsoft.com/office/drawing/2014/main" id="{04E826A3-5595-4F19-918E-5D58E2F07331}"/>
               </a:ext>
             </a:extLst>
           </p:cNvPr>
@@ -17563,17 +17897,17 @@
                 <a:ea typeface="Apple SD Gothic Neo"/>
                 <a:cs typeface="Apple SD Gothic Neo"/>
               </a:rPr>
-              <a:t>재사용 정보의 유효성</a:t>
-            </a:r>
-          </a:p>
-        </p:txBody>
-      </p:sp>
-      <p:sp>
-        <p:nvSpPr>
-          <p:cNvPr id="53" name="dp45-background / n44 / text 1">
-            <a:extLst xmlns:a="http://schemas.openxmlformats.org/drawingml/2006/main">
-              <a:ext uri="{FF2B5EF4-FFF2-40B4-BE49-F238E27FC236}">
-                <a16:creationId xmlns:a16="http://schemas.microsoft.com/office/drawing/2014/main" id="{64E08B5E-E504-47F9-809B-27949EB4B8FD}"/>
+              <a:t>실제 전달과 자료 범위</a:t>
+            </a:r>
+          </a:p>
+        </p:txBody>
+      </p:sp>
+      <p:sp>
+        <p:nvSpPr>
+          <p:cNvPr id="59" name="dp45-background / n46 / text 1">
+            <a:extLst xmlns:a="http://schemas.openxmlformats.org/drawingml/2006/main">
+              <a:ext uri="{FF2B5EF4-FFF2-40B4-BE49-F238E27FC236}">
+                <a16:creationId xmlns:a16="http://schemas.microsoft.com/office/drawing/2014/main" id="{9D67E4C3-BBE2-4740-A13E-B8737294BC22}"/>
               </a:ext>
             </a:extLst>
           </p:cNvPr>
@@ -17621,17 +17955,75 @@
                 <a:ea typeface="Apple SD Gothic Neo"/>
                 <a:cs typeface="Apple SD Gothic Neo"/>
               </a:rPr>
-              <a:t>원본 수정과 삭제 및 요약 누락의 확인</a:t>
-            </a:r>
-          </a:p>
-        </p:txBody>
-      </p:sp>
-      <p:sp>
-        <p:nvSpPr>
-          <p:cNvPr id="54" name="dp45-background / n45 / text 1">
-            <a:extLst xmlns:a="http://schemas.openxmlformats.org/drawingml/2006/main">
-              <a:ext uri="{FF2B5EF4-FFF2-40B4-BE49-F238E27FC236}">
-                <a16:creationId xmlns:a16="http://schemas.microsoft.com/office/drawing/2014/main" id="{C0DB6565-9136-4974-AE9A-3A5C69E77C2B}"/>
+              <a:t>설명 원문과 실제 표시/재생 범위 구별</a:t>
+            </a:r>
+          </a:p>
+        </p:txBody>
+      </p:sp>
+      <p:sp>
+        <p:nvSpPr>
+          <p:cNvPr id="60" name="dp45-background / n46 / text 2">
+            <a:extLst xmlns:a="http://schemas.openxmlformats.org/drawingml/2006/main">
+              <a:ext uri="{FF2B5EF4-FFF2-40B4-BE49-F238E27FC236}">
+                <a16:creationId xmlns:a16="http://schemas.microsoft.com/office/drawing/2014/main" id="{502A4938-254B-4B36-8E08-47758E623CF9}"/>
+              </a:ext>
+            </a:extLst>
+          </p:cNvPr>
+          <p:cNvSpPr>
+            <a:spLocks xmlns:a="http://schemas.openxmlformats.org/drawingml/2006/main" noGrp="1"/>
+          </p:cNvSpPr>
+          <p:nvPr/>
+        </p:nvSpPr>
+        <p:spPr>
+          <a:xfrm xmlns:a="http://schemas.openxmlformats.org/drawingml/2006/main">
+            <a:off x="12001500" y="5619750"/>
+            <a:ext cx="5676900" cy="317659"/>
+          </a:xfrm>
+          <a:prstGeom xmlns:a="http://schemas.openxmlformats.org/drawingml/2006/main" prst="rect">
+            <a:avLst/>
+          </a:prstGeom>
+          <a:noFill xmlns:a="http://schemas.openxmlformats.org/drawingml/2006/main"/>
+          <a:ln xmlns:a="http://schemas.openxmlformats.org/drawingml/2006/main" w="0">
+            <a:noFill/>
+            <a:prstDash val="solid"/>
+          </a:ln>
+        </p:spPr>
+        <p:txBody>
+          <a:bodyPr xmlns:a="http://schemas.openxmlformats.org/drawingml/2006/main" wrap="none" lIns="0" tIns="0" rIns="0" bIns="0" anchor="t">
+            <a:noAutofit/>
+          </a:bodyPr>
+          <a:lstStyle xmlns:a="http://schemas.openxmlformats.org/drawingml/2006/main"/>
+          <a:p xmlns:a="http://schemas.openxmlformats.org/drawingml/2006/main">
+            <a:pPr algn="l">
+              <a:defRPr sz="1725" b="0">
+                <a:solidFill>
+                  <a:srgbClr val="5F6B77"/>
+                </a:solidFill>
+                <a:latin typeface="Apple SD Gothic Neo"/>
+                <a:ea typeface="Apple SD Gothic Neo"/>
+                <a:cs typeface="Apple SD Gothic Neo"/>
+              </a:defRPr>
+            </a:pPr>
+            <a:r>
+              <a:rPr sz="1725" b="0">
+                <a:solidFill>
+                  <a:srgbClr val="5F6B77"/>
+                </a:solidFill>
+                <a:latin typeface="Apple SD Gothic Neo"/>
+                <a:ea typeface="Apple SD Gothic Neo"/>
+                <a:cs typeface="Apple SD Gothic Neo"/>
+              </a:rPr>
+              <a:t>결과 본문과 허용된 참조 구별</a:t>
+            </a:r>
+          </a:p>
+        </p:txBody>
+      </p:sp>
+      <p:sp>
+        <p:nvSpPr>
+          <p:cNvPr id="61" name="dp45-background / n47 / text 1">
+            <a:extLst xmlns:a="http://schemas.openxmlformats.org/drawingml/2006/main">
+              <a:ext uri="{FF2B5EF4-FFF2-40B4-BE49-F238E27FC236}">
+                <a16:creationId xmlns:a16="http://schemas.microsoft.com/office/drawing/2014/main" id="{97ACFF72-C4BD-42E7-BA14-103B7A383500}"/>
               </a:ext>
             </a:extLst>
           </p:cNvPr>
@@ -17679,17 +18071,17 @@
                 <a:ea typeface="Apple SD Gothic Neo"/>
                 <a:cs typeface="Apple SD Gothic Neo"/>
               </a:rPr>
-              <a:t>반복 조회와 유지 비용</a:t>
-            </a:r>
-          </a:p>
-        </p:txBody>
-      </p:sp>
-      <p:sp>
-        <p:nvSpPr>
-          <p:cNvPr id="55" name="dp45-background / n46 / text 1">
-            <a:extLst xmlns:a="http://schemas.openxmlformats.org/drawingml/2006/main">
-              <a:ext uri="{FF2B5EF4-FFF2-40B4-BE49-F238E27FC236}">
-                <a16:creationId xmlns:a16="http://schemas.microsoft.com/office/drawing/2014/main" id="{2AE414BA-2479-4FB3-B28E-C2D1733CBA59}"/>
+              <a:t>제공 방식과 비용</a:t>
+            </a:r>
+          </a:p>
+        </p:txBody>
+      </p:sp>
+      <p:sp>
+        <p:nvSpPr>
+          <p:cNvPr id="62" name="dp45-background / n48 / text 1">
+            <a:extLst xmlns:a="http://schemas.openxmlformats.org/drawingml/2006/main">
+              <a:ext uri="{FF2B5EF4-FFF2-40B4-BE49-F238E27FC236}">
+                <a16:creationId xmlns:a16="http://schemas.microsoft.com/office/drawing/2014/main" id="{30B96681-73F7-47CE-BD40-FEAABF4636DA}"/>
               </a:ext>
             </a:extLst>
           </p:cNvPr>
@@ -17737,7 +18129,65 @@
                 <a:ea typeface="Apple SD Gothic Neo"/>
                 <a:cs typeface="Apple SD Gothic Neo"/>
               </a:rPr>
-              <a:t>Context 생산과 조회 및 갱신 비용의 균형</a:t>
+              <a:t>단순 실행 맥락이나 index/cache로 충분한지</a:t>
+            </a:r>
+          </a:p>
+        </p:txBody>
+      </p:sp>
+      <p:sp>
+        <p:nvSpPr>
+          <p:cNvPr id="63" name="dp45-background / n48 / text 2">
+            <a:extLst xmlns:a="http://schemas.openxmlformats.org/drawingml/2006/main">
+              <a:ext uri="{FF2B5EF4-FFF2-40B4-BE49-F238E27FC236}">
+                <a16:creationId xmlns:a16="http://schemas.microsoft.com/office/drawing/2014/main" id="{1B9859B3-523D-4BF0-8E9F-FF76D1524FB3}"/>
+              </a:ext>
+            </a:extLst>
+          </p:cNvPr>
+          <p:cNvSpPr>
+            <a:spLocks xmlns:a="http://schemas.openxmlformats.org/drawingml/2006/main" noGrp="1"/>
+          </p:cNvSpPr>
+          <p:nvPr/>
+        </p:nvSpPr>
+        <p:spPr>
+          <a:xfrm xmlns:a="http://schemas.openxmlformats.org/drawingml/2006/main">
+            <a:off x="12001500" y="7143750"/>
+            <a:ext cx="5676900" cy="317659"/>
+          </a:xfrm>
+          <a:prstGeom xmlns:a="http://schemas.openxmlformats.org/drawingml/2006/main" prst="rect">
+            <a:avLst/>
+          </a:prstGeom>
+          <a:noFill xmlns:a="http://schemas.openxmlformats.org/drawingml/2006/main"/>
+          <a:ln xmlns:a="http://schemas.openxmlformats.org/drawingml/2006/main" w="0">
+            <a:noFill/>
+            <a:prstDash val="solid"/>
+          </a:ln>
+        </p:spPr>
+        <p:txBody>
+          <a:bodyPr xmlns:a="http://schemas.openxmlformats.org/drawingml/2006/main" wrap="none" lIns="0" tIns="0" rIns="0" bIns="0" anchor="t">
+            <a:noAutofit/>
+          </a:bodyPr>
+          <a:lstStyle xmlns:a="http://schemas.openxmlformats.org/drawingml/2006/main"/>
+          <a:p xmlns:a="http://schemas.openxmlformats.org/drawingml/2006/main">
+            <a:pPr algn="l">
+              <a:defRPr sz="1725" b="0">
+                <a:solidFill>
+                  <a:srgbClr val="5F6B77"/>
+                </a:solidFill>
+                <a:latin typeface="Apple SD Gothic Neo"/>
+                <a:ea typeface="Apple SD Gothic Neo"/>
+                <a:cs typeface="Apple SD Gothic Neo"/>
+              </a:defRPr>
+            </a:pPr>
+            <a:r>
+              <a:rPr sz="1725" b="0">
+                <a:solidFill>
+                  <a:srgbClr val="5F6B77"/>
+                </a:solidFill>
+                <a:latin typeface="Apple SD Gothic Neo"/>
+                <a:ea typeface="Apple SD Gothic Neo"/>
+                <a:cs typeface="Apple SD Gothic Neo"/>
+              </a:rPr>
+              <a:t>공통 파생 관계의 유지가 필요한지 검토</a:t>
             </a:r>
           </a:p>
         </p:txBody>
@@ -17745,7 +18195,7 @@
     </p:spTree>
     <p:extLst>
       <p:ext uri="{BB962C8B-B14F-4D97-AF65-F5344CB8AC3E}">
-        <p14:creationId xmlns:p14="http://schemas.microsoft.com/office/powerpoint/2010/main" val="225662086"/>
+        <p14:creationId xmlns:p14="http://schemas.microsoft.com/office/powerpoint/2010/main" val="285684146"/>
       </p:ext>
     </p:extLst>
   </p:cSld>

</xml_diff>

<commit_message>
docs: focus DP41 presentation on readable interpretation flows
</commit_message>
<xml_diff>
--- a/docs/presentations_files/dp-background/VIA-DP-background-41-45.pptx
+++ b/docs/presentations_files/dp-background/VIA-DP-background-41-45.pptx
@@ -446,7 +446,7 @@
           <a:lstStyle xmlns:a="http://schemas.openxmlformats.org/drawingml/2006/main"/>
           <a:p xmlns:a="http://schemas.openxmlformats.org/drawingml/2006/main">
             <a:r>
-              <a:t>04-41. 기능 정확성을 위한 VIA Request 해석 설계</a:t>
+              <a:t>04-41. VIA 사용자 요청 이해 설계</a:t>
             </a:r>
           </a:p>
           <a:p xmlns:a="http://schemas.openxmlformats.org/drawingml/2006/main">
@@ -462,6 +462,11 @@
           <a:p xmlns:a="http://schemas.openxmlformats.org/drawingml/2006/main">
             <a:r>
               <a:t>공통 문제와 설계 고려 사항의 배경이며 특정 설계안의 선택을 뜻하지 않는다.</a:t>
+            </a:r>
+          </a:p>
+          <a:p xmlns:a="http://schemas.openxmlformats.org/drawingml/2006/main">
+            <a:r>
+              <a:t>Task1은 예산 보고서, Task2는 실적 보고서 업무다. 선택한 표와 이전 업무 두 후보가 있으므로 아까라는 표현만으로 정답을 미리 결정하지 않는다. 보고서 수정 결과를 메일 초안에 사용하고 메일은 보내지 않는 조건을 유지한다. 보고서 수정과 메일 작성은 외부 업무 수행 Agent가 맡는다.</a:t>
             </a:r>
           </a:p>
         </p:txBody>
@@ -1427,10 +1432,10 @@
       </p:grpSpPr>
       <p:sp>
         <p:nvSpPr>
-          <p:cNvPr id="62" name="dp41-background / n1">
-            <a:extLst xmlns:a="http://schemas.openxmlformats.org/drawingml/2006/main">
-              <a:ext uri="{FF2B5EF4-FFF2-40B4-BE49-F238E27FC236}">
-                <a16:creationId xmlns:a16="http://schemas.microsoft.com/office/drawing/2014/main" id="{992F14F4-33BD-4940-80E2-A814BA57A18B}"/>
+          <p:cNvPr id="63" name="dp41-background / n1">
+            <a:extLst xmlns:a="http://schemas.openxmlformats.org/drawingml/2006/main">
+              <a:ext uri="{FF2B5EF4-FFF2-40B4-BE49-F238E27FC236}">
+                <a16:creationId xmlns:a16="http://schemas.microsoft.com/office/drawing/2014/main" id="{C0B6FD8D-8C7E-4DC0-8BE3-05A70BE45E29}"/>
               </a:ext>
             </a:extLst>
           </p:cNvPr>
@@ -1461,7 +1466,7 @@
           <p:cNvPr id="2" name="dp41-background / n2 / text 1">
             <a:extLst xmlns:a="http://schemas.openxmlformats.org/drawingml/2006/main">
               <a:ext uri="{FF2B5EF4-FFF2-40B4-BE49-F238E27FC236}">
-                <a16:creationId xmlns:a16="http://schemas.microsoft.com/office/drawing/2014/main" id="{158263B5-1115-459C-970C-96DDFE191DB8}"/>
+                <a16:creationId xmlns:a16="http://schemas.microsoft.com/office/drawing/2014/main" id="{C868520A-840C-4869-9A5E-07035B82D6A4}"/>
               </a:ext>
             </a:extLst>
           </p:cNvPr>
@@ -1519,7 +1524,7 @@
           <p:cNvPr id="3" name="dp41-background / n3 / text 1">
             <a:extLst xmlns:a="http://schemas.openxmlformats.org/drawingml/2006/main">
               <a:ext uri="{FF2B5EF4-FFF2-40B4-BE49-F238E27FC236}">
-                <a16:creationId xmlns:a16="http://schemas.microsoft.com/office/drawing/2014/main" id="{1738B9D5-586B-46C9-92D9-6C7BBB23B9CA}"/>
+                <a16:creationId xmlns:a16="http://schemas.microsoft.com/office/drawing/2014/main" id="{30D3C83F-9EA0-42B5-909C-18E0AEE045BC}"/>
               </a:ext>
             </a:extLst>
           </p:cNvPr>
@@ -1577,7 +1582,7 @@
           <p:cNvPr id="4" name="dp41-background / n4 / text 1">
             <a:extLst xmlns:a="http://schemas.openxmlformats.org/drawingml/2006/main">
               <a:ext uri="{FF2B5EF4-FFF2-40B4-BE49-F238E27FC236}">
-                <a16:creationId xmlns:a16="http://schemas.microsoft.com/office/drawing/2014/main" id="{E5460B27-7D74-4A63-9492-1ED524DE52E0}"/>
+                <a16:creationId xmlns:a16="http://schemas.microsoft.com/office/drawing/2014/main" id="{A32C5DAC-3902-468B-8FA8-7DF82DCBD06B}"/>
               </a:ext>
             </a:extLst>
           </p:cNvPr>
@@ -1625,7 +1630,7 @@
                 <a:ea typeface="Apple SD Gothic Neo"/>
                 <a:cs typeface="Apple SD Gothic Neo"/>
               </a:rPr>
-              <a:t>04-41. 기능 정확성을 위한 VIA Request 해석 설계</a:t>
+              <a:t>04-41. VIA 사용자 요청 이해 설계</a:t>
             </a:r>
           </a:p>
         </p:txBody>
@@ -1635,7 +1640,7 @@
           <p:cNvPr id="5" name="dp41-background / n5 / path">
             <a:extLst xmlns:a="http://schemas.openxmlformats.org/drawingml/2006/main">
               <a:ext uri="{FF2B5EF4-FFF2-40B4-BE49-F238E27FC236}">
-                <a16:creationId xmlns:a16="http://schemas.microsoft.com/office/drawing/2014/main" id="{1312E4C1-077B-4890-9D04-63AD9C906844}"/>
+                <a16:creationId xmlns:a16="http://schemas.microsoft.com/office/drawing/2014/main" id="{91B0259E-C1F4-43CD-8D2E-206DD2A2A310}"/>
               </a:ext>
             </a:extLst>
           </p:cNvPr>
@@ -1675,7 +1680,7 @@
           <p:cNvPr id="6" name="dp41-background / n6">
             <a:extLst xmlns:a="http://schemas.openxmlformats.org/drawingml/2006/main">
               <a:ext uri="{FF2B5EF4-FFF2-40B4-BE49-F238E27FC236}">
-                <a16:creationId xmlns:a16="http://schemas.microsoft.com/office/drawing/2014/main" id="{67D945C6-873B-49D9-B486-801DF0878659}"/>
+                <a16:creationId xmlns:a16="http://schemas.microsoft.com/office/drawing/2014/main" id="{86B754AA-FC32-4CB6-BC07-C92EC3CE6D78}"/>
               </a:ext>
             </a:extLst>
           </p:cNvPr>
@@ -1706,7 +1711,7 @@
           <p:cNvPr id="7" name="dp41-background / n7 / text 1">
             <a:extLst xmlns:a="http://schemas.openxmlformats.org/drawingml/2006/main">
               <a:ext uri="{FF2B5EF4-FFF2-40B4-BE49-F238E27FC236}">
-                <a16:creationId xmlns:a16="http://schemas.microsoft.com/office/drawing/2014/main" id="{DDB416F8-FE35-4F18-8F6F-1DD93BBC20BC}"/>
+                <a16:creationId xmlns:a16="http://schemas.microsoft.com/office/drawing/2014/main" id="{5EE2CB34-2899-4443-8F16-C817FD8DFB77}"/>
               </a:ext>
             </a:extLst>
           </p:cNvPr>
@@ -1764,7 +1769,7 @@
           <p:cNvPr id="8" name="dp41-background / n8 / path">
             <a:extLst xmlns:a="http://schemas.openxmlformats.org/drawingml/2006/main">
               <a:ext uri="{FF2B5EF4-FFF2-40B4-BE49-F238E27FC236}">
-                <a16:creationId xmlns:a16="http://schemas.microsoft.com/office/drawing/2014/main" id="{355370DC-AD4F-4990-BD68-A43E7C10A6ED}"/>
+                <a16:creationId xmlns:a16="http://schemas.microsoft.com/office/drawing/2014/main" id="{05EBD508-56FF-447B-AB51-C825C15CFD63}"/>
               </a:ext>
             </a:extLst>
           </p:cNvPr>
@@ -1804,7 +1809,7 @@
           <p:cNvPr id="9" name="dp41-background / n9 / text 1">
             <a:extLst xmlns:a="http://schemas.openxmlformats.org/drawingml/2006/main">
               <a:ext uri="{FF2B5EF4-FFF2-40B4-BE49-F238E27FC236}">
-                <a16:creationId xmlns:a16="http://schemas.microsoft.com/office/drawing/2014/main" id="{3D07FD33-EBF3-4F86-820E-69F571097560}"/>
+                <a16:creationId xmlns:a16="http://schemas.microsoft.com/office/drawing/2014/main" id="{0D5A8950-0EFB-4A87-A871-6612FF61108C}"/>
               </a:ext>
             </a:extLst>
           </p:cNvPr>
@@ -1862,7 +1867,7 @@
           <p:cNvPr id="10" name="dp41-background / n10 / path">
             <a:extLst xmlns:a="http://schemas.openxmlformats.org/drawingml/2006/main">
               <a:ext uri="{FF2B5EF4-FFF2-40B4-BE49-F238E27FC236}">
-                <a16:creationId xmlns:a16="http://schemas.microsoft.com/office/drawing/2014/main" id="{BE2A50A9-4B5F-4CF5-A3CA-92FC3B3C97C0}"/>
+                <a16:creationId xmlns:a16="http://schemas.microsoft.com/office/drawing/2014/main" id="{6426EDC2-F850-4641-9CBE-5ED87B8E3F6E}"/>
               </a:ext>
             </a:extLst>
           </p:cNvPr>
@@ -1902,7 +1907,7 @@
           <p:cNvPr id="11" name="dp41-background / n11 / text 1">
             <a:extLst xmlns:a="http://schemas.openxmlformats.org/drawingml/2006/main">
               <a:ext uri="{FF2B5EF4-FFF2-40B4-BE49-F238E27FC236}">
-                <a16:creationId xmlns:a16="http://schemas.microsoft.com/office/drawing/2014/main" id="{847C7A0B-A484-41A4-9D5F-AE61D086D43E}"/>
+                <a16:creationId xmlns:a16="http://schemas.microsoft.com/office/drawing/2014/main" id="{7E4B0802-00EF-4FAF-84CC-254020C9EE7C}"/>
               </a:ext>
             </a:extLst>
           </p:cNvPr>
@@ -1960,7 +1965,7 @@
           <p:cNvPr id="12" name="dp41-background / n12 / text 1">
             <a:extLst xmlns:a="http://schemas.openxmlformats.org/drawingml/2006/main">
               <a:ext uri="{FF2B5EF4-FFF2-40B4-BE49-F238E27FC236}">
-                <a16:creationId xmlns:a16="http://schemas.microsoft.com/office/drawing/2014/main" id="{77342004-0190-49E9-8DA0-7D3248BA34AE}"/>
+                <a16:creationId xmlns:a16="http://schemas.microsoft.com/office/drawing/2014/main" id="{944E17CF-26CA-4C04-A213-EC191507A862}"/>
               </a:ext>
             </a:extLst>
           </p:cNvPr>
@@ -2018,7 +2023,7 @@
           <p:cNvPr id="13" name="dp41-background / n13 / text 1">
             <a:extLst xmlns:a="http://schemas.openxmlformats.org/drawingml/2006/main">
               <a:ext uri="{FF2B5EF4-FFF2-40B4-BE49-F238E27FC236}">
-                <a16:creationId xmlns:a16="http://schemas.microsoft.com/office/drawing/2014/main" id="{A13D7F84-125B-4A5C-A02C-D0411915B0FA}"/>
+                <a16:creationId xmlns:a16="http://schemas.microsoft.com/office/drawing/2014/main" id="{65E9DAEF-4039-40BE-B2FC-92B485276EAF}"/>
               </a:ext>
             </a:extLst>
           </p:cNvPr>
@@ -2076,7 +2081,7 @@
           <p:cNvPr id="14" name="dp41-background / n14 / text 1">
             <a:extLst xmlns:a="http://schemas.openxmlformats.org/drawingml/2006/main">
               <a:ext uri="{FF2B5EF4-FFF2-40B4-BE49-F238E27FC236}">
-                <a16:creationId xmlns:a16="http://schemas.microsoft.com/office/drawing/2014/main" id="{38EC2AEC-1386-41B7-8901-C138BD769EFE}"/>
+                <a16:creationId xmlns:a16="http://schemas.microsoft.com/office/drawing/2014/main" id="{E389A183-9EC7-4C8C-9BF3-96DFB2919BAB}"/>
               </a:ext>
             </a:extLst>
           </p:cNvPr>
@@ -2134,65 +2139,123 @@
           <p:cNvPr id="15" name="dp41-background / n15 / text 1">
             <a:extLst xmlns:a="http://schemas.openxmlformats.org/drawingml/2006/main">
               <a:ext uri="{FF2B5EF4-FFF2-40B4-BE49-F238E27FC236}">
-                <a16:creationId xmlns:a16="http://schemas.microsoft.com/office/drawing/2014/main" id="{8E45DDD3-6A5A-496F-8E2A-E8CD3FFCB95A}"/>
-              </a:ext>
-            </a:extLst>
-          </p:cNvPr>
-          <p:cNvSpPr>
-            <a:spLocks xmlns:a="http://schemas.openxmlformats.org/drawingml/2006/main" noGrp="1"/>
-          </p:cNvSpPr>
-          <p:nvPr/>
-        </p:nvSpPr>
-        <p:spPr>
-          <a:xfrm xmlns:a="http://schemas.openxmlformats.org/drawingml/2006/main">
-            <a:off x="609600" y="2524125"/>
-            <a:ext cx="10572750" cy="400526"/>
-          </a:xfrm>
-          <a:prstGeom xmlns:a="http://schemas.openxmlformats.org/drawingml/2006/main" prst="rect">
-            <a:avLst/>
-          </a:prstGeom>
-          <a:noFill xmlns:a="http://schemas.openxmlformats.org/drawingml/2006/main"/>
-          <a:ln xmlns:a="http://schemas.openxmlformats.org/drawingml/2006/main" w="0">
-            <a:noFill/>
-            <a:prstDash val="solid"/>
-          </a:ln>
-        </p:spPr>
-        <p:txBody>
-          <a:bodyPr xmlns:a="http://schemas.openxmlformats.org/drawingml/2006/main" wrap="none" lIns="0" tIns="0" rIns="0" bIns="0" anchor="t">
-            <a:noAutofit/>
-          </a:bodyPr>
-          <a:lstStyle xmlns:a="http://schemas.openxmlformats.org/drawingml/2006/main"/>
-          <a:p xmlns:a="http://schemas.openxmlformats.org/drawingml/2006/main">
-            <a:pPr algn="l">
-              <a:defRPr sz="2175" b="1">
-                <a:solidFill>
-                  <a:srgbClr val="18232E"/>
-                </a:solidFill>
-                <a:latin typeface="Apple SD Gothic Neo"/>
-                <a:ea typeface="Apple SD Gothic Neo"/>
-                <a:cs typeface="Apple SD Gothic Neo"/>
-              </a:defRPr>
-            </a:pPr>
-            <a:r>
-              <a:rPr sz="2175" b="1">
-                <a:solidFill>
-                  <a:srgbClr val="18232E"/>
-                </a:solidFill>
-                <a:latin typeface="Apple SD Gothic Neo"/>
-                <a:ea typeface="Apple SD Gothic Neo"/>
-                <a:cs typeface="Apple SD Gothic Neo"/>
-              </a:rPr>
-              <a:t>“이 표를 아까 보고서에 넣고, 메일은 초안만 만들어.”</a:t>
-            </a:r>
-          </a:p>
-        </p:txBody>
-      </p:sp>
-      <p:sp>
-        <p:nvSpPr>
-          <p:cNvPr id="16" name="dp41-background / n16">
-            <a:extLst xmlns:a="http://schemas.openxmlformats.org/drawingml/2006/main">
-              <a:ext uri="{FF2B5EF4-FFF2-40B4-BE49-F238E27FC236}">
-                <a16:creationId xmlns:a16="http://schemas.microsoft.com/office/drawing/2014/main" id="{125F5457-5B9A-44DB-BD7F-B35C38E03EB1}"/>
+                <a16:creationId xmlns:a16="http://schemas.microsoft.com/office/drawing/2014/main" id="{FB6E1A85-AD78-479A-BB2D-F247447ED4F3}"/>
+              </a:ext>
+            </a:extLst>
+          </p:cNvPr>
+          <p:cNvSpPr>
+            <a:spLocks xmlns:a="http://schemas.openxmlformats.org/drawingml/2006/main" noGrp="1"/>
+          </p:cNvSpPr>
+          <p:nvPr/>
+        </p:nvSpPr>
+        <p:spPr>
+          <a:xfrm xmlns:a="http://schemas.openxmlformats.org/drawingml/2006/main">
+            <a:off x="609600" y="2428875"/>
+            <a:ext cx="10572750" cy="386715"/>
+          </a:xfrm>
+          <a:prstGeom xmlns:a="http://schemas.openxmlformats.org/drawingml/2006/main" prst="rect">
+            <a:avLst/>
+          </a:prstGeom>
+          <a:noFill xmlns:a="http://schemas.openxmlformats.org/drawingml/2006/main"/>
+          <a:ln xmlns:a="http://schemas.openxmlformats.org/drawingml/2006/main" w="0">
+            <a:noFill/>
+            <a:prstDash val="solid"/>
+          </a:ln>
+        </p:spPr>
+        <p:txBody>
+          <a:bodyPr xmlns:a="http://schemas.openxmlformats.org/drawingml/2006/main" wrap="none" lIns="0" tIns="0" rIns="0" bIns="0" anchor="t">
+            <a:noAutofit/>
+          </a:bodyPr>
+          <a:lstStyle xmlns:a="http://schemas.openxmlformats.org/drawingml/2006/main"/>
+          <a:p xmlns:a="http://schemas.openxmlformats.org/drawingml/2006/main">
+            <a:pPr algn="l">
+              <a:defRPr sz="2100" b="1">
+                <a:solidFill>
+                  <a:srgbClr val="18232E"/>
+                </a:solidFill>
+                <a:latin typeface="Apple SD Gothic Neo"/>
+                <a:ea typeface="Apple SD Gothic Neo"/>
+                <a:cs typeface="Apple SD Gothic Neo"/>
+              </a:defRPr>
+            </a:pPr>
+            <a:r>
+              <a:rPr sz="2100" b="1">
+                <a:solidFill>
+                  <a:srgbClr val="18232E"/>
+                </a:solidFill>
+                <a:latin typeface="Apple SD Gothic Neo"/>
+                <a:ea typeface="Apple SD Gothic Neo"/>
+                <a:cs typeface="Apple SD Gothic Neo"/>
+              </a:rPr>
+              <a:t>“이 표를 아까 보고서에 넣고, 메일은 보내지 말고</a:t>
+            </a:r>
+          </a:p>
+        </p:txBody>
+      </p:sp>
+      <p:sp>
+        <p:nvSpPr>
+          <p:cNvPr id="16" name="dp41-background / n15 / text 2">
+            <a:extLst xmlns:a="http://schemas.openxmlformats.org/drawingml/2006/main">
+              <a:ext uri="{FF2B5EF4-FFF2-40B4-BE49-F238E27FC236}">
+                <a16:creationId xmlns:a16="http://schemas.microsoft.com/office/drawing/2014/main" id="{1EAFBE82-808C-41AC-B64A-16C778842B79}"/>
+              </a:ext>
+            </a:extLst>
+          </p:cNvPr>
+          <p:cNvSpPr>
+            <a:spLocks xmlns:a="http://schemas.openxmlformats.org/drawingml/2006/main" noGrp="1"/>
+          </p:cNvSpPr>
+          <p:nvPr/>
+        </p:nvSpPr>
+        <p:spPr>
+          <a:xfrm xmlns:a="http://schemas.openxmlformats.org/drawingml/2006/main">
+            <a:off x="609600" y="2762250"/>
+            <a:ext cx="10572750" cy="386715"/>
+          </a:xfrm>
+          <a:prstGeom xmlns:a="http://schemas.openxmlformats.org/drawingml/2006/main" prst="rect">
+            <a:avLst/>
+          </a:prstGeom>
+          <a:noFill xmlns:a="http://schemas.openxmlformats.org/drawingml/2006/main"/>
+          <a:ln xmlns:a="http://schemas.openxmlformats.org/drawingml/2006/main" w="0">
+            <a:noFill/>
+            <a:prstDash val="solid"/>
+          </a:ln>
+        </p:spPr>
+        <p:txBody>
+          <a:bodyPr xmlns:a="http://schemas.openxmlformats.org/drawingml/2006/main" wrap="none" lIns="0" tIns="0" rIns="0" bIns="0" anchor="t">
+            <a:noAutofit/>
+          </a:bodyPr>
+          <a:lstStyle xmlns:a="http://schemas.openxmlformats.org/drawingml/2006/main"/>
+          <a:p xmlns:a="http://schemas.openxmlformats.org/drawingml/2006/main">
+            <a:pPr algn="l">
+              <a:defRPr sz="2100" b="1">
+                <a:solidFill>
+                  <a:srgbClr val="18232E"/>
+                </a:solidFill>
+                <a:latin typeface="Apple SD Gothic Neo"/>
+                <a:ea typeface="Apple SD Gothic Neo"/>
+                <a:cs typeface="Apple SD Gothic Neo"/>
+              </a:defRPr>
+            </a:pPr>
+            <a:r>
+              <a:rPr sz="2100" b="1">
+                <a:solidFill>
+                  <a:srgbClr val="18232E"/>
+                </a:solidFill>
+                <a:latin typeface="Apple SD Gothic Neo"/>
+                <a:ea typeface="Apple SD Gothic Neo"/>
+                <a:cs typeface="Apple SD Gothic Neo"/>
+              </a:rPr>
+              <a:t>결과를 바탕으로 초안만 만들어.”</a:t>
+            </a:r>
+          </a:p>
+        </p:txBody>
+      </p:sp>
+      <p:sp>
+        <p:nvSpPr>
+          <p:cNvPr id="17" name="dp41-background / n16">
+            <a:extLst xmlns:a="http://schemas.openxmlformats.org/drawingml/2006/main">
+              <a:ext uri="{FF2B5EF4-FFF2-40B4-BE49-F238E27FC236}">
+                <a16:creationId xmlns:a16="http://schemas.microsoft.com/office/drawing/2014/main" id="{B42C7AB7-F3BA-4EE7-8B85-21A585C7512D}"/>
               </a:ext>
             </a:extLst>
           </p:cNvPr>
@@ -2222,10 +2285,10 @@
       </p:sp>
       <p:sp>
         <p:nvSpPr>
-          <p:cNvPr id="17" name="dp41-background / n17 / text 1">
-            <a:extLst xmlns:a="http://schemas.openxmlformats.org/drawingml/2006/main">
-              <a:ext uri="{FF2B5EF4-FFF2-40B4-BE49-F238E27FC236}">
-                <a16:creationId xmlns:a16="http://schemas.microsoft.com/office/drawing/2014/main" id="{B15336EC-136B-4077-B566-4FA6DAC7BA49}"/>
+          <p:cNvPr id="18" name="dp41-background / n17 / text 1">
+            <a:extLst xmlns:a="http://schemas.openxmlformats.org/drawingml/2006/main">
+              <a:ext uri="{FF2B5EF4-FFF2-40B4-BE49-F238E27FC236}">
+                <a16:creationId xmlns:a16="http://schemas.microsoft.com/office/drawing/2014/main" id="{E01A3C19-8CBF-44D8-80A0-0C9C68D0410A}"/>
               </a:ext>
             </a:extLst>
           </p:cNvPr>
@@ -2280,10 +2343,10 @@
       </p:sp>
       <p:sp>
         <p:nvSpPr>
-          <p:cNvPr id="18" name="dp41-background / n18">
-            <a:extLst xmlns:a="http://schemas.openxmlformats.org/drawingml/2006/main">
-              <a:ext uri="{FF2B5EF4-FFF2-40B4-BE49-F238E27FC236}">
-                <a16:creationId xmlns:a16="http://schemas.microsoft.com/office/drawing/2014/main" id="{94AD00F5-33E5-4895-A500-0682D098DDDD}"/>
+          <p:cNvPr id="19" name="dp41-background / n18">
+            <a:extLst xmlns:a="http://schemas.openxmlformats.org/drawingml/2006/main">
+              <a:ext uri="{FF2B5EF4-FFF2-40B4-BE49-F238E27FC236}">
+                <a16:creationId xmlns:a16="http://schemas.microsoft.com/office/drawing/2014/main" id="{D2F89509-00C3-401B-A637-2CD534EBBFF2}"/>
               </a:ext>
             </a:extLst>
           </p:cNvPr>
@@ -2313,10 +2376,10 @@
       </p:sp>
       <p:sp>
         <p:nvSpPr>
-          <p:cNvPr id="19" name="dp41-background / n19 / text 1">
-            <a:extLst xmlns:a="http://schemas.openxmlformats.org/drawingml/2006/main">
-              <a:ext uri="{FF2B5EF4-FFF2-40B4-BE49-F238E27FC236}">
-                <a16:creationId xmlns:a16="http://schemas.microsoft.com/office/drawing/2014/main" id="{FD3AA8CE-DDAD-408C-9208-045E68CE8532}"/>
+          <p:cNvPr id="20" name="dp41-background / n19 / text 1">
+            <a:extLst xmlns:a="http://schemas.openxmlformats.org/drawingml/2006/main">
+              <a:ext uri="{FF2B5EF4-FFF2-40B4-BE49-F238E27FC236}">
+                <a16:creationId xmlns:a16="http://schemas.microsoft.com/office/drawing/2014/main" id="{74D372FF-8301-4862-B9DA-E35B9F951573}"/>
               </a:ext>
             </a:extLst>
           </p:cNvPr>
@@ -2371,10 +2434,10 @@
       </p:sp>
       <p:sp>
         <p:nvSpPr>
-          <p:cNvPr id="20" name="dp41-background / n20 / text 1">
-            <a:extLst xmlns:a="http://schemas.openxmlformats.org/drawingml/2006/main">
-              <a:ext uri="{FF2B5EF4-FFF2-40B4-BE49-F238E27FC236}">
-                <a16:creationId xmlns:a16="http://schemas.microsoft.com/office/drawing/2014/main" id="{54BC4F3C-80DA-4A12-A679-5CAAA9BC2D15}"/>
+          <p:cNvPr id="21" name="dp41-background / n20 / text 1">
+            <a:extLst xmlns:a="http://schemas.openxmlformats.org/drawingml/2006/main">
+              <a:ext uri="{FF2B5EF4-FFF2-40B4-BE49-F238E27FC236}">
+                <a16:creationId xmlns:a16="http://schemas.microsoft.com/office/drawing/2014/main" id="{71F108C1-B759-4052-A9C2-E260CCA8A3AA}"/>
               </a:ext>
             </a:extLst>
           </p:cNvPr>
@@ -2429,10 +2492,10 @@
       </p:sp>
       <p:sp>
         <p:nvSpPr>
-          <p:cNvPr id="21" name="dp41-background / n21">
-            <a:extLst xmlns:a="http://schemas.openxmlformats.org/drawingml/2006/main">
-              <a:ext uri="{FF2B5EF4-FFF2-40B4-BE49-F238E27FC236}">
-                <a16:creationId xmlns:a16="http://schemas.microsoft.com/office/drawing/2014/main" id="{7AADF1B4-9BBB-41F4-83C5-AAF02B2082D5}"/>
+          <p:cNvPr id="22" name="dp41-background / n21">
+            <a:extLst xmlns:a="http://schemas.openxmlformats.org/drawingml/2006/main">
+              <a:ext uri="{FF2B5EF4-FFF2-40B4-BE49-F238E27FC236}">
+                <a16:creationId xmlns:a16="http://schemas.microsoft.com/office/drawing/2014/main" id="{6E7A91AD-67F2-4ACC-AEF4-9C8DEC7C4B6D}"/>
               </a:ext>
             </a:extLst>
           </p:cNvPr>
@@ -2462,10 +2525,10 @@
       </p:sp>
       <p:sp>
         <p:nvSpPr>
-          <p:cNvPr id="22" name="dp41-background / n22">
-            <a:extLst xmlns:a="http://schemas.openxmlformats.org/drawingml/2006/main">
-              <a:ext uri="{FF2B5EF4-FFF2-40B4-BE49-F238E27FC236}">
-                <a16:creationId xmlns:a16="http://schemas.microsoft.com/office/drawing/2014/main" id="{670DC6B8-CD03-46F5-ACB0-9E73FA586B60}"/>
+          <p:cNvPr id="23" name="dp41-background / n22">
+            <a:extLst xmlns:a="http://schemas.openxmlformats.org/drawingml/2006/main">
+              <a:ext uri="{FF2B5EF4-FFF2-40B4-BE49-F238E27FC236}">
+                <a16:creationId xmlns:a16="http://schemas.microsoft.com/office/drawing/2014/main" id="{3A5BEC2D-A182-45D9-BE07-C7FBA9539C7E}"/>
               </a:ext>
             </a:extLst>
           </p:cNvPr>
@@ -2493,10 +2556,10 @@
       </p:sp>
       <p:sp>
         <p:nvSpPr>
-          <p:cNvPr id="23" name="dp41-background / n23 / path">
-            <a:extLst xmlns:a="http://schemas.openxmlformats.org/drawingml/2006/main">
-              <a:ext uri="{FF2B5EF4-FFF2-40B4-BE49-F238E27FC236}">
-                <a16:creationId xmlns:a16="http://schemas.microsoft.com/office/drawing/2014/main" id="{1421923C-ACAC-4C04-B093-921F43F62BF0}"/>
+          <p:cNvPr id="24" name="dp41-background / n23 / path">
+            <a:extLst xmlns:a="http://schemas.openxmlformats.org/drawingml/2006/main">
+              <a:ext uri="{FF2B5EF4-FFF2-40B4-BE49-F238E27FC236}">
+                <a16:creationId xmlns:a16="http://schemas.microsoft.com/office/drawing/2014/main" id="{F2C8FB0A-54A1-4543-8E8C-8C3713896CED}"/>
               </a:ext>
             </a:extLst>
           </p:cNvPr>
@@ -2533,10 +2596,10 @@
       </p:sp>
       <p:sp>
         <p:nvSpPr>
-          <p:cNvPr id="24" name="dp41-background / n24 / path">
-            <a:extLst xmlns:a="http://schemas.openxmlformats.org/drawingml/2006/main">
-              <a:ext uri="{FF2B5EF4-FFF2-40B4-BE49-F238E27FC236}">
-                <a16:creationId xmlns:a16="http://schemas.microsoft.com/office/drawing/2014/main" id="{5B5F2278-D4B9-4FA2-A5D4-48B36BA7C391}"/>
+          <p:cNvPr id="25" name="dp41-background / n24 / path">
+            <a:extLst xmlns:a="http://schemas.openxmlformats.org/drawingml/2006/main">
+              <a:ext uri="{FF2B5EF4-FFF2-40B4-BE49-F238E27FC236}">
+                <a16:creationId xmlns:a16="http://schemas.microsoft.com/office/drawing/2014/main" id="{52B57D5B-AC3C-47C3-BFAF-B1DAE9178776}"/>
               </a:ext>
             </a:extLst>
           </p:cNvPr>
@@ -2573,10 +2636,10 @@
       </p:sp>
       <p:sp>
         <p:nvSpPr>
-          <p:cNvPr id="25" name="dp41-background / n25 / path">
-            <a:extLst xmlns:a="http://schemas.openxmlformats.org/drawingml/2006/main">
-              <a:ext uri="{FF2B5EF4-FFF2-40B4-BE49-F238E27FC236}">
-                <a16:creationId xmlns:a16="http://schemas.microsoft.com/office/drawing/2014/main" id="{48501672-C42E-4CBE-8DAE-51D7DFFAB18F}"/>
+          <p:cNvPr id="26" name="dp41-background / n25 / path">
+            <a:extLst xmlns:a="http://schemas.openxmlformats.org/drawingml/2006/main">
+              <a:ext uri="{FF2B5EF4-FFF2-40B4-BE49-F238E27FC236}">
+                <a16:creationId xmlns:a16="http://schemas.microsoft.com/office/drawing/2014/main" id="{DE47FC49-9BF7-4C81-87F9-930D84D5DEBE}"/>
               </a:ext>
             </a:extLst>
           </p:cNvPr>
@@ -2613,10 +2676,10 @@
       </p:sp>
       <p:sp>
         <p:nvSpPr>
-          <p:cNvPr id="26" name="dp41-background / n26 / path">
-            <a:extLst xmlns:a="http://schemas.openxmlformats.org/drawingml/2006/main">
-              <a:ext uri="{FF2B5EF4-FFF2-40B4-BE49-F238E27FC236}">
-                <a16:creationId xmlns:a16="http://schemas.microsoft.com/office/drawing/2014/main" id="{D01C2541-109F-440D-9617-AE10287B1968}"/>
+          <p:cNvPr id="27" name="dp41-background / n26 / path">
+            <a:extLst xmlns:a="http://schemas.openxmlformats.org/drawingml/2006/main">
+              <a:ext uri="{FF2B5EF4-FFF2-40B4-BE49-F238E27FC236}">
+                <a16:creationId xmlns:a16="http://schemas.microsoft.com/office/drawing/2014/main" id="{49BFD5AB-F04E-406A-8104-1B2F99267404}"/>
               </a:ext>
             </a:extLst>
           </p:cNvPr>
@@ -2653,10 +2716,10 @@
       </p:sp>
       <p:sp>
         <p:nvSpPr>
-          <p:cNvPr id="27" name="dp41-background / n27 / path">
-            <a:extLst xmlns:a="http://schemas.openxmlformats.org/drawingml/2006/main">
-              <a:ext uri="{FF2B5EF4-FFF2-40B4-BE49-F238E27FC236}">
-                <a16:creationId xmlns:a16="http://schemas.microsoft.com/office/drawing/2014/main" id="{C3A68F18-BDD8-437C-9F0A-F253E3473FF6}"/>
+          <p:cNvPr id="28" name="dp41-background / n27 / path">
+            <a:extLst xmlns:a="http://schemas.openxmlformats.org/drawingml/2006/main">
+              <a:ext uri="{FF2B5EF4-FFF2-40B4-BE49-F238E27FC236}">
+                <a16:creationId xmlns:a16="http://schemas.microsoft.com/office/drawing/2014/main" id="{B6323BED-63E9-42AE-9786-93E7EF7DDE7B}"/>
               </a:ext>
             </a:extLst>
           </p:cNvPr>
@@ -2693,10 +2756,10 @@
       </p:sp>
       <p:sp>
         <p:nvSpPr>
-          <p:cNvPr id="28" name="dp41-background / n28 / path">
-            <a:extLst xmlns:a="http://schemas.openxmlformats.org/drawingml/2006/main">
-              <a:ext uri="{FF2B5EF4-FFF2-40B4-BE49-F238E27FC236}">
-                <a16:creationId xmlns:a16="http://schemas.microsoft.com/office/drawing/2014/main" id="{19CF6C95-713C-453D-9159-9C59B6D3C4FA}"/>
+          <p:cNvPr id="29" name="dp41-background / n28 / path">
+            <a:extLst xmlns:a="http://schemas.openxmlformats.org/drawingml/2006/main">
+              <a:ext uri="{FF2B5EF4-FFF2-40B4-BE49-F238E27FC236}">
+                <a16:creationId xmlns:a16="http://schemas.microsoft.com/office/drawing/2014/main" id="{ADDE65A5-4852-4DE6-989A-4FE4B8AB318A}"/>
               </a:ext>
             </a:extLst>
           </p:cNvPr>
@@ -2733,10 +2796,10 @@
       </p:sp>
       <p:sp>
         <p:nvSpPr>
-          <p:cNvPr id="29" name="dp41-background / n29 / text 1">
-            <a:extLst xmlns:a="http://schemas.openxmlformats.org/drawingml/2006/main">
-              <a:ext uri="{FF2B5EF4-FFF2-40B4-BE49-F238E27FC236}">
-                <a16:creationId xmlns:a16="http://schemas.microsoft.com/office/drawing/2014/main" id="{659B8C28-19F7-4670-BD5C-E960FF2B9A0F}"/>
+          <p:cNvPr id="30" name="dp41-background / n29 / text 1">
+            <a:extLst xmlns:a="http://schemas.openxmlformats.org/drawingml/2006/main">
+              <a:ext uri="{FF2B5EF4-FFF2-40B4-BE49-F238E27FC236}">
+                <a16:creationId xmlns:a16="http://schemas.microsoft.com/office/drawing/2014/main" id="{F9A115CE-B126-43A6-8ED4-8E92D4E8D60C}"/>
               </a:ext>
             </a:extLst>
           </p:cNvPr>
@@ -2791,10 +2854,10 @@
       </p:sp>
       <p:sp>
         <p:nvSpPr>
-          <p:cNvPr id="30" name="dp41-background / n30 / text 1">
-            <a:extLst xmlns:a="http://schemas.openxmlformats.org/drawingml/2006/main">
-              <a:ext uri="{FF2B5EF4-FFF2-40B4-BE49-F238E27FC236}">
-                <a16:creationId xmlns:a16="http://schemas.microsoft.com/office/drawing/2014/main" id="{3B9F54D8-11BC-40CE-9AB0-AC120F530893}"/>
+          <p:cNvPr id="31" name="dp41-background / n30 / text 1">
+            <a:extLst xmlns:a="http://schemas.openxmlformats.org/drawingml/2006/main">
+              <a:ext uri="{FF2B5EF4-FFF2-40B4-BE49-F238E27FC236}">
+                <a16:creationId xmlns:a16="http://schemas.microsoft.com/office/drawing/2014/main" id="{69D9391B-A4A2-47AE-95FF-4B71F1D462BF}"/>
               </a:ext>
             </a:extLst>
           </p:cNvPr>
@@ -2849,10 +2912,10 @@
       </p:sp>
       <p:sp>
         <p:nvSpPr>
-          <p:cNvPr id="31" name="dp41-background / n31 / text 1">
-            <a:extLst xmlns:a="http://schemas.openxmlformats.org/drawingml/2006/main">
-              <a:ext uri="{FF2B5EF4-FFF2-40B4-BE49-F238E27FC236}">
-                <a16:creationId xmlns:a16="http://schemas.microsoft.com/office/drawing/2014/main" id="{A7F5AF9B-F05D-4761-8C81-462E9F6A47F6}"/>
+          <p:cNvPr id="32" name="dp41-background / n31 / text 1">
+            <a:extLst xmlns:a="http://schemas.openxmlformats.org/drawingml/2006/main">
+              <a:ext uri="{FF2B5EF4-FFF2-40B4-BE49-F238E27FC236}">
+                <a16:creationId xmlns:a16="http://schemas.microsoft.com/office/drawing/2014/main" id="{8A435378-2B3C-4183-9466-A5E88F4F6104}"/>
               </a:ext>
             </a:extLst>
           </p:cNvPr>
@@ -2907,10 +2970,10 @@
       </p:sp>
       <p:sp>
         <p:nvSpPr>
-          <p:cNvPr id="32" name="dp41-background / n32 / text 1">
-            <a:extLst xmlns:a="http://schemas.openxmlformats.org/drawingml/2006/main">
-              <a:ext uri="{FF2B5EF4-FFF2-40B4-BE49-F238E27FC236}">
-                <a16:creationId xmlns:a16="http://schemas.microsoft.com/office/drawing/2014/main" id="{0A436AF8-B7AB-49E2-8142-4A701E23E3EB}"/>
+          <p:cNvPr id="33" name="dp41-background / n32 / text 1">
+            <a:extLst xmlns:a="http://schemas.openxmlformats.org/drawingml/2006/main">
+              <a:ext uri="{FF2B5EF4-FFF2-40B4-BE49-F238E27FC236}">
+                <a16:creationId xmlns:a16="http://schemas.microsoft.com/office/drawing/2014/main" id="{26EA4F21-7D8B-44C7-A9CB-A2722F97DAD9}"/>
               </a:ext>
             </a:extLst>
           </p:cNvPr>
@@ -2965,10 +3028,10 @@
       </p:sp>
       <p:sp>
         <p:nvSpPr>
-          <p:cNvPr id="33" name="dp41-background / n33 / text 1">
-            <a:extLst xmlns:a="http://schemas.openxmlformats.org/drawingml/2006/main">
-              <a:ext uri="{FF2B5EF4-FFF2-40B4-BE49-F238E27FC236}">
-                <a16:creationId xmlns:a16="http://schemas.microsoft.com/office/drawing/2014/main" id="{3D53D860-B030-4C1C-B598-D94B08DA12D1}"/>
+          <p:cNvPr id="34" name="dp41-background / n33 / text 1">
+            <a:extLst xmlns:a="http://schemas.openxmlformats.org/drawingml/2006/main">
+              <a:ext uri="{FF2B5EF4-FFF2-40B4-BE49-F238E27FC236}">
+                <a16:creationId xmlns:a16="http://schemas.microsoft.com/office/drawing/2014/main" id="{6BA9F2E7-F0CB-4CF3-BA91-3A86731D25C4}"/>
               </a:ext>
             </a:extLst>
           </p:cNvPr>
@@ -3023,10 +3086,10 @@
       </p:sp>
       <p:sp>
         <p:nvSpPr>
-          <p:cNvPr id="34" name="dp41-background / n34 / text 1">
-            <a:extLst xmlns:a="http://schemas.openxmlformats.org/drawingml/2006/main">
-              <a:ext uri="{FF2B5EF4-FFF2-40B4-BE49-F238E27FC236}">
-                <a16:creationId xmlns:a16="http://schemas.microsoft.com/office/drawing/2014/main" id="{DCDCB8AB-64CF-4561-BBC6-2BBA2C2C91F4}"/>
+          <p:cNvPr id="35" name="dp41-background / n34 / text 1">
+            <a:extLst xmlns:a="http://schemas.openxmlformats.org/drawingml/2006/main">
+              <a:ext uri="{FF2B5EF4-FFF2-40B4-BE49-F238E27FC236}">
+                <a16:creationId xmlns:a16="http://schemas.microsoft.com/office/drawing/2014/main" id="{F0872575-B993-4AC2-B7D5-C0964CB9A28A}"/>
               </a:ext>
             </a:extLst>
           </p:cNvPr>
@@ -3081,10 +3144,10 @@
       </p:sp>
       <p:sp>
         <p:nvSpPr>
-          <p:cNvPr id="35" name="dp41-background / n35 / text 1">
-            <a:extLst xmlns:a="http://schemas.openxmlformats.org/drawingml/2006/main">
-              <a:ext uri="{FF2B5EF4-FFF2-40B4-BE49-F238E27FC236}">
-                <a16:creationId xmlns:a16="http://schemas.microsoft.com/office/drawing/2014/main" id="{6B4B23A7-428B-43C2-96C4-8036A524D5E8}"/>
+          <p:cNvPr id="36" name="dp41-background / n35 / text 1">
+            <a:extLst xmlns:a="http://schemas.openxmlformats.org/drawingml/2006/main">
+              <a:ext uri="{FF2B5EF4-FFF2-40B4-BE49-F238E27FC236}">
+                <a16:creationId xmlns:a16="http://schemas.microsoft.com/office/drawing/2014/main" id="{93DD65B0-4B87-4DDE-990B-5BF40A5CB141}"/>
               </a:ext>
             </a:extLst>
           </p:cNvPr>
@@ -3139,10 +3202,10 @@
       </p:sp>
       <p:sp>
         <p:nvSpPr>
-          <p:cNvPr id="36" name="dp41-background / n36 / text 1">
-            <a:extLst xmlns:a="http://schemas.openxmlformats.org/drawingml/2006/main">
-              <a:ext uri="{FF2B5EF4-FFF2-40B4-BE49-F238E27FC236}">
-                <a16:creationId xmlns:a16="http://schemas.microsoft.com/office/drawing/2014/main" id="{55F8D591-D0CA-4746-BB4C-204B84832A7C}"/>
+          <p:cNvPr id="37" name="dp41-background / n36 / text 1">
+            <a:extLst xmlns:a="http://schemas.openxmlformats.org/drawingml/2006/main">
+              <a:ext uri="{FF2B5EF4-FFF2-40B4-BE49-F238E27FC236}">
+                <a16:creationId xmlns:a16="http://schemas.microsoft.com/office/drawing/2014/main" id="{07C80A85-22AB-4A40-97A0-D5F2C88F5CCA}"/>
               </a:ext>
             </a:extLst>
           </p:cNvPr>
@@ -3197,10 +3260,10 @@
       </p:sp>
       <p:sp>
         <p:nvSpPr>
-          <p:cNvPr id="37" name="dp41-background / n37 / text 1">
-            <a:extLst xmlns:a="http://schemas.openxmlformats.org/drawingml/2006/main">
-              <a:ext uri="{FF2B5EF4-FFF2-40B4-BE49-F238E27FC236}">
-                <a16:creationId xmlns:a16="http://schemas.microsoft.com/office/drawing/2014/main" id="{33B32471-0CAA-45C4-AED1-4DA8DF228849}"/>
+          <p:cNvPr id="38" name="dp41-background / n37 / text 1">
+            <a:extLst xmlns:a="http://schemas.openxmlformats.org/drawingml/2006/main">
+              <a:ext uri="{FF2B5EF4-FFF2-40B4-BE49-F238E27FC236}">
+                <a16:creationId xmlns:a16="http://schemas.microsoft.com/office/drawing/2014/main" id="{4C44B76F-7CAF-464E-8ED1-1206C5B15357}"/>
               </a:ext>
             </a:extLst>
           </p:cNvPr>
@@ -3255,10 +3318,10 @@
       </p:sp>
       <p:sp>
         <p:nvSpPr>
-          <p:cNvPr id="38" name="dp41-background / n38 / text 1">
-            <a:extLst xmlns:a="http://schemas.openxmlformats.org/drawingml/2006/main">
-              <a:ext uri="{FF2B5EF4-FFF2-40B4-BE49-F238E27FC236}">
-                <a16:creationId xmlns:a16="http://schemas.microsoft.com/office/drawing/2014/main" id="{C83B7C72-598B-4D1B-9E41-4C9677D9A714}"/>
+          <p:cNvPr id="39" name="dp41-background / n38 / text 1">
+            <a:extLst xmlns:a="http://schemas.openxmlformats.org/drawingml/2006/main">
+              <a:ext uri="{FF2B5EF4-FFF2-40B4-BE49-F238E27FC236}">
+                <a16:creationId xmlns:a16="http://schemas.microsoft.com/office/drawing/2014/main" id="{26FD870B-5986-4E68-9FDF-DE553F9CEF71}"/>
               </a:ext>
             </a:extLst>
           </p:cNvPr>
@@ -3313,10 +3376,10 @@
       </p:sp>
       <p:sp>
         <p:nvSpPr>
-          <p:cNvPr id="39" name="dp41-background / n39 / text 1">
-            <a:extLst xmlns:a="http://schemas.openxmlformats.org/drawingml/2006/main">
-              <a:ext uri="{FF2B5EF4-FFF2-40B4-BE49-F238E27FC236}">
-                <a16:creationId xmlns:a16="http://schemas.microsoft.com/office/drawing/2014/main" id="{944C9EC3-0E84-4721-A3C9-D51BF2E9BEF4}"/>
+          <p:cNvPr id="40" name="dp41-background / n39 / text 1">
+            <a:extLst xmlns:a="http://schemas.openxmlformats.org/drawingml/2006/main">
+              <a:ext uri="{FF2B5EF4-FFF2-40B4-BE49-F238E27FC236}">
+                <a16:creationId xmlns:a16="http://schemas.microsoft.com/office/drawing/2014/main" id="{45878D15-EE8D-450F-9DFB-9DF605EB10D5}"/>
               </a:ext>
             </a:extLst>
           </p:cNvPr>
@@ -3371,10 +3434,10 @@
       </p:sp>
       <p:sp>
         <p:nvSpPr>
-          <p:cNvPr id="40" name="dp41-background / n40 / text 1">
-            <a:extLst xmlns:a="http://schemas.openxmlformats.org/drawingml/2006/main">
-              <a:ext uri="{FF2B5EF4-FFF2-40B4-BE49-F238E27FC236}">
-                <a16:creationId xmlns:a16="http://schemas.microsoft.com/office/drawing/2014/main" id="{FB90B84E-FA7F-4019-9D03-A14D0CF7AD53}"/>
+          <p:cNvPr id="41" name="dp41-background / n40 / text 1">
+            <a:extLst xmlns:a="http://schemas.openxmlformats.org/drawingml/2006/main">
+              <a:ext uri="{FF2B5EF4-FFF2-40B4-BE49-F238E27FC236}">
+                <a16:creationId xmlns:a16="http://schemas.microsoft.com/office/drawing/2014/main" id="{F02835F3-A719-43C1-9111-61BCFE38DE1D}"/>
               </a:ext>
             </a:extLst>
           </p:cNvPr>
@@ -3429,10 +3492,10 @@
       </p:sp>
       <p:sp>
         <p:nvSpPr>
-          <p:cNvPr id="41" name="dp41-background / n41 / text 1">
-            <a:extLst xmlns:a="http://schemas.openxmlformats.org/drawingml/2006/main">
-              <a:ext uri="{FF2B5EF4-FFF2-40B4-BE49-F238E27FC236}">
-                <a16:creationId xmlns:a16="http://schemas.microsoft.com/office/drawing/2014/main" id="{A71FC22F-1569-4621-B16B-FAE8DE03D295}"/>
+          <p:cNvPr id="42" name="dp41-background / n41 / text 1">
+            <a:extLst xmlns:a="http://schemas.openxmlformats.org/drawingml/2006/main">
+              <a:ext uri="{FF2B5EF4-FFF2-40B4-BE49-F238E27FC236}">
+                <a16:creationId xmlns:a16="http://schemas.microsoft.com/office/drawing/2014/main" id="{B06FCB23-BCA0-4CA3-9403-735FE0D46927}"/>
               </a:ext>
             </a:extLst>
           </p:cNvPr>
@@ -3487,10 +3550,10 @@
       </p:sp>
       <p:sp>
         <p:nvSpPr>
-          <p:cNvPr id="42" name="dp41-background / n42 / text 1">
-            <a:extLst xmlns:a="http://schemas.openxmlformats.org/drawingml/2006/main">
-              <a:ext uri="{FF2B5EF4-FFF2-40B4-BE49-F238E27FC236}">
-                <a16:creationId xmlns:a16="http://schemas.microsoft.com/office/drawing/2014/main" id="{2DACCE3D-1E6B-4EBE-B881-A07E2D05EB97}"/>
+          <p:cNvPr id="43" name="dp41-background / n42 / text 1">
+            <a:extLst xmlns:a="http://schemas.openxmlformats.org/drawingml/2006/main">
+              <a:ext uri="{FF2B5EF4-FFF2-40B4-BE49-F238E27FC236}">
+                <a16:creationId xmlns:a16="http://schemas.microsoft.com/office/drawing/2014/main" id="{28A4D0C6-955F-49EC-8DE5-6B190A8A9B06}"/>
               </a:ext>
             </a:extLst>
           </p:cNvPr>
@@ -3545,10 +3608,10 @@
       </p:sp>
       <p:sp>
         <p:nvSpPr>
-          <p:cNvPr id="43" name="dp41-background / n43 / text 1">
-            <a:extLst xmlns:a="http://schemas.openxmlformats.org/drawingml/2006/main">
-              <a:ext uri="{FF2B5EF4-FFF2-40B4-BE49-F238E27FC236}">
-                <a16:creationId xmlns:a16="http://schemas.microsoft.com/office/drawing/2014/main" id="{26DF9B6F-2FD8-4E36-A257-622A06B40221}"/>
+          <p:cNvPr id="44" name="dp41-background / n43 / text 1">
+            <a:extLst xmlns:a="http://schemas.openxmlformats.org/drawingml/2006/main">
+              <a:ext uri="{FF2B5EF4-FFF2-40B4-BE49-F238E27FC236}">
+                <a16:creationId xmlns:a16="http://schemas.microsoft.com/office/drawing/2014/main" id="{D56F491F-B35C-47C2-A0EA-722F18960547}"/>
               </a:ext>
             </a:extLst>
           </p:cNvPr>
@@ -3603,10 +3666,10 @@
       </p:sp>
       <p:sp>
         <p:nvSpPr>
-          <p:cNvPr id="44" name="dp41-background / n44 / text 1">
-            <a:extLst xmlns:a="http://schemas.openxmlformats.org/drawingml/2006/main">
-              <a:ext uri="{FF2B5EF4-FFF2-40B4-BE49-F238E27FC236}">
-                <a16:creationId xmlns:a16="http://schemas.microsoft.com/office/drawing/2014/main" id="{A5F8006C-5EC5-4BE1-B282-5446A4D5CB21}"/>
+          <p:cNvPr id="45" name="dp41-background / n44 / text 1">
+            <a:extLst xmlns:a="http://schemas.openxmlformats.org/drawingml/2006/main">
+              <a:ext uri="{FF2B5EF4-FFF2-40B4-BE49-F238E27FC236}">
+                <a16:creationId xmlns:a16="http://schemas.microsoft.com/office/drawing/2014/main" id="{10524030-28E6-4063-9D39-22697226996E}"/>
               </a:ext>
             </a:extLst>
           </p:cNvPr>
@@ -3661,10 +3724,10 @@
       </p:sp>
       <p:sp>
         <p:nvSpPr>
-          <p:cNvPr id="45" name="dp41-background / n45">
-            <a:extLst xmlns:a="http://schemas.openxmlformats.org/drawingml/2006/main">
-              <a:ext uri="{FF2B5EF4-FFF2-40B4-BE49-F238E27FC236}">
-                <a16:creationId xmlns:a16="http://schemas.microsoft.com/office/drawing/2014/main" id="{723C1248-277F-4B4E-B4C1-7B5BC6CD3B6F}"/>
+          <p:cNvPr id="46" name="dp41-background / n45">
+            <a:extLst xmlns:a="http://schemas.openxmlformats.org/drawingml/2006/main">
+              <a:ext uri="{FF2B5EF4-FFF2-40B4-BE49-F238E27FC236}">
+                <a16:creationId xmlns:a16="http://schemas.microsoft.com/office/drawing/2014/main" id="{F4050B84-AD42-417A-94C5-CAF45CE61D42}"/>
               </a:ext>
             </a:extLst>
           </p:cNvPr>
@@ -3694,10 +3757,10 @@
       </p:sp>
       <p:sp>
         <p:nvSpPr>
-          <p:cNvPr id="46" name="dp41-background / n46 / text 1">
-            <a:extLst xmlns:a="http://schemas.openxmlformats.org/drawingml/2006/main">
-              <a:ext uri="{FF2B5EF4-FFF2-40B4-BE49-F238E27FC236}">
-                <a16:creationId xmlns:a16="http://schemas.microsoft.com/office/drawing/2014/main" id="{E41DDA74-83ED-4BEC-A643-7414BB285570}"/>
+          <p:cNvPr id="47" name="dp41-background / n46 / text 1">
+            <a:extLst xmlns:a="http://schemas.openxmlformats.org/drawingml/2006/main">
+              <a:ext uri="{FF2B5EF4-FFF2-40B4-BE49-F238E27FC236}">
+                <a16:creationId xmlns:a16="http://schemas.microsoft.com/office/drawing/2014/main" id="{B7AE0A00-ABBC-415D-9995-3A5F1DF2A001}"/>
               </a:ext>
             </a:extLst>
           </p:cNvPr>
@@ -3745,17 +3808,17 @@
                 <a:ea typeface="Apple SD Gothic Neo"/>
                 <a:cs typeface="Apple SD Gothic Neo"/>
               </a:rPr>
-              <a:t>이전 Request와 Task 후보</a:t>
-            </a:r>
-          </a:p>
-        </p:txBody>
-      </p:sp>
-      <p:sp>
-        <p:nvSpPr>
-          <p:cNvPr id="47" name="dp41-background / n47 / text 1">
-            <a:extLst xmlns:a="http://schemas.openxmlformats.org/drawingml/2006/main">
-              <a:ext uri="{FF2B5EF4-FFF2-40B4-BE49-F238E27FC236}">
-                <a16:creationId xmlns:a16="http://schemas.microsoft.com/office/drawing/2014/main" id="{A8A354BF-FB9D-454B-A5E3-7586D68183C8}"/>
+              <a:t>이전 요청과 업무(Task) 후보</a:t>
+            </a:r>
+          </a:p>
+        </p:txBody>
+      </p:sp>
+      <p:sp>
+        <p:nvSpPr>
+          <p:cNvPr id="48" name="dp41-background / n47 / text 1">
+            <a:extLst xmlns:a="http://schemas.openxmlformats.org/drawingml/2006/main">
+              <a:ext uri="{FF2B5EF4-FFF2-40B4-BE49-F238E27FC236}">
+                <a16:creationId xmlns:a16="http://schemas.microsoft.com/office/drawing/2014/main" id="{91021380-D466-4722-B3EB-79EFA8D9EEC6}"/>
               </a:ext>
             </a:extLst>
           </p:cNvPr>
@@ -3803,17 +3866,17 @@
                 <a:ea typeface="Apple SD Gothic Neo"/>
                 <a:cs typeface="Apple SD Gothic Neo"/>
               </a:rPr>
-              <a:t>예산 보고서 Task</a:t>
-            </a:r>
-          </a:p>
-        </p:txBody>
-      </p:sp>
-      <p:sp>
-        <p:nvSpPr>
-          <p:cNvPr id="48" name="dp41-background / n48 / text 1">
-            <a:extLst xmlns:a="http://schemas.openxmlformats.org/drawingml/2006/main">
-              <a:ext uri="{FF2B5EF4-FFF2-40B4-BE49-F238E27FC236}">
-                <a16:creationId xmlns:a16="http://schemas.microsoft.com/office/drawing/2014/main" id="{830F0025-6622-4EC6-9D60-BF8DEC757D1D}"/>
+              <a:t>Task1: 예산 보고서</a:t>
+            </a:r>
+          </a:p>
+        </p:txBody>
+      </p:sp>
+      <p:sp>
+        <p:nvSpPr>
+          <p:cNvPr id="49" name="dp41-background / n48 / text 1">
+            <a:extLst xmlns:a="http://schemas.openxmlformats.org/drawingml/2006/main">
+              <a:ext uri="{FF2B5EF4-FFF2-40B4-BE49-F238E27FC236}">
+                <a16:creationId xmlns:a16="http://schemas.microsoft.com/office/drawing/2014/main" id="{C85C3C1E-182B-41B2-AFB9-E253653BAB2C}"/>
               </a:ext>
             </a:extLst>
           </p:cNvPr>
@@ -3868,10 +3931,10 @@
       </p:sp>
       <p:sp>
         <p:nvSpPr>
-          <p:cNvPr id="49" name="dp41-background / n49 / path">
-            <a:extLst xmlns:a="http://schemas.openxmlformats.org/drawingml/2006/main">
-              <a:ext uri="{FF2B5EF4-FFF2-40B4-BE49-F238E27FC236}">
-                <a16:creationId xmlns:a16="http://schemas.microsoft.com/office/drawing/2014/main" id="{56BB0B62-57F4-4B51-93D2-2C6D24603B0D}"/>
+          <p:cNvPr id="50" name="dp41-background / n49 / path">
+            <a:extLst xmlns:a="http://schemas.openxmlformats.org/drawingml/2006/main">
+              <a:ext uri="{FF2B5EF4-FFF2-40B4-BE49-F238E27FC236}">
+                <a16:creationId xmlns:a16="http://schemas.microsoft.com/office/drawing/2014/main" id="{46286B00-8A0E-48B1-A25D-F66F5A8034E7}"/>
               </a:ext>
             </a:extLst>
           </p:cNvPr>
@@ -3908,10 +3971,10 @@
       </p:sp>
       <p:sp>
         <p:nvSpPr>
-          <p:cNvPr id="50" name="dp41-background / n50 / text 1">
-            <a:extLst xmlns:a="http://schemas.openxmlformats.org/drawingml/2006/main">
-              <a:ext uri="{FF2B5EF4-FFF2-40B4-BE49-F238E27FC236}">
-                <a16:creationId xmlns:a16="http://schemas.microsoft.com/office/drawing/2014/main" id="{E8B92A38-9F22-4943-906D-229114700C76}"/>
+          <p:cNvPr id="51" name="dp41-background / n50 / text 1">
+            <a:extLst xmlns:a="http://schemas.openxmlformats.org/drawingml/2006/main">
+              <a:ext uri="{FF2B5EF4-FFF2-40B4-BE49-F238E27FC236}">
+                <a16:creationId xmlns:a16="http://schemas.microsoft.com/office/drawing/2014/main" id="{FD9273FF-CBD3-4233-8C5E-2218B53A407B}"/>
               </a:ext>
             </a:extLst>
           </p:cNvPr>
@@ -3959,17 +4022,17 @@
                 <a:ea typeface="Apple SD Gothic Neo"/>
                 <a:cs typeface="Apple SD Gothic Neo"/>
               </a:rPr>
-              <a:t>실적 보고서 Task</a:t>
-            </a:r>
-          </a:p>
-        </p:txBody>
-      </p:sp>
-      <p:sp>
-        <p:nvSpPr>
-          <p:cNvPr id="51" name="dp41-background / n51 / text 1">
-            <a:extLst xmlns:a="http://schemas.openxmlformats.org/drawingml/2006/main">
-              <a:ext uri="{FF2B5EF4-FFF2-40B4-BE49-F238E27FC236}">
-                <a16:creationId xmlns:a16="http://schemas.microsoft.com/office/drawing/2014/main" id="{E0616A0E-434C-4917-9805-D6BE23452643}"/>
+              <a:t>Task2: 실적 보고서</a:t>
+            </a:r>
+          </a:p>
+        </p:txBody>
+      </p:sp>
+      <p:sp>
+        <p:nvSpPr>
+          <p:cNvPr id="52" name="dp41-background / n51 / text 1">
+            <a:extLst xmlns:a="http://schemas.openxmlformats.org/drawingml/2006/main">
+              <a:ext uri="{FF2B5EF4-FFF2-40B4-BE49-F238E27FC236}">
+                <a16:creationId xmlns:a16="http://schemas.microsoft.com/office/drawing/2014/main" id="{16379021-C397-4E92-8DAA-A3038E53E339}"/>
               </a:ext>
             </a:extLst>
           </p:cNvPr>
@@ -4024,10 +4087,10 @@
       </p:sp>
       <p:sp>
         <p:nvSpPr>
-          <p:cNvPr id="52" name="dp41-background / n52 / text 1">
-            <a:extLst xmlns:a="http://schemas.openxmlformats.org/drawingml/2006/main">
-              <a:ext uri="{FF2B5EF4-FFF2-40B4-BE49-F238E27FC236}">
-                <a16:creationId xmlns:a16="http://schemas.microsoft.com/office/drawing/2014/main" id="{54428504-9D81-4A01-917A-9EFB36A31101}"/>
+          <p:cNvPr id="53" name="dp41-background / n52 / text 1">
+            <a:extLst xmlns:a="http://schemas.openxmlformats.org/drawingml/2006/main">
+              <a:ext uri="{FF2B5EF4-FFF2-40B4-BE49-F238E27FC236}">
+                <a16:creationId xmlns:a16="http://schemas.microsoft.com/office/drawing/2014/main" id="{F555DB51-CA54-4F5C-9615-CF545D0434E7}"/>
               </a:ext>
             </a:extLst>
           </p:cNvPr>
@@ -4082,10 +4145,10 @@
       </p:sp>
       <p:sp>
         <p:nvSpPr>
-          <p:cNvPr id="53" name="dp41-background / n53">
-            <a:extLst xmlns:a="http://schemas.openxmlformats.org/drawingml/2006/main">
-              <a:ext uri="{FF2B5EF4-FFF2-40B4-BE49-F238E27FC236}">
-                <a16:creationId xmlns:a16="http://schemas.microsoft.com/office/drawing/2014/main" id="{B88B37CE-A38D-4389-A4C3-CDB379C33CF2}"/>
+          <p:cNvPr id="54" name="dp41-background / n53">
+            <a:extLst xmlns:a="http://schemas.openxmlformats.org/drawingml/2006/main">
+              <a:ext uri="{FF2B5EF4-FFF2-40B4-BE49-F238E27FC236}">
+                <a16:creationId xmlns:a16="http://schemas.microsoft.com/office/drawing/2014/main" id="{430236F9-FE84-46FD-A8C8-F5E69999C54A}"/>
               </a:ext>
             </a:extLst>
           </p:cNvPr>
@@ -4113,10 +4176,10 @@
       </p:sp>
       <p:sp>
         <p:nvSpPr>
-          <p:cNvPr id="54" name="dp41-background / n54 / text 1">
-            <a:extLst xmlns:a="http://schemas.openxmlformats.org/drawingml/2006/main">
-              <a:ext uri="{FF2B5EF4-FFF2-40B4-BE49-F238E27FC236}">
-                <a16:creationId xmlns:a16="http://schemas.microsoft.com/office/drawing/2014/main" id="{A8B4E9A8-15C3-49D3-A443-D0EE9F4CC701}"/>
+          <p:cNvPr id="55" name="dp41-background / n54 / text 1">
+            <a:extLst xmlns:a="http://schemas.openxmlformats.org/drawingml/2006/main">
+              <a:ext uri="{FF2B5EF4-FFF2-40B4-BE49-F238E27FC236}">
+                <a16:creationId xmlns:a16="http://schemas.microsoft.com/office/drawing/2014/main" id="{F151DB0C-AEBB-421F-AC7E-28D81211F510}"/>
               </a:ext>
             </a:extLst>
           </p:cNvPr>
@@ -4128,53 +4191,53 @@
         <p:spPr>
           <a:xfrm xmlns:a="http://schemas.openxmlformats.org/drawingml/2006/main">
             <a:off x="800100" y="7572375"/>
-            <a:ext cx="10172700" cy="372904"/>
-          </a:xfrm>
-          <a:prstGeom xmlns:a="http://schemas.openxmlformats.org/drawingml/2006/main" prst="rect">
-            <a:avLst/>
-          </a:prstGeom>
-          <a:noFill xmlns:a="http://schemas.openxmlformats.org/drawingml/2006/main"/>
-          <a:ln xmlns:a="http://schemas.openxmlformats.org/drawingml/2006/main" w="0">
-            <a:noFill/>
-            <a:prstDash val="solid"/>
-          </a:ln>
-        </p:spPr>
-        <p:txBody>
-          <a:bodyPr xmlns:a="http://schemas.openxmlformats.org/drawingml/2006/main" wrap="none" lIns="0" tIns="0" rIns="0" bIns="0" anchor="t">
-            <a:noAutofit/>
-          </a:bodyPr>
-          <a:lstStyle xmlns:a="http://schemas.openxmlformats.org/drawingml/2006/main"/>
-          <a:p xmlns:a="http://schemas.openxmlformats.org/drawingml/2006/main">
-            <a:pPr algn="l">
-              <a:defRPr sz="2025" b="1">
-                <a:solidFill>
-                  <a:srgbClr val="18232E"/>
-                </a:solidFill>
-                <a:latin typeface="Apple SD Gothic Neo"/>
-                <a:ea typeface="Apple SD Gothic Neo"/>
-                <a:cs typeface="Apple SD Gothic Neo"/>
-              </a:defRPr>
-            </a:pPr>
-            <a:r>
-              <a:rPr sz="2025" b="1">
-                <a:solidFill>
-                  <a:srgbClr val="18232E"/>
-                </a:solidFill>
-                <a:latin typeface="Apple SD Gothic Neo"/>
-                <a:ea typeface="Apple SD Gothic Neo"/>
-                <a:cs typeface="Apple SD Gothic Neo"/>
-              </a:rPr>
-              <a:t>메일 Request의 고정 조건 / 초안 작성, 발송 제외</a:t>
-            </a:r>
-          </a:p>
-        </p:txBody>
-      </p:sp>
-      <p:sp>
-        <p:nvSpPr>
-          <p:cNvPr id="55" name="dp41-background / n55 / text 1">
-            <a:extLst xmlns:a="http://schemas.openxmlformats.org/drawingml/2006/main">
-              <a:ext uri="{FF2B5EF4-FFF2-40B4-BE49-F238E27FC236}">
-                <a16:creationId xmlns:a16="http://schemas.microsoft.com/office/drawing/2014/main" id="{373964DF-7376-4E7D-9E73-483C6F67CEDE}"/>
+            <a:ext cx="10172700" cy="345281"/>
+          </a:xfrm>
+          <a:prstGeom xmlns:a="http://schemas.openxmlformats.org/drawingml/2006/main" prst="rect">
+            <a:avLst/>
+          </a:prstGeom>
+          <a:noFill xmlns:a="http://schemas.openxmlformats.org/drawingml/2006/main"/>
+          <a:ln xmlns:a="http://schemas.openxmlformats.org/drawingml/2006/main" w="0">
+            <a:noFill/>
+            <a:prstDash val="solid"/>
+          </a:ln>
+        </p:spPr>
+        <p:txBody>
+          <a:bodyPr xmlns:a="http://schemas.openxmlformats.org/drawingml/2006/main" wrap="none" lIns="0" tIns="0" rIns="0" bIns="0" anchor="t">
+            <a:noAutofit/>
+          </a:bodyPr>
+          <a:lstStyle xmlns:a="http://schemas.openxmlformats.org/drawingml/2006/main"/>
+          <a:p xmlns:a="http://schemas.openxmlformats.org/drawingml/2006/main">
+            <a:pPr algn="l">
+              <a:defRPr sz="1875" b="1">
+                <a:solidFill>
+                  <a:srgbClr val="18232E"/>
+                </a:solidFill>
+                <a:latin typeface="Apple SD Gothic Neo"/>
+                <a:ea typeface="Apple SD Gothic Neo"/>
+                <a:cs typeface="Apple SD Gothic Neo"/>
+              </a:defRPr>
+            </a:pPr>
+            <a:r>
+              <a:rPr sz="1875" b="1">
+                <a:solidFill>
+                  <a:srgbClr val="18232E"/>
+                </a:solidFill>
+                <a:latin typeface="Apple SD Gothic Neo"/>
+                <a:ea typeface="Apple SD Gothic Neo"/>
+                <a:cs typeface="Apple SD Gothic Neo"/>
+              </a:rPr>
+              <a:t>수정된 보고서 결과로 메일 초안 작성 / 메일 발송 금지</a:t>
+            </a:r>
+          </a:p>
+        </p:txBody>
+      </p:sp>
+      <p:sp>
+        <p:nvSpPr>
+          <p:cNvPr id="56" name="dp41-background / n55 / text 1">
+            <a:extLst xmlns:a="http://schemas.openxmlformats.org/drawingml/2006/main">
+              <a:ext uri="{FF2B5EF4-FFF2-40B4-BE49-F238E27FC236}">
+                <a16:creationId xmlns:a16="http://schemas.microsoft.com/office/drawing/2014/main" id="{EEA3AAD4-CD83-46B0-AD8B-8C7BDB9473FA}"/>
               </a:ext>
             </a:extLst>
           </p:cNvPr>
@@ -4229,10 +4292,10 @@
       </p:sp>
       <p:sp>
         <p:nvSpPr>
-          <p:cNvPr id="56" name="dp41-background / n56 / text 1">
-            <a:extLst xmlns:a="http://schemas.openxmlformats.org/drawingml/2006/main">
-              <a:ext uri="{FF2B5EF4-FFF2-40B4-BE49-F238E27FC236}">
-                <a16:creationId xmlns:a16="http://schemas.microsoft.com/office/drawing/2014/main" id="{36254AC6-4B4C-4667-BFB0-021970F7A84E}"/>
+          <p:cNvPr id="57" name="dp41-background / n56 / text 1">
+            <a:extLst xmlns:a="http://schemas.openxmlformats.org/drawingml/2006/main">
+              <a:ext uri="{FF2B5EF4-FFF2-40B4-BE49-F238E27FC236}">
+                <a16:creationId xmlns:a16="http://schemas.microsoft.com/office/drawing/2014/main" id="{7E97BBCB-DC4C-4657-82B2-CEDA010E9DA1}"/>
               </a:ext>
             </a:extLst>
           </p:cNvPr>
@@ -4280,17 +4343,17 @@
                 <a:ea typeface="Apple SD Gothic Neo"/>
                 <a:cs typeface="Apple SD Gothic Neo"/>
               </a:rPr>
-              <a:t>화면 정보와 Referent 범위 확인</a:t>
-            </a:r>
-          </a:p>
-        </p:txBody>
-      </p:sp>
-      <p:sp>
-        <p:nvSpPr>
-          <p:cNvPr id="57" name="dp41-background / n57 / text 1">
-            <a:extLst xmlns:a="http://schemas.openxmlformats.org/drawingml/2006/main">
-              <a:ext uri="{FF2B5EF4-FFF2-40B4-BE49-F238E27FC236}">
-                <a16:creationId xmlns:a16="http://schemas.microsoft.com/office/drawing/2014/main" id="{0364B3A1-D922-45C7-9CE5-6FBCB3C942C8}"/>
+              <a:t>“이 표”가 가리킨 자료의 범위 확인</a:t>
+            </a:r>
+          </a:p>
+        </p:txBody>
+      </p:sp>
+      <p:sp>
+        <p:nvSpPr>
+          <p:cNvPr id="58" name="dp41-background / n57 / text 1">
+            <a:extLst xmlns:a="http://schemas.openxmlformats.org/drawingml/2006/main">
+              <a:ext uri="{FF2B5EF4-FFF2-40B4-BE49-F238E27FC236}">
+                <a16:creationId xmlns:a16="http://schemas.microsoft.com/office/drawing/2014/main" id="{54216B74-E592-4A8E-85B9-F4B3064370F3}"/>
               </a:ext>
             </a:extLst>
           </p:cNvPr>
@@ -4338,17 +4401,17 @@
                 <a:ea typeface="Apple SD Gothic Neo"/>
                 <a:cs typeface="Apple SD Gothic Neo"/>
               </a:rPr>
-              <a:t>관련 Task의 구분</a:t>
-            </a:r>
-          </a:p>
-        </p:txBody>
-      </p:sp>
-      <p:sp>
-        <p:nvSpPr>
-          <p:cNvPr id="58" name="dp41-background / n58 / text 1">
-            <a:extLst xmlns:a="http://schemas.openxmlformats.org/drawingml/2006/main">
-              <a:ext uri="{FF2B5EF4-FFF2-40B4-BE49-F238E27FC236}">
-                <a16:creationId xmlns:a16="http://schemas.microsoft.com/office/drawing/2014/main" id="{FE8724C2-BC4A-43EA-AFF6-9149A7D4A847}"/>
+              <a:t>관련 업무의 구분</a:t>
+            </a:r>
+          </a:p>
+        </p:txBody>
+      </p:sp>
+      <p:sp>
+        <p:nvSpPr>
+          <p:cNvPr id="59" name="dp41-background / n58 / text 1">
+            <a:extLst xmlns:a="http://schemas.openxmlformats.org/drawingml/2006/main">
+              <a:ext uri="{FF2B5EF4-FFF2-40B4-BE49-F238E27FC236}">
+                <a16:creationId xmlns:a16="http://schemas.microsoft.com/office/drawing/2014/main" id="{55E7CCDC-9FE1-4DAE-95B8-A0E56D6D4F54}"/>
               </a:ext>
             </a:extLst>
           </p:cNvPr>
@@ -4396,17 +4459,17 @@
                 <a:ea typeface="Apple SD Gothic Neo"/>
                 <a:cs typeface="Apple SD Gothic Neo"/>
               </a:rPr>
-              <a:t>이전 Request와 현재 Task 상태 확인</a:t>
-            </a:r>
-          </a:p>
-        </p:txBody>
-      </p:sp>
-      <p:sp>
-        <p:nvSpPr>
-          <p:cNvPr id="59" name="dp41-background / n59 / text 1">
-            <a:extLst xmlns:a="http://schemas.openxmlformats.org/drawingml/2006/main">
-              <a:ext uri="{FF2B5EF4-FFF2-40B4-BE49-F238E27FC236}">
-                <a16:creationId xmlns:a16="http://schemas.microsoft.com/office/drawing/2014/main" id="{5BBDA5DC-DD26-48DA-AD79-FEBEA9E78743}"/>
+              <a:t>이전 요청과 현재 업무 상태 확인</a:t>
+            </a:r>
+          </a:p>
+        </p:txBody>
+      </p:sp>
+      <p:sp>
+        <p:nvSpPr>
+          <p:cNvPr id="60" name="dp41-background / n59 / text 1">
+            <a:extLst xmlns:a="http://schemas.openxmlformats.org/drawingml/2006/main">
+              <a:ext uri="{FF2B5EF4-FFF2-40B4-BE49-F238E27FC236}">
+                <a16:creationId xmlns:a16="http://schemas.microsoft.com/office/drawing/2014/main" id="{E54546FA-0846-44A1-8FE9-ED72F14A99BC}"/>
               </a:ext>
             </a:extLst>
           </p:cNvPr>
@@ -4461,10 +4524,10 @@
       </p:sp>
       <p:sp>
         <p:nvSpPr>
-          <p:cNvPr id="60" name="dp41-background / n60 / text 1">
-            <a:extLst xmlns:a="http://schemas.openxmlformats.org/drawingml/2006/main">
-              <a:ext uri="{FF2B5EF4-FFF2-40B4-BE49-F238E27FC236}">
-                <a16:creationId xmlns:a16="http://schemas.microsoft.com/office/drawing/2014/main" id="{A3510A11-B3F8-4E94-AA2E-F1C2D9317CC5}"/>
+          <p:cNvPr id="61" name="dp41-background / n60 / text 1">
+            <a:extLst xmlns:a="http://schemas.openxmlformats.org/drawingml/2006/main">
+              <a:ext uri="{FF2B5EF4-FFF2-40B4-BE49-F238E27FC236}">
+                <a16:creationId xmlns:a16="http://schemas.microsoft.com/office/drawing/2014/main" id="{0E3E607B-2951-40CF-976E-FF6099817920}"/>
               </a:ext>
             </a:extLst>
           </p:cNvPr>
@@ -4512,17 +4575,17 @@
                 <a:ea typeface="Apple SD Gothic Neo"/>
                 <a:cs typeface="Apple SD Gothic Neo"/>
               </a:rPr>
-              <a:t>미확정 Task의 Clarification과</a:t>
-            </a:r>
-          </a:p>
-        </p:txBody>
-      </p:sp>
-      <p:sp>
-        <p:nvSpPr>
-          <p:cNvPr id="61" name="dp41-background / n60 / text 2">
-            <a:extLst xmlns:a="http://schemas.openxmlformats.org/drawingml/2006/main">
-              <a:ext uri="{FF2B5EF4-FFF2-40B4-BE49-F238E27FC236}">
-                <a16:creationId xmlns:a16="http://schemas.microsoft.com/office/drawing/2014/main" id="{4AC4A90C-66A7-4322-A70D-8AB754CEF955}"/>
+              <a:t>어느 보고서인지 확인 질문</a:t>
+            </a:r>
+          </a:p>
+        </p:txBody>
+      </p:sp>
+      <p:sp>
+        <p:nvSpPr>
+          <p:cNvPr id="62" name="dp41-background / n60 / text 2">
+            <a:extLst xmlns:a="http://schemas.openxmlformats.org/drawingml/2006/main">
+              <a:ext uri="{FF2B5EF4-FFF2-40B4-BE49-F238E27FC236}">
+                <a16:creationId xmlns:a16="http://schemas.microsoft.com/office/drawing/2014/main" id="{92A6E46A-00BB-4A3A-9F3F-51CDA2CE6F98}"/>
               </a:ext>
             </a:extLst>
           </p:cNvPr>
@@ -4570,7 +4633,7 @@
                 <a:ea typeface="Apple SD Gothic Neo"/>
                 <a:cs typeface="Apple SD Gothic Neo"/>
               </a:rPr>
-              <a:t>초안 조건의 보존</a:t>
+              <a:t>초안 작성과 발송 금지 조건 유지</a:t>
             </a:r>
           </a:p>
         </p:txBody>
@@ -4578,7 +4641,7 @@
     </p:spTree>
     <p:extLst>
       <p:ext uri="{BB962C8B-B14F-4D97-AF65-F5344CB8AC3E}">
-        <p14:creationId xmlns:p14="http://schemas.microsoft.com/office/powerpoint/2010/main" val="1364431658"/>
+        <p14:creationId xmlns:p14="http://schemas.microsoft.com/office/powerpoint/2010/main" val="1439734656"/>
       </p:ext>
     </p:extLst>
   </p:cSld>

</xml_diff>